<commit_message>
feat: add MCP demo config and update docs
</commit_message>
<xml_diff>
--- a/AI_Getting_Started_with_AI_Tools.pptx
+++ b/AI_Getting_Started_with_AI_Tools.pptx
@@ -4,6 +4,9 @@
   <p:sldMasterIdLst>
     <p:sldMasterId id="2147483648" r:id="rId1"/>
   </p:sldMasterIdLst>
+  <p:notesMasterIdLst>
+    <p:notesMasterId r:id="rId17"/>
+  </p:notesMasterIdLst>
   <p:sldIdLst>
     <p:sldId id="256" r:id="rId2"/>
     <p:sldId id="257" r:id="rId3"/>
@@ -21,10 +24,7 @@
     <p:sldId id="269" r:id="rId15"/>
     <p:sldId id="270" r:id="rId16"/>
   </p:sldIdLst>
-  <p:notesMasterIdLst>
-    <p:notesMasterId r:id="rId17"/>
-  </p:notesMasterIdLst>
-  <p:sldSz cx="9144000" cy="5143500"/>
+  <p:sldSz cx="9144000" cy="5143500" type="screen16x9"/>
   <p:notesSz cx="5143500" cy="9144000"/>
   <p:defaultTextStyle>
     <a:lvl1pPr marL="0" algn="l" defTabSz="914400" rtl="0" eaLnBrk="1" latinLnBrk="0" hangingPunct="1">
@@ -118,6 +118,11 @@
       </a:defRPr>
     </a:lvl9pPr>
   </p:defaultTextStyle>
+  <p:extLst>
+    <p:ext uri="{EFAFB233-063F-42B5-8137-9DF3F51BA10A}">
+      <p15:sldGuideLst xmlns:p15="http://schemas.microsoft.com/office/powerpoint/2012/main"/>
+    </p:ext>
+  </p:extLst>
 </p:presentation>
 </file>
 
@@ -143,234 +148,10 @@
           <a:chExt cx="0" cy="0"/>
         </a:xfrm>
       </p:grpSpPr>
-      <p:sp>
-        <p:nvSpPr>
-          <p:cNvPr id="2" name="Header Placeholder 1"/>
-          <p:cNvSpPr>
-            <a:spLocks noGrp="1"/>
-          </p:cNvSpPr>
-          <p:nvPr>
-            <p:ph type="hdr" sz="quarter"/>
-          </p:nvPr>
-        </p:nvSpPr>
-        <p:spPr>
-          <a:xfrm>
-            <a:off x="0" y="0"/>
-            <a:ext cx="2971800" cy="458788"/>
-          </a:xfrm>
-          <a:prstGeom prst="rect">
-            <a:avLst/>
-          </a:prstGeom>
-        </p:spPr>
-        <p:txBody>
-          <a:bodyPr vert="horz" lIns="91440" tIns="45720" rIns="91440" bIns="45720" rtlCol="0"/>
-          <a:lstStyle>
-            <a:lvl1pPr algn="l">
-              <a:defRPr sz="1200"/>
-            </a:lvl1pPr>
-          </a:lstStyle>
-          <a:p>
-            <a:endParaRPr lang="en-US"/>
-          </a:p>
-        </p:txBody>
-      </p:sp>
-      <p:sp>
-        <p:nvSpPr>
-          <p:cNvPr id="3" name="Date Placeholder 2"/>
-          <p:cNvSpPr>
-            <a:spLocks noGrp="1"/>
-          </p:cNvSpPr>
-          <p:nvPr>
-            <p:ph type="dt" idx="1"/>
-          </p:nvPr>
-        </p:nvSpPr>
-        <p:spPr>
-          <a:xfrm>
-            <a:off x="3884613" y="0"/>
-            <a:ext cx="2971800" cy="458788"/>
-          </a:xfrm>
-          <a:prstGeom prst="rect">
-            <a:avLst/>
-          </a:prstGeom>
-        </p:spPr>
-        <p:txBody>
-          <a:bodyPr vert="horz" lIns="91440" tIns="45720" rIns="91440" bIns="45720" rtlCol="0"/>
-          <a:lstStyle>
-            <a:lvl1pPr algn="r">
-              <a:defRPr sz="1200"/>
-            </a:lvl1pPr>
-          </a:lstStyle>
-          <a:p>
-            <a:fld id="{5282F153-3F37-0F45-9E97-73ACFA13230C}" type="datetimeFigureOut">
-              <a:rPr lang="en-US"/>
-              <a:t>7/23/19</a:t>
-            </a:fld>
-            <a:endParaRPr lang="en-US"/>
-          </a:p>
-        </p:txBody>
-      </p:sp>
-      <p:sp>
-        <p:nvSpPr>
-          <p:cNvPr id="4" name="Slide Image Placeholder 3"/>
-          <p:cNvSpPr>
-            <a:spLocks noGrp="1" noRot="1" noChangeAspect="1"/>
-          </p:cNvSpPr>
-          <p:nvPr>
-            <p:ph type="sldImg" idx="2"/>
-          </p:nvPr>
-        </p:nvSpPr>
-        <p:spPr>
-          <a:xfrm>
-            <a:off x="685800" y="1143000"/>
-            <a:ext cx="5486400" cy="3086100"/>
-          </a:xfrm>
-          <a:prstGeom prst="rect">
-            <a:avLst/>
-          </a:prstGeom>
-          <a:noFill/>
-          <a:ln w="12700">
-            <a:solidFill>
-              <a:prstClr val="black"/>
-            </a:solidFill>
-          </a:ln>
-        </p:spPr>
-        <p:txBody>
-          <a:bodyPr vert="horz" lIns="91440" tIns="45720" rIns="91440" bIns="45720" rtlCol="0" anchor="ctr"/>
-          <a:lstStyle/>
-          <a:p>
-            <a:endParaRPr lang="en-US"/>
-          </a:p>
-        </p:txBody>
-      </p:sp>
-      <p:sp>
-        <p:nvSpPr>
-          <p:cNvPr id="5" name="Notes Placeholder 4"/>
-          <p:cNvSpPr>
-            <a:spLocks noGrp="1"/>
-          </p:cNvSpPr>
-          <p:nvPr>
-            <p:ph type="body" sz="quarter" idx="3"/>
-          </p:nvPr>
-        </p:nvSpPr>
-        <p:spPr>
-          <a:xfrm>
-            <a:off x="685800" y="4400550"/>
-            <a:ext cx="5486400" cy="3600450"/>
-          </a:xfrm>
-          <a:prstGeom prst="rect">
-            <a:avLst/>
-          </a:prstGeom>
-        </p:spPr>
-        <p:txBody>
-          <a:bodyPr vert="horz" lIns="91440" tIns="45720" rIns="91440" bIns="45720" rtlCol="0"/>
-          <a:lstStyle/>
-          <a:p>
-            <a:pPr lvl="0"/>
-            <a:r>
-              <a:rPr lang="en-US"/>
-              <a:t>Click to edit Master text styles</a:t>
-            </a:r>
-          </a:p>
-          <a:p>
-            <a:pPr lvl="1"/>
-            <a:r>
-              <a:rPr lang="en-US"/>
-              <a:t>Second level</a:t>
-            </a:r>
-          </a:p>
-          <a:p>
-            <a:pPr lvl="2"/>
-            <a:r>
-              <a:rPr lang="en-US"/>
-              <a:t>Third level</a:t>
-            </a:r>
-          </a:p>
-          <a:p>
-            <a:pPr lvl="3"/>
-            <a:r>
-              <a:rPr lang="en-US"/>
-              <a:t>Fourth level</a:t>
-            </a:r>
-          </a:p>
-          <a:p>
-            <a:pPr lvl="4"/>
-            <a:r>
-              <a:rPr lang="en-US"/>
-              <a:t>Fifth level</a:t>
-            </a:r>
-          </a:p>
-        </p:txBody>
-      </p:sp>
-      <p:sp>
-        <p:nvSpPr>
-          <p:cNvPr id="6" name="Footer Placeholder 5"/>
-          <p:cNvSpPr>
-            <a:spLocks noGrp="1"/>
-          </p:cNvSpPr>
-          <p:nvPr>
-            <p:ph type="ftr" sz="quarter" idx="4"/>
-          </p:nvPr>
-        </p:nvSpPr>
-        <p:spPr>
-          <a:xfrm>
-            <a:off x="0" y="8685213"/>
-            <a:ext cx="2971800" cy="458787"/>
-          </a:xfrm>
-          <a:prstGeom prst="rect">
-            <a:avLst/>
-          </a:prstGeom>
-        </p:spPr>
-        <p:txBody>
-          <a:bodyPr vert="horz" lIns="91440" tIns="45720" rIns="91440" bIns="45720" rtlCol="0" anchor="b"/>
-          <a:lstStyle>
-            <a:lvl1pPr algn="l">
-              <a:defRPr sz="1200"/>
-            </a:lvl1pPr>
-          </a:lstStyle>
-          <a:p>
-            <a:endParaRPr lang="en-US"/>
-          </a:p>
-        </p:txBody>
-      </p:sp>
-      <p:sp>
-        <p:nvSpPr>
-          <p:cNvPr id="7" name="Slide Number Placeholder 6"/>
-          <p:cNvSpPr>
-            <a:spLocks noGrp="1"/>
-          </p:cNvSpPr>
-          <p:nvPr>
-            <p:ph type="sldNum" sz="quarter" idx="5"/>
-          </p:nvPr>
-        </p:nvSpPr>
-        <p:spPr>
-          <a:xfrm>
-            <a:off x="3884613" y="8685213"/>
-            <a:ext cx="2971800" cy="458787"/>
-          </a:xfrm>
-          <a:prstGeom prst="rect">
-            <a:avLst/>
-          </a:prstGeom>
-        </p:spPr>
-        <p:txBody>
-          <a:bodyPr vert="horz" lIns="91440" tIns="45720" rIns="91440" bIns="45720" rtlCol="0" anchor="b"/>
-          <a:lstStyle>
-            <a:lvl1pPr algn="r">
-              <a:defRPr sz="1200"/>
-            </a:lvl1pPr>
-          </a:lstStyle>
-          <a:p>
-            <a:fld id="{CE5E9CC1-C706-0F49-92D6-E571CC5EEA8F}" type="slidenum">
-              <a:rPr lang="en-US"/>
-              <a:t>‹#›</a:t>
-            </a:fld>
-            <a:endParaRPr lang="en-US"/>
-          </a:p>
-        </p:txBody>
-      </p:sp>
     </p:spTree>
     <p:extLst>
       <p:ext uri="{BB962C8B-B14F-4D97-AF65-F5344CB8AC3E}">
-        <p14:creationId xmlns:p14="http://schemas.microsoft.com/office/powerpoint/2010/main" val="1024086991"/>
+        <p14:creationId xmlns:p14="http://schemas.microsoft.com/office/powerpoint/2010/main" val="1176429320"/>
       </p:ext>
     </p:extLst>
   </p:cSld>
@@ -514,10 +295,6 @@
           <a:bodyPr/>
           <a:lstStyle/>
           <a:p>
-            <a:r>
-              <a:rPr lang="en-US" dirty="0"/>
-              <a:t/>
-            </a:r>
             <a:endParaRPr lang="en-US" dirty="0"/>
           </a:p>
         </p:txBody>
@@ -602,10 +379,6 @@
           <a:bodyPr/>
           <a:lstStyle/>
           <a:p>
-            <a:r>
-              <a:rPr lang="en-US" dirty="0"/>
-              <a:t/>
-            </a:r>
             <a:endParaRPr lang="en-US" dirty="0"/>
           </a:p>
         </p:txBody>
@@ -690,10 +463,6 @@
           <a:bodyPr/>
           <a:lstStyle/>
           <a:p>
-            <a:r>
-              <a:rPr lang="en-US" dirty="0"/>
-              <a:t/>
-            </a:r>
             <a:endParaRPr lang="en-US" dirty="0"/>
           </a:p>
         </p:txBody>
@@ -778,10 +547,6 @@
           <a:bodyPr/>
           <a:lstStyle/>
           <a:p>
-            <a:r>
-              <a:rPr lang="en-US" dirty="0"/>
-              <a:t/>
-            </a:r>
             <a:endParaRPr lang="en-US" dirty="0"/>
           </a:p>
         </p:txBody>
@@ -866,10 +631,6 @@
           <a:bodyPr/>
           <a:lstStyle/>
           <a:p>
-            <a:r>
-              <a:rPr lang="en-US" dirty="0"/>
-              <a:t/>
-            </a:r>
             <a:endParaRPr lang="en-US" dirty="0"/>
           </a:p>
         </p:txBody>
@@ -954,10 +715,6 @@
           <a:bodyPr/>
           <a:lstStyle/>
           <a:p>
-            <a:r>
-              <a:rPr lang="en-US" dirty="0"/>
-              <a:t/>
-            </a:r>
             <a:endParaRPr lang="en-US" dirty="0"/>
           </a:p>
         </p:txBody>
@@ -1042,10 +799,6 @@
           <a:bodyPr/>
           <a:lstStyle/>
           <a:p>
-            <a:r>
-              <a:rPr lang="en-US" dirty="0"/>
-              <a:t/>
-            </a:r>
             <a:endParaRPr lang="en-US" dirty="0"/>
           </a:p>
         </p:txBody>
@@ -1130,10 +883,6 @@
           <a:bodyPr/>
           <a:lstStyle/>
           <a:p>
-            <a:r>
-              <a:rPr lang="en-US" dirty="0"/>
-              <a:t/>
-            </a:r>
             <a:endParaRPr lang="en-US" dirty="0"/>
           </a:p>
         </p:txBody>
@@ -1218,10 +967,6 @@
           <a:bodyPr/>
           <a:lstStyle/>
           <a:p>
-            <a:r>
-              <a:rPr lang="en-US" dirty="0"/>
-              <a:t/>
-            </a:r>
             <a:endParaRPr lang="en-US" dirty="0"/>
           </a:p>
         </p:txBody>
@@ -1306,10 +1051,6 @@
           <a:bodyPr/>
           <a:lstStyle/>
           <a:p>
-            <a:r>
-              <a:rPr lang="en-US" dirty="0"/>
-              <a:t/>
-            </a:r>
             <a:endParaRPr lang="en-US" dirty="0"/>
           </a:p>
         </p:txBody>
@@ -1394,10 +1135,6 @@
           <a:bodyPr/>
           <a:lstStyle/>
           <a:p>
-            <a:r>
-              <a:rPr lang="en-US" dirty="0"/>
-              <a:t/>
-            </a:r>
             <a:endParaRPr lang="en-US" dirty="0"/>
           </a:p>
         </p:txBody>
@@ -1482,10 +1219,6 @@
           <a:bodyPr/>
           <a:lstStyle/>
           <a:p>
-            <a:r>
-              <a:rPr lang="en-US" dirty="0"/>
-              <a:t/>
-            </a:r>
             <a:endParaRPr lang="en-US" dirty="0"/>
           </a:p>
         </p:txBody>
@@ -1570,10 +1303,6 @@
           <a:bodyPr/>
           <a:lstStyle/>
           <a:p>
-            <a:r>
-              <a:rPr lang="en-US" dirty="0"/>
-              <a:t/>
-            </a:r>
             <a:endParaRPr lang="en-US" dirty="0"/>
           </a:p>
         </p:txBody>
@@ -1658,10 +1387,6 @@
           <a:bodyPr/>
           <a:lstStyle/>
           <a:p>
-            <a:r>
-              <a:rPr lang="en-US" dirty="0"/>
-              <a:t/>
-            </a:r>
             <a:endParaRPr lang="en-US" dirty="0"/>
           </a:p>
         </p:txBody>
@@ -1746,10 +1471,6 @@
           <a:bodyPr/>
           <a:lstStyle/>
           <a:p>
-            <a:r>
-              <a:rPr lang="en-US" dirty="0"/>
-              <a:t/>
-            </a:r>
             <a:endParaRPr lang="en-US" dirty="0"/>
           </a:p>
         </p:txBody>
@@ -1823,6 +1544,11 @@
 <file path=ppt/slideMasters/slideMaster1.xml><?xml version="1.0" encoding="utf-8"?>
 <p:sldMaster xmlns:a="http://schemas.openxmlformats.org/drawingml/2006/main" xmlns:r="http://schemas.openxmlformats.org/officeDocument/2006/relationships" xmlns:p="http://schemas.openxmlformats.org/presentationml/2006/main">
   <p:cSld>
+    <p:bg>
+      <p:bgRef idx="1001">
+        <a:schemeClr val="bg1"/>
+      </p:bgRef>
+    </p:bg>
     <p:spTree>
       <p:nvGrpSpPr>
         <p:cNvPr id="1" name=""/>
@@ -2105,6 +1831,7 @@
         <a:solidFill>
           <a:srgbClr val="0F172A"/>
         </a:solidFill>
+        <a:effectLst/>
       </p:bgPr>
     </p:bg>
     <p:spTree>
@@ -2186,7 +1913,7 @@
           <a:bodyPr wrap="square" lIns="0" tIns="0" rIns="0" bIns="0" rtlCol="0" anchor="ctr"/>
           <a:lstStyle/>
           <a:p>
-            <a:pPr indent="0" marL="0">
+            <a:pPr marL="0" indent="0">
               <a:buNone/>
             </a:pPr>
             <a:r>
@@ -2198,7 +1925,7 @@
                 <a:ea typeface="Arial Black" pitchFamily="34" charset="-122"/>
                 <a:cs typeface="Arial Black" pitchFamily="34" charset="-120"/>
               </a:rPr>
-              <a:t>AI Coding Tools 101</a:t>
+              <a:t>AI Coding Tools</a:t>
             </a:r>
             <a:endParaRPr lang="en-US" sz="4800" dirty="0"/>
           </a:p>
@@ -2225,7 +1952,7 @@
           <a:bodyPr wrap="square" lIns="0" tIns="0" rIns="0" bIns="0" rtlCol="0" anchor="ctr"/>
           <a:lstStyle/>
           <a:p>
-            <a:pPr indent="0" marL="0">
+            <a:pPr marL="0" indent="0">
               <a:buNone/>
             </a:pPr>
             <a:r>
@@ -2287,7 +2014,7 @@
           <a:bodyPr wrap="square" lIns="0" tIns="0" rIns="0" bIns="0" rtlCol="0" anchor="ctr"/>
           <a:lstStyle/>
           <a:p>
-            <a:pPr indent="0" marL="0">
+            <a:pPr marL="0" indent="0">
               <a:buNone/>
             </a:pPr>
             <a:r>
@@ -2326,7 +2053,7 @@
           <a:bodyPr wrap="square" lIns="0" tIns="0" rIns="0" bIns="0" rtlCol="0" anchor="ctr"/>
           <a:lstStyle/>
           <a:p>
-            <a:pPr indent="0" marL="0">
+            <a:pPr marL="0" indent="0">
               <a:buNone/>
             </a:pPr>
             <a:r>
@@ -2360,6 +2087,7 @@
         <a:solidFill>
           <a:srgbClr val="F8FAFC"/>
         </a:solidFill>
+        <a:effectLst/>
       </p:bgPr>
     </p:bg>
     <p:spTree>
@@ -2404,8 +2132,8 @@
         </p:nvSpPr>
         <p:spPr>
           <a:xfrm>
-            <a:off x="640080" y="320040"/>
-            <a:ext cx="7315200" cy="502920"/>
+            <a:off x="572002" y="306324"/>
+            <a:ext cx="8137155" cy="502920"/>
           </a:xfrm>
           <a:prstGeom prst="rect">
             <a:avLst/>
@@ -2417,11 +2145,11 @@
           <a:bodyPr wrap="square" lIns="0" tIns="0" rIns="0" bIns="0" rtlCol="0" anchor="ctr"/>
           <a:lstStyle/>
           <a:p>
-            <a:pPr indent="0" marL="0">
-              <a:buNone/>
-            </a:pPr>
-            <a:r>
-              <a:rPr lang="en-US" sz="3200" dirty="0">
+            <a:pPr marL="0" indent="0">
+              <a:buNone/>
+            </a:pPr>
+            <a:r>
+              <a:rPr lang="en-US" sz="2800" dirty="0">
                 <a:solidFill>
                   <a:srgbClr val="1E293B"/>
                 </a:solidFill>
@@ -2431,7 +2159,7 @@
               </a:rPr>
               <a:t>Workflows Demo — Orchestrating Skills</a:t>
             </a:r>
-            <a:endParaRPr lang="en-US" sz="3200" dirty="0"/>
+            <a:endParaRPr lang="en-US" sz="2800" dirty="0"/>
           </a:p>
         </p:txBody>
       </p:sp>
@@ -2454,7 +2182,7 @@
           </a:solidFill>
           <a:ln/>
           <a:effectLst>
-            <a:outerShdw sx="100000" sy="100000" kx="0" ky="0" algn="bl" rotWithShape="0" blurRad="76200" dist="25400" dir="8100000">
+            <a:outerShdw blurRad="76200" dist="25400" dir="8100000" algn="bl" rotWithShape="0">
               <a:srgbClr val="000000">
                 <a:alpha val="10000"/>
               </a:srgbClr>
@@ -2503,7 +2231,7 @@
           <a:bodyPr wrap="square" lIns="0" tIns="0" rIns="0" bIns="0" rtlCol="0" anchor="ctr"/>
           <a:lstStyle/>
           <a:p>
-            <a:pPr indent="0" marL="0">
+            <a:pPr marL="0" indent="0">
               <a:buNone/>
             </a:pPr>
             <a:r>
@@ -2562,7 +2290,7 @@
           <a:bodyPr wrap="square" lIns="0" tIns="0" rIns="0" bIns="0" rtlCol="0" anchor="ctr"/>
           <a:lstStyle/>
           <a:p>
-            <a:pPr algn="ctr" indent="0" marL="0">
+            <a:pPr marL="0" indent="0" algn="ctr">
               <a:buNone/>
             </a:pPr>
             <a:r>
@@ -2579,7 +2307,7 @@
             <a:endParaRPr lang="en-US" sz="1100" dirty="0"/>
           </a:p>
           <a:p>
-            <a:pPr algn="ctr" indent="0" marL="0">
+            <a:pPr marL="0" indent="0" algn="ctr">
               <a:buNone/>
             </a:pPr>
             <a:r>
@@ -2638,7 +2366,7 @@
           <a:bodyPr wrap="square" lIns="0" tIns="0" rIns="0" bIns="0" rtlCol="0" anchor="ctr"/>
           <a:lstStyle/>
           <a:p>
-            <a:pPr algn="ctr" indent="0" marL="0">
+            <a:pPr marL="0" indent="0" algn="ctr">
               <a:buNone/>
             </a:pPr>
             <a:r>
@@ -2655,7 +2383,7 @@
             <a:endParaRPr lang="en-US" sz="1100" dirty="0"/>
           </a:p>
           <a:p>
-            <a:pPr algn="ctr" indent="0" marL="0">
+            <a:pPr marL="0" indent="0" algn="ctr">
               <a:buNone/>
             </a:pPr>
             <a:r>
@@ -2714,7 +2442,7 @@
           <a:bodyPr wrap="square" lIns="0" tIns="0" rIns="0" bIns="0" rtlCol="0" anchor="ctr"/>
           <a:lstStyle/>
           <a:p>
-            <a:pPr algn="ctr" indent="0" marL="0">
+            <a:pPr marL="0" indent="0" algn="ctr">
               <a:buNone/>
             </a:pPr>
             <a:r>
@@ -2731,7 +2459,7 @@
             <a:endParaRPr lang="en-US" sz="1100" dirty="0"/>
           </a:p>
           <a:p>
-            <a:pPr algn="ctr" indent="0" marL="0">
+            <a:pPr marL="0" indent="0" algn="ctr">
               <a:buNone/>
             </a:pPr>
             <a:r>
@@ -2790,7 +2518,7 @@
           <a:bodyPr wrap="square" lIns="0" tIns="0" rIns="0" bIns="0" rtlCol="0" anchor="ctr"/>
           <a:lstStyle/>
           <a:p>
-            <a:pPr algn="ctr" indent="0" marL="0">
+            <a:pPr marL="0" indent="0" algn="ctr">
               <a:buNone/>
             </a:pPr>
             <a:r>
@@ -2807,7 +2535,7 @@
             <a:endParaRPr lang="en-US" sz="1100" dirty="0"/>
           </a:p>
           <a:p>
-            <a:pPr algn="ctr" indent="0" marL="0">
+            <a:pPr marL="0" indent="0" algn="ctr">
               <a:buNone/>
             </a:pPr>
             <a:r>
@@ -2866,7 +2594,7 @@
           <a:bodyPr wrap="square" lIns="0" tIns="0" rIns="0" bIns="0" rtlCol="0" anchor="ctr"/>
           <a:lstStyle/>
           <a:p>
-            <a:pPr algn="ctr" indent="0" marL="0">
+            <a:pPr marL="0" indent="0" algn="ctr">
               <a:buNone/>
             </a:pPr>
             <a:r>
@@ -2883,7 +2611,7 @@
             <a:endParaRPr lang="en-US" sz="1100" dirty="0"/>
           </a:p>
           <a:p>
-            <a:pPr algn="ctr" indent="0" marL="0">
+            <a:pPr marL="0" indent="0" algn="ctr">
               <a:buNone/>
             </a:pPr>
             <a:r>
@@ -2942,7 +2670,7 @@
           <a:bodyPr wrap="square" lIns="0" tIns="0" rIns="0" bIns="0" rtlCol="0" anchor="ctr"/>
           <a:lstStyle/>
           <a:p>
-            <a:pPr algn="ctr" indent="0" marL="0">
+            <a:pPr marL="0" indent="0" algn="ctr">
               <a:buNone/>
             </a:pPr>
             <a:r>
@@ -2959,7 +2687,7 @@
             <a:endParaRPr lang="en-US" sz="1100" dirty="0"/>
           </a:p>
           <a:p>
-            <a:pPr algn="ctr" indent="0" marL="0">
+            <a:pPr marL="0" indent="0" algn="ctr">
               <a:buNone/>
             </a:pPr>
             <a:r>
@@ -3018,7 +2746,7 @@
           <a:bodyPr wrap="square" lIns="0" tIns="0" rIns="0" bIns="0" rtlCol="0" anchor="ctr"/>
           <a:lstStyle/>
           <a:p>
-            <a:pPr algn="ctr" indent="0" marL="0">
+            <a:pPr marL="0" indent="0" algn="ctr">
               <a:buNone/>
             </a:pPr>
             <a:r>
@@ -3035,7 +2763,7 @@
             <a:endParaRPr lang="en-US" sz="1100" dirty="0"/>
           </a:p>
           <a:p>
-            <a:pPr algn="ctr" indent="0" marL="0">
+            <a:pPr marL="0" indent="0" algn="ctr">
               <a:buNone/>
             </a:pPr>
             <a:r>
@@ -3074,7 +2802,7 @@
           <a:bodyPr wrap="square" lIns="0" tIns="0" rIns="0" bIns="0" rtlCol="0" anchor="ctr"/>
           <a:lstStyle/>
           <a:p>
-            <a:pPr algn="ctr" indent="0" marL="0">
+            <a:pPr marL="0" indent="0" algn="ctr">
               <a:buNone/>
             </a:pPr>
             <a:r>
@@ -3110,7 +2838,7 @@
           <a:bodyPr wrap="square" lIns="0" tIns="0" rIns="0" bIns="0" rtlCol="0" anchor="ctr"/>
           <a:lstStyle/>
           <a:p>
-            <a:pPr algn="ctr" indent="0" marL="0">
+            <a:pPr marL="0" indent="0" algn="ctr">
               <a:buNone/>
             </a:pPr>
             <a:r>
@@ -3146,7 +2874,7 @@
           <a:bodyPr wrap="square" lIns="0" tIns="0" rIns="0" bIns="0" rtlCol="0" anchor="ctr"/>
           <a:lstStyle/>
           <a:p>
-            <a:pPr algn="ctr" indent="0" marL="0">
+            <a:pPr marL="0" indent="0" algn="ctr">
               <a:buNone/>
             </a:pPr>
             <a:r>
@@ -3182,7 +2910,7 @@
           <a:bodyPr wrap="square" lIns="0" tIns="0" rIns="0" bIns="0" rtlCol="0" anchor="ctr"/>
           <a:lstStyle/>
           <a:p>
-            <a:pPr algn="ctr" indent="0" marL="0">
+            <a:pPr marL="0" indent="0" algn="ctr">
               <a:buNone/>
             </a:pPr>
             <a:r>
@@ -3218,7 +2946,7 @@
           <a:bodyPr wrap="square" lIns="0" tIns="0" rIns="0" bIns="0" rtlCol="0" anchor="ctr"/>
           <a:lstStyle/>
           <a:p>
-            <a:pPr algn="ctr" indent="0" marL="0">
+            <a:pPr marL="0" indent="0" algn="ctr">
               <a:buNone/>
             </a:pPr>
             <a:r>
@@ -3254,7 +2982,7 @@
           <a:bodyPr wrap="square" lIns="0" tIns="0" rIns="0" bIns="0" rtlCol="0" anchor="ctr"/>
           <a:lstStyle/>
           <a:p>
-            <a:pPr algn="ctr" indent="0" marL="0">
+            <a:pPr marL="0" indent="0" algn="ctr">
               <a:buNone/>
             </a:pPr>
             <a:r>
@@ -3310,7 +3038,7 @@
           <a:bodyPr wrap="square" lIns="0" tIns="0" rIns="0" bIns="0" rtlCol="0" anchor="ctr"/>
           <a:lstStyle/>
           <a:p>
-            <a:pPr indent="0" marL="0">
+            <a:pPr marL="0" indent="0">
               <a:buNone/>
             </a:pPr>
             <a:r>
@@ -3327,7 +3055,7 @@
             <a:endParaRPr lang="en-US" sz="1000" dirty="0"/>
           </a:p>
           <a:p>
-            <a:pPr indent="0" marL="0">
+            <a:pPr marL="0" indent="0">
               <a:buNone/>
             </a:pPr>
             <a:r>
@@ -3341,9 +3069,6 @@
               </a:rPr>
               <a:t>Invoke: </a:t>
             </a:r>
-            <a:pPr indent="0" marL="0">
-              <a:buNone/>
-            </a:pPr>
             <a:r>
               <a:rPr lang="en-US" sz="1000" dirty="0">
                 <a:solidFill>
@@ -3355,9 +3080,6 @@
               </a:rPr>
               <a:t>/ci-pipeline</a:t>
             </a:r>
-            <a:pPr indent="0" marL="0">
-              <a:buNone/>
-            </a:pPr>
             <a:r>
               <a:rPr lang="en-US" sz="1000" dirty="0">
                 <a:solidFill>
@@ -3394,7 +3116,7 @@
           <a:bodyPr wrap="square" lIns="0" tIns="0" rIns="0" bIns="0" rtlCol="0" anchor="ctr"/>
           <a:lstStyle/>
           <a:p>
-            <a:pPr indent="0" marL="0">
+            <a:pPr marL="0" indent="0">
               <a:buNone/>
             </a:pPr>
             <a:r>
@@ -3428,6 +3150,7 @@
         <a:solidFill>
           <a:srgbClr val="F8FAFC"/>
         </a:solidFill>
+        <a:effectLst/>
       </p:bgPr>
     </p:bg>
     <p:spTree>
@@ -3485,11 +3208,11 @@
           <a:bodyPr wrap="square" lIns="0" tIns="0" rIns="0" bIns="0" rtlCol="0" anchor="ctr"/>
           <a:lstStyle/>
           <a:p>
-            <a:pPr indent="0" marL="0">
-              <a:buNone/>
-            </a:pPr>
-            <a:r>
-              <a:rPr lang="en-US" sz="3600" dirty="0">
+            <a:pPr marL="0" indent="0">
+              <a:buNone/>
+            </a:pPr>
+            <a:r>
+              <a:rPr lang="en-US" sz="3200" dirty="0">
                 <a:solidFill>
                   <a:srgbClr val="1E293B"/>
                 </a:solidFill>
@@ -3499,7 +3222,7 @@
               </a:rPr>
               <a:t>MCP — Model Context Protocol</a:t>
             </a:r>
-            <a:endParaRPr lang="en-US" sz="3600" dirty="0"/>
+            <a:endParaRPr lang="en-US" sz="3200" dirty="0"/>
           </a:p>
         </p:txBody>
       </p:sp>
@@ -3524,7 +3247,7 @@
           <a:bodyPr wrap="square" lIns="0" tIns="0" rIns="0" bIns="0" rtlCol="0" anchor="ctr"/>
           <a:lstStyle/>
           <a:p>
-            <a:pPr indent="0" marL="0">
+            <a:pPr marL="0" indent="0">
               <a:buNone/>
             </a:pPr>
             <a:r>
@@ -3583,7 +3306,7 @@
           <a:bodyPr wrap="square" lIns="0" tIns="0" rIns="0" bIns="0" rtlCol="0" anchor="ctr"/>
           <a:lstStyle/>
           <a:p>
-            <a:pPr algn="ctr" indent="0" marL="0">
+            <a:pPr marL="0" indent="0" algn="ctr">
               <a:buNone/>
             </a:pPr>
             <a:r>
@@ -3622,7 +3345,7 @@
           <a:bodyPr wrap="square" lIns="0" tIns="0" rIns="0" bIns="0" rtlCol="0" anchor="ctr"/>
           <a:lstStyle/>
           <a:p>
-            <a:pPr algn="ctr" indent="0" marL="0">
+            <a:pPr marL="0" indent="0" algn="ctr">
               <a:buNone/>
             </a:pPr>
             <a:r>
@@ -3639,7 +3362,7 @@
             <a:endParaRPr lang="en-US" sz="1300" dirty="0"/>
           </a:p>
           <a:p>
-            <a:pPr algn="ctr" indent="0" marL="0">
+            <a:pPr marL="0" indent="0" algn="ctr">
               <a:buNone/>
             </a:pPr>
             <a:r>
@@ -3700,7 +3423,7 @@
           <a:bodyPr wrap="square" lIns="0" tIns="0" rIns="0" bIns="0" rtlCol="0" anchor="ctr"/>
           <a:lstStyle/>
           <a:p>
-            <a:pPr algn="ctr" indent="0" marL="0">
+            <a:pPr marL="0" indent="0" algn="ctr">
               <a:buNone/>
             </a:pPr>
             <a:r>
@@ -3739,7 +3462,7 @@
           <a:bodyPr wrap="square" lIns="0" tIns="0" rIns="0" bIns="0" rtlCol="0" anchor="ctr"/>
           <a:lstStyle/>
           <a:p>
-            <a:pPr algn="ctr" indent="0" marL="0">
+            <a:pPr marL="0" indent="0" algn="ctr">
               <a:buNone/>
             </a:pPr>
             <a:r>
@@ -3756,7 +3479,7 @@
             <a:endParaRPr lang="en-US" sz="1200" dirty="0"/>
           </a:p>
           <a:p>
-            <a:pPr algn="ctr" indent="0" marL="0">
+            <a:pPr marL="0" indent="0" algn="ctr">
               <a:buNone/>
             </a:pPr>
             <a:r>
@@ -3793,7 +3516,7 @@
           </a:solidFill>
           <a:ln/>
           <a:effectLst>
-            <a:outerShdw sx="100000" sy="100000" kx="0" ky="0" algn="bl" rotWithShape="0" blurRad="76200" dist="25400" dir="8100000">
+            <a:outerShdw blurRad="76200" dist="25400" dir="8100000" algn="bl" rotWithShape="0">
               <a:srgbClr val="000000">
                 <a:alpha val="10000"/>
               </a:srgbClr>
@@ -3822,7 +3545,7 @@
           <a:bodyPr wrap="square" lIns="0" tIns="0" rIns="0" bIns="0" rtlCol="0" anchor="ctr"/>
           <a:lstStyle/>
           <a:p>
-            <a:pPr algn="ctr" indent="0" marL="0">
+            <a:pPr marL="0" indent="0" algn="ctr">
               <a:buNone/>
             </a:pPr>
             <a:r>
@@ -3861,7 +3584,7 @@
           <a:bodyPr wrap="square" lIns="0" tIns="0" rIns="0" bIns="0" rtlCol="0" anchor="ctr"/>
           <a:lstStyle/>
           <a:p>
-            <a:pPr algn="ctr" indent="0" marL="0">
+            <a:pPr marL="0" indent="0" algn="ctr">
               <a:buNone/>
             </a:pPr>
             <a:r>
@@ -3878,7 +3601,7 @@
             <a:endParaRPr lang="en-US" sz="1300" dirty="0"/>
           </a:p>
           <a:p>
-            <a:pPr algn="ctr" indent="0" marL="0">
+            <a:pPr marL="0" indent="0" algn="ctr">
               <a:buNone/>
             </a:pPr>
             <a:r>
@@ -3917,7 +3640,7 @@
           <a:bodyPr wrap="square" lIns="0" tIns="0" rIns="0" bIns="0" rtlCol="0" anchor="ctr"/>
           <a:lstStyle/>
           <a:p>
-            <a:pPr algn="ctr" indent="0" marL="0">
+            <a:pPr marL="0" indent="0" algn="ctr">
               <a:buNone/>
             </a:pPr>
             <a:r>
@@ -3953,7 +3676,7 @@
           <a:bodyPr wrap="square" lIns="0" tIns="0" rIns="0" bIns="0" rtlCol="0" anchor="ctr"/>
           <a:lstStyle/>
           <a:p>
-            <a:pPr algn="ctr" indent="0" marL="0">
+            <a:pPr marL="0" indent="0" algn="ctr">
               <a:buNone/>
             </a:pPr>
             <a:r>
@@ -3989,7 +3712,7 @@
           <a:bodyPr wrap="square" lIns="0" tIns="0" rIns="0" bIns="0" rtlCol="0" anchor="ctr"/>
           <a:lstStyle/>
           <a:p>
-            <a:pPr indent="0" marL="0">
+            <a:pPr marL="0" indent="0">
               <a:buNone/>
             </a:pPr>
             <a:r>
@@ -4028,7 +3751,7 @@
           <a:bodyPr wrap="square" lIns="0" tIns="0" rIns="0" bIns="0" rtlCol="0" anchor="ctr"/>
           <a:lstStyle/>
           <a:p>
-            <a:pPr indent="0" marL="0">
+            <a:pPr marL="0" indent="0">
               <a:buNone/>
             </a:pPr>
             <a:r>
@@ -4067,7 +3790,7 @@
           <a:bodyPr wrap="square" lIns="0" tIns="0" rIns="0" bIns="0" rtlCol="0" anchor="ctr"/>
           <a:lstStyle/>
           <a:p>
-            <a:pPr indent="0" marL="0">
+            <a:pPr marL="0" indent="0">
               <a:buNone/>
             </a:pPr>
             <a:r>
@@ -4106,7 +3829,7 @@
           <a:bodyPr wrap="square" lIns="0" tIns="0" rIns="0" bIns="0" rtlCol="0" anchor="ctr"/>
           <a:lstStyle/>
           <a:p>
-            <a:pPr indent="0" marL="0">
+            <a:pPr marL="0" indent="0">
               <a:buNone/>
             </a:pPr>
             <a:r>
@@ -4145,7 +3868,7 @@
           <a:bodyPr wrap="square" lIns="0" tIns="0" rIns="0" bIns="0" rtlCol="0" anchor="ctr"/>
           <a:lstStyle/>
           <a:p>
-            <a:pPr indent="0" marL="0">
+            <a:pPr marL="0" indent="0">
               <a:buNone/>
             </a:pPr>
             <a:r>
@@ -4184,7 +3907,7 @@
           <a:bodyPr wrap="square" lIns="0" tIns="0" rIns="0" bIns="0" rtlCol="0" anchor="ctr"/>
           <a:lstStyle/>
           <a:p>
-            <a:pPr indent="0" marL="0">
+            <a:pPr marL="0" indent="0">
               <a:buNone/>
             </a:pPr>
             <a:r>
@@ -4223,7 +3946,7 @@
           <a:bodyPr wrap="square" lIns="0" tIns="0" rIns="0" bIns="0" rtlCol="0" anchor="ctr"/>
           <a:lstStyle/>
           <a:p>
-            <a:pPr indent="0" marL="0">
+            <a:pPr marL="0" indent="0">
               <a:buNone/>
             </a:pPr>
             <a:r>
@@ -4262,7 +3985,7 @@
           <a:bodyPr wrap="square" lIns="0" tIns="0" rIns="0" bIns="0" rtlCol="0" anchor="ctr"/>
           <a:lstStyle/>
           <a:p>
-            <a:pPr indent="0" marL="0">
+            <a:pPr marL="0" indent="0">
               <a:buNone/>
             </a:pPr>
             <a:r>
@@ -4301,7 +4024,7 @@
           <a:bodyPr wrap="square" lIns="0" tIns="0" rIns="0" bIns="0" rtlCol="0" anchor="ctr"/>
           <a:lstStyle/>
           <a:p>
-            <a:pPr indent="0" marL="0">
+            <a:pPr marL="0" indent="0">
               <a:buNone/>
             </a:pPr>
             <a:r>
@@ -4340,7 +4063,7 @@
           <a:bodyPr wrap="square" lIns="0" tIns="0" rIns="0" bIns="0" rtlCol="0" anchor="ctr"/>
           <a:lstStyle/>
           <a:p>
-            <a:pPr indent="0" marL="0">
+            <a:pPr marL="0" indent="0">
               <a:buNone/>
             </a:pPr>
             <a:r>
@@ -4379,7 +4102,7 @@
           <a:bodyPr wrap="square" lIns="0" tIns="0" rIns="0" bIns="0" rtlCol="0" anchor="ctr"/>
           <a:lstStyle/>
           <a:p>
-            <a:pPr indent="0" marL="0">
+            <a:pPr marL="0" indent="0">
               <a:buNone/>
             </a:pPr>
             <a:r>
@@ -4418,7 +4141,7 @@
           <a:bodyPr wrap="square" lIns="0" tIns="0" rIns="0" bIns="0" rtlCol="0" anchor="ctr"/>
           <a:lstStyle/>
           <a:p>
-            <a:pPr indent="0" marL="0">
+            <a:pPr marL="0" indent="0">
               <a:buNone/>
             </a:pPr>
             <a:r>
@@ -4457,7 +4180,7 @@
           <a:bodyPr wrap="square" lIns="0" tIns="0" rIns="0" bIns="0" rtlCol="0" anchor="ctr"/>
           <a:lstStyle/>
           <a:p>
-            <a:pPr indent="0" marL="0">
+            <a:pPr marL="0" indent="0">
               <a:buNone/>
             </a:pPr>
             <a:r>
@@ -4491,6 +4214,7 @@
         <a:solidFill>
           <a:srgbClr val="F8FAFC"/>
         </a:solidFill>
+        <a:effectLst/>
       </p:bgPr>
     </p:bg>
     <p:spTree>
@@ -4535,8 +4259,8 @@
         </p:nvSpPr>
         <p:spPr>
           <a:xfrm>
-            <a:off x="640080" y="320040"/>
-            <a:ext cx="7315200" cy="502920"/>
+            <a:off x="640079" y="320040"/>
+            <a:ext cx="8007809" cy="502920"/>
           </a:xfrm>
           <a:prstGeom prst="rect">
             <a:avLst/>
@@ -4548,11 +4272,11 @@
           <a:bodyPr wrap="square" lIns="0" tIns="0" rIns="0" bIns="0" rtlCol="0" anchor="ctr"/>
           <a:lstStyle/>
           <a:p>
-            <a:pPr indent="0" marL="0">
-              <a:buNone/>
-            </a:pPr>
-            <a:r>
-              <a:rPr lang="en-US" sz="3200" dirty="0">
+            <a:pPr marL="0" indent="0">
+              <a:buNone/>
+            </a:pPr>
+            <a:r>
+              <a:rPr lang="en-US" sz="2800" dirty="0">
                 <a:solidFill>
                   <a:srgbClr val="1E293B"/>
                 </a:solidFill>
@@ -4562,7 +4286,7 @@
               </a:rPr>
               <a:t>MCP Demo — Expanding AI Capabilities</a:t>
             </a:r>
-            <a:endParaRPr lang="en-US" sz="3200" dirty="0"/>
+            <a:endParaRPr lang="en-US" sz="2800" dirty="0"/>
           </a:p>
         </p:txBody>
       </p:sp>
@@ -4627,7 +4351,7 @@
           <a:bodyPr wrap="square" lIns="0" tIns="0" rIns="0" bIns="0" rtlCol="0" anchor="ctr"/>
           <a:lstStyle/>
           <a:p>
-            <a:pPr indent="0" marL="0">
+            <a:pPr marL="0" indent="0">
               <a:buNone/>
             </a:pPr>
             <a:r>
@@ -4796,7 +4520,7 @@
           <a:bodyPr wrap="square" lIns="0" tIns="0" rIns="0" bIns="0" rtlCol="0" anchor="ctr"/>
           <a:lstStyle/>
           <a:p>
-            <a:pPr algn="ctr" indent="0" marL="0">
+            <a:pPr marL="0" indent="0" algn="ctr">
               <a:buNone/>
             </a:pPr>
             <a:r>
@@ -4875,7 +4599,7 @@
           <a:bodyPr wrap="square" lIns="0" tIns="0" rIns="0" bIns="0" rtlCol="0" anchor="ctr"/>
           <a:lstStyle/>
           <a:p>
-            <a:pPr indent="0" marL="0">
+            <a:pPr marL="0" indent="0">
               <a:buNone/>
             </a:pPr>
             <a:r>
@@ -5044,7 +4768,7 @@
           <a:bodyPr wrap="square" lIns="0" tIns="0" rIns="0" bIns="0" rtlCol="0" anchor="ctr"/>
           <a:lstStyle/>
           <a:p>
-            <a:pPr indent="0" marL="0">
+            <a:pPr marL="0" indent="0">
               <a:buNone/>
             </a:pPr>
             <a:r>
@@ -5078,6 +4802,7 @@
         <a:solidFill>
           <a:srgbClr val="F8FAFC"/>
         </a:solidFill>
+        <a:effectLst/>
       </p:bgPr>
     </p:bg>
     <p:spTree>
@@ -5135,7 +4860,7 @@
           <a:bodyPr wrap="square" lIns="0" tIns="0" rIns="0" bIns="0" rtlCol="0" anchor="ctr"/>
           <a:lstStyle/>
           <a:p>
-            <a:pPr indent="0" marL="0">
+            <a:pPr marL="0" indent="0">
               <a:buNone/>
             </a:pPr>
             <a:r>
@@ -5176,10 +4901,34 @@
             <a:tbl>
               <a:tblPr/>
               <a:tblGrid>
-                <a:gridCol w="1828800"/>
-                <a:gridCol w="2130552"/>
-                <a:gridCol w="2130552"/>
-                <a:gridCol w="2130552"/>
+                <a:gridCol w="1828800">
+                  <a:extLst>
+                    <a:ext uri="{9D8B030D-6E8A-4147-A177-3AD203B41FA5}">
+                      <a16:colId xmlns:a16="http://schemas.microsoft.com/office/drawing/2014/main" val="20000"/>
+                    </a:ext>
+                  </a:extLst>
+                </a:gridCol>
+                <a:gridCol w="2130552">
+                  <a:extLst>
+                    <a:ext uri="{9D8B030D-6E8A-4147-A177-3AD203B41FA5}">
+                      <a16:colId xmlns:a16="http://schemas.microsoft.com/office/drawing/2014/main" val="20001"/>
+                    </a:ext>
+                  </a:extLst>
+                </a:gridCol>
+                <a:gridCol w="2130552">
+                  <a:extLst>
+                    <a:ext uri="{9D8B030D-6E8A-4147-A177-3AD203B41FA5}">
+                      <a16:colId xmlns:a16="http://schemas.microsoft.com/office/drawing/2014/main" val="20002"/>
+                    </a:ext>
+                  </a:extLst>
+                </a:gridCol>
+                <a:gridCol w="2130552">
+                  <a:extLst>
+                    <a:ext uri="{9D8B030D-6E8A-4147-A177-3AD203B41FA5}">
+                      <a16:colId xmlns:a16="http://schemas.microsoft.com/office/drawing/2014/main" val="20003"/>
+                    </a:ext>
+                  </a:extLst>
+                </a:gridCol>
               </a:tblGrid>
               <a:tr h="457200">
                 <a:tc>
@@ -5187,7 +4936,7 @@
                     <a:bodyPr/>
                     <a:lstStyle/>
                     <a:p>
-                      <a:pPr algn="ctr" indent="0" marL="0">
+                      <a:pPr marL="0" indent="0" algn="ctr">
                         <a:buNone/>
                       </a:pPr>
                       <a:r>
@@ -5208,7 +4957,7 @@
                       </a:endParaRPr>
                     </a:p>
                   </a:txBody>
-                  <a:tcPr marL="91440" marR="91440" marT="45720" marB="45720" anchor="ctr">
+                  <a:tcPr anchor="ctr">
                     <a:lnL w="6350" cap="flat" cmpd="sng" algn="ctr">
                       <a:solidFill>
                         <a:srgbClr val="E2E8F0"/>
@@ -5255,7 +5004,7 @@
                     <a:bodyPr/>
                     <a:lstStyle/>
                     <a:p>
-                      <a:pPr algn="ctr" indent="0" marL="0">
+                      <a:pPr marL="0" indent="0" algn="ctr">
                         <a:buNone/>
                       </a:pPr>
                       <a:r>
@@ -5276,7 +5025,7 @@
                       </a:endParaRPr>
                     </a:p>
                   </a:txBody>
-                  <a:tcPr marL="91440" marR="91440" marT="45720" marB="45720" anchor="ctr">
+                  <a:tcPr anchor="ctr">
                     <a:lnL w="6350" cap="flat" cmpd="sng" algn="ctr">
                       <a:solidFill>
                         <a:srgbClr val="E2E8F0"/>
@@ -5323,7 +5072,7 @@
                     <a:bodyPr/>
                     <a:lstStyle/>
                     <a:p>
-                      <a:pPr algn="ctr" indent="0" marL="0">
+                      <a:pPr marL="0" indent="0" algn="ctr">
                         <a:buNone/>
                       </a:pPr>
                       <a:r>
@@ -5344,7 +5093,7 @@
                       </a:endParaRPr>
                     </a:p>
                   </a:txBody>
-                  <a:tcPr marL="91440" marR="91440" marT="45720" marB="45720" anchor="ctr">
+                  <a:tcPr anchor="ctr">
                     <a:lnL w="6350" cap="flat" cmpd="sng" algn="ctr">
                       <a:solidFill>
                         <a:srgbClr val="E2E8F0"/>
@@ -5391,7 +5140,7 @@
                     <a:bodyPr/>
                     <a:lstStyle/>
                     <a:p>
-                      <a:pPr algn="ctr" indent="0" marL="0">
+                      <a:pPr marL="0" indent="0" algn="ctr">
                         <a:buNone/>
                       </a:pPr>
                       <a:r>
@@ -5412,7 +5161,7 @@
                       </a:endParaRPr>
                     </a:p>
                   </a:txBody>
-                  <a:tcPr marL="91440" marR="91440" marT="45720" marB="45720" anchor="ctr">
+                  <a:tcPr anchor="ctr">
                     <a:lnL w="6350" cap="flat" cmpd="sng" algn="ctr">
                       <a:solidFill>
                         <a:srgbClr val="E2E8F0"/>
@@ -5454,6 +5203,11 @@
                     </a:solidFill>
                   </a:tcPr>
                 </a:tc>
+                <a:extLst>
+                  <a:ext uri="{0D108BD9-81ED-4DB2-BD59-A6C34878D82A}">
+                    <a16:rowId xmlns:a16="http://schemas.microsoft.com/office/drawing/2014/main" val="10000"/>
+                  </a:ext>
+                </a:extLst>
               </a:tr>
               <a:tr h="384048">
                 <a:tc>
@@ -5461,7 +5215,7 @@
                     <a:bodyPr/>
                     <a:lstStyle/>
                     <a:p>
-                      <a:pPr algn="ctr" indent="0" marL="0">
+                      <a:pPr marL="0" indent="0" algn="ctr">
                         <a:buNone/>
                       </a:pPr>
                       <a:r>
@@ -5482,7 +5236,7 @@
                       </a:endParaRPr>
                     </a:p>
                   </a:txBody>
-                  <a:tcPr marL="91440" marR="91440" marT="45720" marB="45720" anchor="ctr">
+                  <a:tcPr anchor="ctr">
                     <a:lnL w="6350" cap="flat" cmpd="sng" algn="ctr">
                       <a:solidFill>
                         <a:srgbClr val="E2E8F0"/>
@@ -5529,7 +5283,7 @@
                     <a:bodyPr/>
                     <a:lstStyle/>
                     <a:p>
-                      <a:pPr algn="ctr" indent="0" marL="0">
+                      <a:pPr marL="0" indent="0" algn="ctr">
                         <a:buNone/>
                       </a:pPr>
                       <a:r>
@@ -5550,7 +5304,7 @@
                       </a:endParaRPr>
                     </a:p>
                   </a:txBody>
-                  <a:tcPr marL="91440" marR="91440" marT="45720" marB="45720" anchor="ctr">
+                  <a:tcPr anchor="ctr">
                     <a:lnL w="6350" cap="flat" cmpd="sng" algn="ctr">
                       <a:solidFill>
                         <a:srgbClr val="E2E8F0"/>
@@ -5597,7 +5351,7 @@
                     <a:bodyPr/>
                     <a:lstStyle/>
                     <a:p>
-                      <a:pPr algn="ctr" indent="0" marL="0">
+                      <a:pPr marL="0" indent="0" algn="ctr">
                         <a:buNone/>
                       </a:pPr>
                       <a:r>
@@ -5618,7 +5372,7 @@
                       </a:endParaRPr>
                     </a:p>
                   </a:txBody>
-                  <a:tcPr marL="91440" marR="91440" marT="45720" marB="45720" anchor="ctr">
+                  <a:tcPr anchor="ctr">
                     <a:lnL w="6350" cap="flat" cmpd="sng" algn="ctr">
                       <a:solidFill>
                         <a:srgbClr val="E2E8F0"/>
@@ -5665,7 +5419,7 @@
                     <a:bodyPr/>
                     <a:lstStyle/>
                     <a:p>
-                      <a:pPr algn="ctr" indent="0" marL="0">
+                      <a:pPr marL="0" indent="0" algn="ctr">
                         <a:buNone/>
                       </a:pPr>
                       <a:r>
@@ -5686,7 +5440,7 @@
                       </a:endParaRPr>
                     </a:p>
                   </a:txBody>
-                  <a:tcPr marL="91440" marR="91440" marT="45720" marB="45720" anchor="ctr">
+                  <a:tcPr anchor="ctr">
                     <a:lnL w="6350" cap="flat" cmpd="sng" algn="ctr">
                       <a:solidFill>
                         <a:srgbClr val="E2E8F0"/>
@@ -5730,6 +5484,11 @@
                     </a:solidFill>
                   </a:tcPr>
                 </a:tc>
+                <a:extLst>
+                  <a:ext uri="{0D108BD9-81ED-4DB2-BD59-A6C34878D82A}">
+                    <a16:rowId xmlns:a16="http://schemas.microsoft.com/office/drawing/2014/main" val="10001"/>
+                  </a:ext>
+                </a:extLst>
               </a:tr>
               <a:tr h="384048">
                 <a:tc>
@@ -5737,7 +5496,7 @@
                     <a:bodyPr/>
                     <a:lstStyle/>
                     <a:p>
-                      <a:pPr algn="ctr" indent="0" marL="0">
+                      <a:pPr marL="0" indent="0" algn="ctr">
                         <a:buNone/>
                       </a:pPr>
                       <a:r>
@@ -5758,7 +5517,7 @@
                       </a:endParaRPr>
                     </a:p>
                   </a:txBody>
-                  <a:tcPr marL="91440" marR="91440" marT="45720" marB="45720" anchor="ctr">
+                  <a:tcPr anchor="ctr">
                     <a:lnL w="6350" cap="flat" cmpd="sng" algn="ctr">
                       <a:solidFill>
                         <a:srgbClr val="E2E8F0"/>
@@ -5805,7 +5564,7 @@
                     <a:bodyPr/>
                     <a:lstStyle/>
                     <a:p>
-                      <a:pPr algn="ctr" indent="0" marL="0">
+                      <a:pPr marL="0" indent="0" algn="ctr">
                         <a:buNone/>
                       </a:pPr>
                       <a:r>
@@ -5826,7 +5585,7 @@
                       </a:endParaRPr>
                     </a:p>
                   </a:txBody>
-                  <a:tcPr marL="91440" marR="91440" marT="45720" marB="45720" anchor="ctr">
+                  <a:tcPr anchor="ctr">
                     <a:lnL w="6350" cap="flat" cmpd="sng" algn="ctr">
                       <a:solidFill>
                         <a:srgbClr val="E2E8F0"/>
@@ -5873,7 +5632,7 @@
                     <a:bodyPr/>
                     <a:lstStyle/>
                     <a:p>
-                      <a:pPr algn="ctr" indent="0" marL="0">
+                      <a:pPr marL="0" indent="0" algn="ctr">
                         <a:buNone/>
                       </a:pPr>
                       <a:r>
@@ -5894,7 +5653,7 @@
                       </a:endParaRPr>
                     </a:p>
                   </a:txBody>
-                  <a:tcPr marL="91440" marR="91440" marT="45720" marB="45720" anchor="ctr">
+                  <a:tcPr anchor="ctr">
                     <a:lnL w="6350" cap="flat" cmpd="sng" algn="ctr">
                       <a:solidFill>
                         <a:srgbClr val="E2E8F0"/>
@@ -5941,7 +5700,7 @@
                     <a:bodyPr/>
                     <a:lstStyle/>
                     <a:p>
-                      <a:pPr algn="ctr" indent="0" marL="0">
+                      <a:pPr marL="0" indent="0" algn="ctr">
                         <a:buNone/>
                       </a:pPr>
                       <a:r>
@@ -5962,7 +5721,7 @@
                       </a:endParaRPr>
                     </a:p>
                   </a:txBody>
-                  <a:tcPr marL="91440" marR="91440" marT="45720" marB="45720" anchor="ctr">
+                  <a:tcPr anchor="ctr">
                     <a:lnL w="6350" cap="flat" cmpd="sng" algn="ctr">
                       <a:solidFill>
                         <a:srgbClr val="E2E8F0"/>
@@ -6006,6 +5765,11 @@
                     </a:solidFill>
                   </a:tcPr>
                 </a:tc>
+                <a:extLst>
+                  <a:ext uri="{0D108BD9-81ED-4DB2-BD59-A6C34878D82A}">
+                    <a16:rowId xmlns:a16="http://schemas.microsoft.com/office/drawing/2014/main" val="10002"/>
+                  </a:ext>
+                </a:extLst>
               </a:tr>
               <a:tr h="384048">
                 <a:tc>
@@ -6013,7 +5777,7 @@
                     <a:bodyPr/>
                     <a:lstStyle/>
                     <a:p>
-                      <a:pPr algn="ctr" indent="0" marL="0">
+                      <a:pPr marL="0" indent="0" algn="ctr">
                         <a:buNone/>
                       </a:pPr>
                       <a:r>
@@ -6034,7 +5798,7 @@
                       </a:endParaRPr>
                     </a:p>
                   </a:txBody>
-                  <a:tcPr marL="91440" marR="91440" marT="45720" marB="45720" anchor="ctr">
+                  <a:tcPr anchor="ctr">
                     <a:lnL w="6350" cap="flat" cmpd="sng" algn="ctr">
                       <a:solidFill>
                         <a:srgbClr val="E2E8F0"/>
@@ -6081,7 +5845,7 @@
                     <a:bodyPr/>
                     <a:lstStyle/>
                     <a:p>
-                      <a:pPr algn="ctr" indent="0" marL="0">
+                      <a:pPr marL="0" indent="0" algn="ctr">
                         <a:buNone/>
                       </a:pPr>
                       <a:r>
@@ -6102,7 +5866,7 @@
                       </a:endParaRPr>
                     </a:p>
                   </a:txBody>
-                  <a:tcPr marL="91440" marR="91440" marT="45720" marB="45720" anchor="ctr">
+                  <a:tcPr anchor="ctr">
                     <a:lnL w="6350" cap="flat" cmpd="sng" algn="ctr">
                       <a:solidFill>
                         <a:srgbClr val="E2E8F0"/>
@@ -6149,7 +5913,7 @@
                     <a:bodyPr/>
                     <a:lstStyle/>
                     <a:p>
-                      <a:pPr algn="ctr" indent="0" marL="0">
+                      <a:pPr marL="0" indent="0" algn="ctr">
                         <a:buNone/>
                       </a:pPr>
                       <a:r>
@@ -6170,7 +5934,7 @@
                       </a:endParaRPr>
                     </a:p>
                   </a:txBody>
-                  <a:tcPr marL="91440" marR="91440" marT="45720" marB="45720" anchor="ctr">
+                  <a:tcPr anchor="ctr">
                     <a:lnL w="6350" cap="flat" cmpd="sng" algn="ctr">
                       <a:solidFill>
                         <a:srgbClr val="E2E8F0"/>
@@ -6217,7 +5981,7 @@
                     <a:bodyPr/>
                     <a:lstStyle/>
                     <a:p>
-                      <a:pPr algn="ctr" indent="0" marL="0">
+                      <a:pPr marL="0" indent="0" algn="ctr">
                         <a:buNone/>
                       </a:pPr>
                       <a:r>
@@ -6238,7 +6002,7 @@
                       </a:endParaRPr>
                     </a:p>
                   </a:txBody>
-                  <a:tcPr marL="91440" marR="91440" marT="45720" marB="45720" anchor="ctr">
+                  <a:tcPr anchor="ctr">
                     <a:lnL w="6350" cap="flat" cmpd="sng" algn="ctr">
                       <a:solidFill>
                         <a:srgbClr val="E2E8F0"/>
@@ -6282,6 +6046,11 @@
                     </a:solidFill>
                   </a:tcPr>
                 </a:tc>
+                <a:extLst>
+                  <a:ext uri="{0D108BD9-81ED-4DB2-BD59-A6C34878D82A}">
+                    <a16:rowId xmlns:a16="http://schemas.microsoft.com/office/drawing/2014/main" val="10003"/>
+                  </a:ext>
+                </a:extLst>
               </a:tr>
               <a:tr h="384048">
                 <a:tc>
@@ -6289,7 +6058,7 @@
                     <a:bodyPr/>
                     <a:lstStyle/>
                     <a:p>
-                      <a:pPr algn="ctr" indent="0" marL="0">
+                      <a:pPr marL="0" indent="0" algn="ctr">
                         <a:buNone/>
                       </a:pPr>
                       <a:r>
@@ -6310,7 +6079,7 @@
                       </a:endParaRPr>
                     </a:p>
                   </a:txBody>
-                  <a:tcPr marL="91440" marR="91440" marT="45720" marB="45720" anchor="ctr">
+                  <a:tcPr anchor="ctr">
                     <a:lnL w="6350" cap="flat" cmpd="sng" algn="ctr">
                       <a:solidFill>
                         <a:srgbClr val="E2E8F0"/>
@@ -6357,7 +6126,7 @@
                     <a:bodyPr/>
                     <a:lstStyle/>
                     <a:p>
-                      <a:pPr algn="ctr" indent="0" marL="0">
+                      <a:pPr marL="0" indent="0" algn="ctr">
                         <a:buNone/>
                       </a:pPr>
                       <a:r>
@@ -6378,7 +6147,7 @@
                       </a:endParaRPr>
                     </a:p>
                   </a:txBody>
-                  <a:tcPr marL="91440" marR="91440" marT="45720" marB="45720" anchor="ctr">
+                  <a:tcPr anchor="ctr">
                     <a:lnL w="6350" cap="flat" cmpd="sng" algn="ctr">
                       <a:solidFill>
                         <a:srgbClr val="E2E8F0"/>
@@ -6425,7 +6194,7 @@
                     <a:bodyPr/>
                     <a:lstStyle/>
                     <a:p>
-                      <a:pPr algn="ctr" indent="0" marL="0">
+                      <a:pPr marL="0" indent="0" algn="ctr">
                         <a:buNone/>
                       </a:pPr>
                       <a:r>
@@ -6446,7 +6215,7 @@
                       </a:endParaRPr>
                     </a:p>
                   </a:txBody>
-                  <a:tcPr marL="91440" marR="91440" marT="45720" marB="45720" anchor="ctr">
+                  <a:tcPr anchor="ctr">
                     <a:lnL w="6350" cap="flat" cmpd="sng" algn="ctr">
                       <a:solidFill>
                         <a:srgbClr val="E2E8F0"/>
@@ -6493,7 +6262,7 @@
                     <a:bodyPr/>
                     <a:lstStyle/>
                     <a:p>
-                      <a:pPr algn="ctr" indent="0" marL="0">
+                      <a:pPr marL="0" indent="0" algn="ctr">
                         <a:buNone/>
                       </a:pPr>
                       <a:r>
@@ -6514,7 +6283,7 @@
                       </a:endParaRPr>
                     </a:p>
                   </a:txBody>
-                  <a:tcPr marL="91440" marR="91440" marT="45720" marB="45720" anchor="ctr">
+                  <a:tcPr anchor="ctr">
                     <a:lnL w="6350" cap="flat" cmpd="sng" algn="ctr">
                       <a:solidFill>
                         <a:srgbClr val="E2E8F0"/>
@@ -6558,6 +6327,11 @@
                     </a:solidFill>
                   </a:tcPr>
                 </a:tc>
+                <a:extLst>
+                  <a:ext uri="{0D108BD9-81ED-4DB2-BD59-A6C34878D82A}">
+                    <a16:rowId xmlns:a16="http://schemas.microsoft.com/office/drawing/2014/main" val="10004"/>
+                  </a:ext>
+                </a:extLst>
               </a:tr>
               <a:tr h="384048">
                 <a:tc>
@@ -6565,7 +6339,7 @@
                     <a:bodyPr/>
                     <a:lstStyle/>
                     <a:p>
-                      <a:pPr algn="ctr" indent="0" marL="0">
+                      <a:pPr marL="0" indent="0" algn="ctr">
                         <a:buNone/>
                       </a:pPr>
                       <a:r>
@@ -6586,7 +6360,7 @@
                       </a:endParaRPr>
                     </a:p>
                   </a:txBody>
-                  <a:tcPr marL="91440" marR="91440" marT="45720" marB="45720" anchor="ctr">
+                  <a:tcPr anchor="ctr">
                     <a:lnL w="6350" cap="flat" cmpd="sng" algn="ctr">
                       <a:solidFill>
                         <a:srgbClr val="E2E8F0"/>
@@ -6633,7 +6407,7 @@
                     <a:bodyPr/>
                     <a:lstStyle/>
                     <a:p>
-                      <a:pPr algn="ctr" indent="0" marL="0">
+                      <a:pPr marL="0" indent="0" algn="ctr">
                         <a:buNone/>
                       </a:pPr>
                       <a:r>
@@ -6654,7 +6428,7 @@
                       </a:endParaRPr>
                     </a:p>
                   </a:txBody>
-                  <a:tcPr marL="91440" marR="91440" marT="45720" marB="45720" anchor="ctr">
+                  <a:tcPr anchor="ctr">
                     <a:lnL w="6350" cap="flat" cmpd="sng" algn="ctr">
                       <a:solidFill>
                         <a:srgbClr val="E2E8F0"/>
@@ -6701,7 +6475,7 @@
                     <a:bodyPr/>
                     <a:lstStyle/>
                     <a:p>
-                      <a:pPr algn="ctr" indent="0" marL="0">
+                      <a:pPr marL="0" indent="0" algn="ctr">
                         <a:buNone/>
                       </a:pPr>
                       <a:r>
@@ -6722,7 +6496,7 @@
                       </a:endParaRPr>
                     </a:p>
                   </a:txBody>
-                  <a:tcPr marL="91440" marR="91440" marT="45720" marB="45720" anchor="ctr">
+                  <a:tcPr anchor="ctr">
                     <a:lnL w="6350" cap="flat" cmpd="sng" algn="ctr">
                       <a:solidFill>
                         <a:srgbClr val="E2E8F0"/>
@@ -6769,7 +6543,7 @@
                     <a:bodyPr/>
                     <a:lstStyle/>
                     <a:p>
-                      <a:pPr algn="ctr" indent="0" marL="0">
+                      <a:pPr marL="0" indent="0" algn="ctr">
                         <a:buNone/>
                       </a:pPr>
                       <a:r>
@@ -6790,7 +6564,7 @@
                       </a:endParaRPr>
                     </a:p>
                   </a:txBody>
-                  <a:tcPr marL="91440" marR="91440" marT="45720" marB="45720" anchor="ctr">
+                  <a:tcPr anchor="ctr">
                     <a:lnL w="6350" cap="flat" cmpd="sng" algn="ctr">
                       <a:solidFill>
                         <a:srgbClr val="E2E8F0"/>
@@ -6834,6 +6608,11 @@
                     </a:solidFill>
                   </a:tcPr>
                 </a:tc>
+                <a:extLst>
+                  <a:ext uri="{0D108BD9-81ED-4DB2-BD59-A6C34878D82A}">
+                    <a16:rowId xmlns:a16="http://schemas.microsoft.com/office/drawing/2014/main" val="10005"/>
+                  </a:ext>
+                </a:extLst>
               </a:tr>
               <a:tr h="384048">
                 <a:tc>
@@ -6841,7 +6620,7 @@
                     <a:bodyPr/>
                     <a:lstStyle/>
                     <a:p>
-                      <a:pPr algn="ctr" indent="0" marL="0">
+                      <a:pPr marL="0" indent="0" algn="ctr">
                         <a:buNone/>
                       </a:pPr>
                       <a:r>
@@ -6862,7 +6641,7 @@
                       </a:endParaRPr>
                     </a:p>
                   </a:txBody>
-                  <a:tcPr marL="91440" marR="91440" marT="45720" marB="45720" anchor="ctr">
+                  <a:tcPr anchor="ctr">
                     <a:lnL w="6350" cap="flat" cmpd="sng" algn="ctr">
                       <a:solidFill>
                         <a:srgbClr val="E2E8F0"/>
@@ -6909,7 +6688,7 @@
                     <a:bodyPr/>
                     <a:lstStyle/>
                     <a:p>
-                      <a:pPr algn="ctr" indent="0" marL="0">
+                      <a:pPr marL="0" indent="0" algn="ctr">
                         <a:buNone/>
                       </a:pPr>
                       <a:r>
@@ -6930,7 +6709,7 @@
                       </a:endParaRPr>
                     </a:p>
                   </a:txBody>
-                  <a:tcPr marL="91440" marR="91440" marT="45720" marB="45720" anchor="ctr">
+                  <a:tcPr anchor="ctr">
                     <a:lnL w="6350" cap="flat" cmpd="sng" algn="ctr">
                       <a:solidFill>
                         <a:srgbClr val="E2E8F0"/>
@@ -6977,7 +6756,7 @@
                     <a:bodyPr/>
                     <a:lstStyle/>
                     <a:p>
-                      <a:pPr algn="ctr" indent="0" marL="0">
+                      <a:pPr marL="0" indent="0" algn="ctr">
                         <a:buNone/>
                       </a:pPr>
                       <a:r>
@@ -6998,7 +6777,7 @@
                       </a:endParaRPr>
                     </a:p>
                   </a:txBody>
-                  <a:tcPr marL="91440" marR="91440" marT="45720" marB="45720" anchor="ctr">
+                  <a:tcPr anchor="ctr">
                     <a:lnL w="6350" cap="flat" cmpd="sng" algn="ctr">
                       <a:solidFill>
                         <a:srgbClr val="E2E8F0"/>
@@ -7045,7 +6824,7 @@
                     <a:bodyPr/>
                     <a:lstStyle/>
                     <a:p>
-                      <a:pPr algn="ctr" indent="0" marL="0">
+                      <a:pPr marL="0" indent="0" algn="ctr">
                         <a:buNone/>
                       </a:pPr>
                       <a:r>
@@ -7066,7 +6845,7 @@
                       </a:endParaRPr>
                     </a:p>
                   </a:txBody>
-                  <a:tcPr marL="91440" marR="91440" marT="45720" marB="45720" anchor="ctr">
+                  <a:tcPr anchor="ctr">
                     <a:lnL w="6350" cap="flat" cmpd="sng" algn="ctr">
                       <a:solidFill>
                         <a:srgbClr val="E2E8F0"/>
@@ -7110,6 +6889,11 @@
                     </a:solidFill>
                   </a:tcPr>
                 </a:tc>
+                <a:extLst>
+                  <a:ext uri="{0D108BD9-81ED-4DB2-BD59-A6C34878D82A}">
+                    <a16:rowId xmlns:a16="http://schemas.microsoft.com/office/drawing/2014/main" val="10006"/>
+                  </a:ext>
+                </a:extLst>
               </a:tr>
             </a:tbl>
           </a:graphicData>
@@ -7176,7 +6960,7 @@
           <a:bodyPr wrap="square" lIns="0" tIns="0" rIns="0" bIns="0" rtlCol="0" anchor="ctr"/>
           <a:lstStyle/>
           <a:p>
-            <a:pPr indent="0" marL="0">
+            <a:pPr marL="0" indent="0">
               <a:buNone/>
             </a:pPr>
             <a:r>
@@ -7210,6 +6994,7 @@
         <a:solidFill>
           <a:srgbClr val="F8FAFC"/>
         </a:solidFill>
+        <a:effectLst/>
       </p:bgPr>
     </p:bg>
     <p:spTree>
@@ -7267,7 +7052,7 @@
           <a:bodyPr wrap="square" lIns="0" tIns="0" rIns="0" bIns="0" rtlCol="0" anchor="ctr"/>
           <a:lstStyle/>
           <a:p>
-            <a:pPr indent="0" marL="0">
+            <a:pPr marL="0" indent="0">
               <a:buNone/>
             </a:pPr>
             <a:r>
@@ -7306,7 +7091,7 @@
           <a:bodyPr wrap="square" lIns="0" tIns="0" rIns="0" bIns="0" rtlCol="0" anchor="ctr"/>
           <a:lstStyle/>
           <a:p>
-            <a:pPr indent="0" marL="0">
+            <a:pPr marL="0" indent="0">
               <a:buNone/>
             </a:pPr>
             <a:r>
@@ -7365,7 +7150,7 @@
           <a:bodyPr wrap="square" lIns="0" tIns="0" rIns="0" bIns="0" rtlCol="0" anchor="ctr"/>
           <a:lstStyle/>
           <a:p>
-            <a:pPr algn="ctr" indent="0" marL="0">
+            <a:pPr marL="0" indent="0" algn="ctr">
               <a:buNone/>
             </a:pPr>
             <a:r>
@@ -7424,7 +7209,7 @@
           <a:bodyPr wrap="square" lIns="0" tIns="0" rIns="0" bIns="0" rtlCol="0" anchor="ctr"/>
           <a:lstStyle/>
           <a:p>
-            <a:pPr algn="ctr" indent="0" marL="0">
+            <a:pPr marL="0" indent="0" algn="ctr">
               <a:buNone/>
             </a:pPr>
             <a:r>
@@ -7483,7 +7268,7 @@
           <a:bodyPr wrap="square" lIns="0" tIns="0" rIns="0" bIns="0" rtlCol="0" anchor="ctr"/>
           <a:lstStyle/>
           <a:p>
-            <a:pPr algn="ctr" indent="0" marL="0">
+            <a:pPr marL="0" indent="0" algn="ctr">
               <a:buNone/>
             </a:pPr>
             <a:r>
@@ -7542,7 +7327,7 @@
           <a:bodyPr wrap="square" lIns="0" tIns="0" rIns="0" bIns="0" rtlCol="0" anchor="ctr"/>
           <a:lstStyle/>
           <a:p>
-            <a:pPr algn="ctr" indent="0" marL="0">
+            <a:pPr marL="0" indent="0" algn="ctr">
               <a:buNone/>
             </a:pPr>
             <a:r>
@@ -7581,7 +7366,7 @@
           <a:bodyPr wrap="square" lIns="0" tIns="0" rIns="0" bIns="0" rtlCol="0" anchor="ctr"/>
           <a:lstStyle/>
           <a:p>
-            <a:pPr indent="0" marL="0">
+            <a:pPr marL="0" indent="0">
               <a:buNone/>
             </a:pPr>
             <a:r>
@@ -7640,7 +7425,7 @@
           <a:bodyPr wrap="square" lIns="0" tIns="0" rIns="0" bIns="0" rtlCol="0" anchor="ctr"/>
           <a:lstStyle/>
           <a:p>
-            <a:pPr indent="0" marL="0">
+            <a:pPr marL="0" indent="0">
               <a:buNone/>
             </a:pPr>
             <a:r>
@@ -7699,7 +7484,7 @@
           <a:bodyPr wrap="square" lIns="0" tIns="0" rIns="0" bIns="0" rtlCol="0" anchor="ctr"/>
           <a:lstStyle/>
           <a:p>
-            <a:pPr indent="0" marL="0">
+            <a:pPr marL="0" indent="0">
               <a:buNone/>
             </a:pPr>
             <a:r>
@@ -7758,7 +7543,7 @@
           <a:bodyPr wrap="square" lIns="0" tIns="0" rIns="0" bIns="0" rtlCol="0" anchor="ctr"/>
           <a:lstStyle/>
           <a:p>
-            <a:pPr indent="0" marL="0">
+            <a:pPr marL="0" indent="0">
               <a:buNone/>
             </a:pPr>
             <a:r>
@@ -7792,6 +7577,7 @@
         <a:solidFill>
           <a:srgbClr val="0F172A"/>
         </a:solidFill>
+        <a:effectLst/>
       </p:bgPr>
     </p:bg>
     <p:spTree>
@@ -7873,7 +7659,7 @@
           <a:bodyPr wrap="square" lIns="0" tIns="0" rIns="0" bIns="0" rtlCol="0" anchor="ctr"/>
           <a:lstStyle/>
           <a:p>
-            <a:pPr algn="ctr" indent="0" marL="0">
+            <a:pPr marL="0" indent="0" algn="ctr">
               <a:buNone/>
             </a:pPr>
             <a:r>
@@ -7935,7 +7721,7 @@
           <a:bodyPr wrap="square" lIns="0" tIns="0" rIns="0" bIns="0" rtlCol="0" anchor="ctr"/>
           <a:lstStyle/>
           <a:p>
-            <a:pPr algn="ctr" indent="0" marL="0">
+            <a:pPr marL="0" indent="0" algn="ctr">
               <a:buNone/>
             </a:pPr>
             <a:r>
@@ -7974,7 +7760,7 @@
           <a:bodyPr wrap="square" lIns="0" tIns="0" rIns="0" bIns="0" rtlCol="0" anchor="ctr"/>
           <a:lstStyle/>
           <a:p>
-            <a:pPr algn="ctr" indent="0" marL="0">
+            <a:pPr marL="0" indent="0" algn="ctr">
               <a:buNone/>
             </a:pPr>
             <a:r>
@@ -8008,6 +7794,7 @@
         <a:solidFill>
           <a:srgbClr val="F8FAFC"/>
         </a:solidFill>
+        <a:effectLst/>
       </p:bgPr>
     </p:bg>
     <p:spTree>
@@ -8065,7 +7852,7 @@
           <a:bodyPr wrap="square" lIns="0" tIns="0" rIns="0" bIns="0" rtlCol="0" anchor="ctr"/>
           <a:lstStyle/>
           <a:p>
-            <a:pPr indent="0" marL="0">
+            <a:pPr marL="0" indent="0">
               <a:buNone/>
             </a:pPr>
             <a:r>
@@ -8104,7 +7891,7 @@
           <a:bodyPr wrap="square" lIns="0" tIns="0" rIns="0" bIns="0" rtlCol="0" anchor="ctr"/>
           <a:lstStyle/>
           <a:p>
-            <a:pPr indent="0" marL="0">
+            <a:pPr marL="0" indent="0">
               <a:buNone/>
             </a:pPr>
             <a:r>
@@ -8143,7 +7930,7 @@
           <a:bodyPr wrap="square" rtlCol="0" anchor="t"/>
           <a:lstStyle/>
           <a:p>
-            <a:pPr indent="0" marL="0">
+            <a:pPr marL="0" indent="0">
               <a:buNone/>
             </a:pPr>
             <a:r>
@@ -8160,7 +7947,7 @@
             <a:endParaRPr lang="en-US" sz="2000" dirty="0"/>
           </a:p>
           <a:p>
-            <a:pPr indent="0" marL="0">
+            <a:pPr marL="0" indent="0">
               <a:buNone/>
             </a:pPr>
             <a:r>
@@ -8174,7 +7961,7 @@
             <a:endParaRPr lang="en-US" sz="2000" dirty="0"/>
           </a:p>
           <a:p>
-            <a:pPr indent="0" marL="0">
+            <a:pPr marL="0" indent="0">
               <a:buNone/>
             </a:pPr>
             <a:r>
@@ -8191,7 +7978,7 @@
             <a:endParaRPr lang="en-US" sz="2000" dirty="0"/>
           </a:p>
           <a:p>
-            <a:pPr indent="0" marL="0">
+            <a:pPr marL="0" indent="0">
               <a:buNone/>
             </a:pPr>
             <a:r>
@@ -8208,7 +7995,7 @@
             <a:endParaRPr lang="en-US" sz="2000" dirty="0"/>
           </a:p>
           <a:p>
-            <a:pPr indent="0" marL="0">
+            <a:pPr marL="0" indent="0">
               <a:buNone/>
             </a:pPr>
             <a:r>
@@ -8222,7 +8009,7 @@
             <a:endParaRPr lang="en-US" sz="2000" dirty="0"/>
           </a:p>
           <a:p>
-            <a:pPr indent="0" marL="0">
+            <a:pPr marL="0" indent="0">
               <a:buNone/>
             </a:pPr>
             <a:r>
@@ -8239,7 +8026,7 @@
             <a:endParaRPr lang="en-US" sz="2000" dirty="0"/>
           </a:p>
           <a:p>
-            <a:pPr indent="0" marL="0">
+            <a:pPr marL="0" indent="0">
               <a:buNone/>
             </a:pPr>
             <a:r>
@@ -8327,7 +8114,7 @@
           </a:solidFill>
           <a:ln/>
           <a:effectLst>
-            <a:outerShdw sx="100000" sy="100000" kx="0" ky="0" algn="bl" rotWithShape="0" blurRad="76200" dist="25400" dir="8100000">
+            <a:outerShdw blurRad="76200" dist="25400" dir="8100000" algn="bl" rotWithShape="0">
               <a:srgbClr val="000000">
                 <a:alpha val="10000"/>
               </a:srgbClr>
@@ -8376,7 +8163,7 @@
           <a:bodyPr wrap="square" lIns="0" tIns="0" rIns="0" bIns="0" rtlCol="0" anchor="ctr"/>
           <a:lstStyle/>
           <a:p>
-            <a:pPr indent="0" marL="0">
+            <a:pPr marL="0" indent="0">
               <a:buNone/>
             </a:pPr>
             <a:r>
@@ -8435,7 +8222,7 @@
           <a:bodyPr wrap="square" rtlCol="0" anchor="t"/>
           <a:lstStyle/>
           <a:p>
-            <a:pPr indent="0" marL="0">
+            <a:pPr marL="0" indent="0">
               <a:buNone/>
             </a:pPr>
             <a:r>
@@ -8452,7 +8239,7 @@
             <a:endParaRPr lang="en-US" sz="1000" dirty="0"/>
           </a:p>
           <a:p>
-            <a:pPr indent="0" marL="0">
+            <a:pPr marL="0" indent="0">
               <a:buNone/>
             </a:pPr>
             <a:r>
@@ -8469,7 +8256,7 @@
             <a:endParaRPr lang="en-US" sz="1000" dirty="0"/>
           </a:p>
           <a:p>
-            <a:pPr indent="0" marL="0">
+            <a:pPr marL="0" indent="0">
               <a:buNone/>
             </a:pPr>
             <a:r>
@@ -8483,7 +8270,7 @@
             <a:endParaRPr lang="en-US" sz="1000" dirty="0"/>
           </a:p>
           <a:p>
-            <a:pPr indent="0" marL="0">
+            <a:pPr marL="0" indent="0">
               <a:buNone/>
             </a:pPr>
             <a:r>
@@ -8500,7 +8287,7 @@
             <a:endParaRPr lang="en-US" sz="1000" dirty="0"/>
           </a:p>
           <a:p>
-            <a:pPr indent="0" marL="0">
+            <a:pPr marL="0" indent="0">
               <a:buNone/>
             </a:pPr>
             <a:r>
@@ -8534,6 +8321,7 @@
         <a:solidFill>
           <a:srgbClr val="F8FAFC"/>
         </a:solidFill>
+        <a:effectLst/>
       </p:bgPr>
     </p:bg>
     <p:spTree>
@@ -8591,7 +8379,7 @@
           <a:bodyPr wrap="square" lIns="0" tIns="0" rIns="0" bIns="0" rtlCol="0" anchor="ctr"/>
           <a:lstStyle/>
           <a:p>
-            <a:pPr indent="0" marL="0">
+            <a:pPr marL="0" indent="0">
               <a:buNone/>
             </a:pPr>
             <a:r>
@@ -8630,7 +8418,7 @@
           <a:bodyPr wrap="square" lIns="0" tIns="0" rIns="0" bIns="0" rtlCol="0" anchor="ctr"/>
           <a:lstStyle/>
           <a:p>
-            <a:pPr indent="0" marL="0">
+            <a:pPr marL="0" indent="0">
               <a:buNone/>
             </a:pPr>
             <a:r>
@@ -8667,7 +8455,7 @@
           </a:solidFill>
           <a:ln/>
           <a:effectLst>
-            <a:outerShdw sx="100000" sy="100000" kx="0" ky="0" algn="bl" rotWithShape="0" blurRad="76200" dist="25400" dir="8100000">
+            <a:outerShdw blurRad="76200" dist="25400" dir="8100000" algn="bl" rotWithShape="0">
               <a:srgbClr val="000000">
                 <a:alpha val="10000"/>
               </a:srgbClr>
@@ -8716,7 +8504,7 @@
           <a:bodyPr wrap="square" lIns="0" tIns="0" rIns="0" bIns="0" rtlCol="0" anchor="ctr"/>
           <a:lstStyle/>
           <a:p>
-            <a:pPr indent="0" marL="0">
+            <a:pPr marL="0" indent="0">
               <a:buNone/>
             </a:pPr>
             <a:r>
@@ -8755,7 +8543,7 @@
           <a:bodyPr wrap="square" lIns="0" tIns="0" rIns="0" bIns="0" rtlCol="0" anchor="t"/>
           <a:lstStyle/>
           <a:p>
-            <a:pPr indent="0" marL="0">
+            <a:pPr marL="0" indent="0">
               <a:buNone/>
             </a:pPr>
             <a:r>
@@ -8772,7 +8560,7 @@
             <a:endParaRPr lang="en-US" sz="1300" dirty="0"/>
           </a:p>
           <a:p>
-            <a:pPr indent="0" marL="0">
+            <a:pPr marL="0" indent="0">
               <a:buNone/>
             </a:pPr>
             <a:r>
@@ -8789,7 +8577,7 @@
             <a:endParaRPr lang="en-US" sz="1300" dirty="0"/>
           </a:p>
           <a:p>
-            <a:pPr indent="0" marL="0">
+            <a:pPr marL="0" indent="0">
               <a:buNone/>
             </a:pPr>
             <a:r>
@@ -8826,7 +8614,7 @@
           </a:solidFill>
           <a:ln/>
           <a:effectLst>
-            <a:outerShdw sx="100000" sy="100000" kx="0" ky="0" algn="bl" rotWithShape="0" blurRad="76200" dist="25400" dir="8100000">
+            <a:outerShdw blurRad="76200" dist="25400" dir="8100000" algn="bl" rotWithShape="0">
               <a:srgbClr val="000000">
                 <a:alpha val="10000"/>
               </a:srgbClr>
@@ -8875,7 +8663,7 @@
           <a:bodyPr wrap="square" lIns="0" tIns="0" rIns="0" bIns="0" rtlCol="0" anchor="ctr"/>
           <a:lstStyle/>
           <a:p>
-            <a:pPr indent="0" marL="0">
+            <a:pPr marL="0" indent="0">
               <a:buNone/>
             </a:pPr>
             <a:r>
@@ -8914,7 +8702,7 @@
           <a:bodyPr wrap="square" lIns="0" tIns="0" rIns="0" bIns="0" rtlCol="0" anchor="t"/>
           <a:lstStyle/>
           <a:p>
-            <a:pPr indent="0" marL="0">
+            <a:pPr marL="0" indent="0">
               <a:buNone/>
             </a:pPr>
             <a:r>
@@ -8931,7 +8719,7 @@
             <a:endParaRPr lang="en-US" sz="1300" dirty="0"/>
           </a:p>
           <a:p>
-            <a:pPr indent="0" marL="0">
+            <a:pPr marL="0" indent="0">
               <a:buNone/>
             </a:pPr>
             <a:r>
@@ -8948,7 +8736,7 @@
             <a:endParaRPr lang="en-US" sz="1300" dirty="0"/>
           </a:p>
           <a:p>
-            <a:pPr indent="0" marL="0">
+            <a:pPr marL="0" indent="0">
               <a:buNone/>
             </a:pPr>
             <a:r>
@@ -8985,7 +8773,7 @@
           </a:solidFill>
           <a:ln/>
           <a:effectLst>
-            <a:outerShdw sx="100000" sy="100000" kx="0" ky="0" algn="bl" rotWithShape="0" blurRad="76200" dist="25400" dir="8100000">
+            <a:outerShdw blurRad="76200" dist="25400" dir="8100000" algn="bl" rotWithShape="0">
               <a:srgbClr val="000000">
                 <a:alpha val="10000"/>
               </a:srgbClr>
@@ -9034,7 +8822,7 @@
           <a:bodyPr wrap="square" lIns="0" tIns="0" rIns="0" bIns="0" rtlCol="0" anchor="ctr"/>
           <a:lstStyle/>
           <a:p>
-            <a:pPr indent="0" marL="0">
+            <a:pPr marL="0" indent="0">
               <a:buNone/>
             </a:pPr>
             <a:r>
@@ -9073,7 +8861,7 @@
           <a:bodyPr wrap="square" lIns="0" tIns="0" rIns="0" bIns="0" rtlCol="0" anchor="t"/>
           <a:lstStyle/>
           <a:p>
-            <a:pPr indent="0" marL="0">
+            <a:pPr marL="0" indent="0">
               <a:buNone/>
             </a:pPr>
             <a:r>
@@ -9090,7 +8878,7 @@
             <a:endParaRPr lang="en-US" sz="1300" dirty="0"/>
           </a:p>
           <a:p>
-            <a:pPr indent="0" marL="0">
+            <a:pPr marL="0" indent="0">
               <a:buNone/>
             </a:pPr>
             <a:r>
@@ -9107,7 +8895,7 @@
             <a:endParaRPr lang="en-US" sz="1300" dirty="0"/>
           </a:p>
           <a:p>
-            <a:pPr indent="0" marL="0">
+            <a:pPr marL="0" indent="0">
               <a:buNone/>
             </a:pPr>
             <a:r>
@@ -9146,7 +8934,7 @@
           <a:bodyPr wrap="square" lIns="0" tIns="0" rIns="0" bIns="0" rtlCol="0" anchor="ctr"/>
           <a:lstStyle/>
           <a:p>
-            <a:pPr algn="ctr" indent="0" marL="0">
+            <a:pPr marL="0" indent="0" algn="ctr">
               <a:buNone/>
             </a:pPr>
             <a:r>
@@ -9180,6 +8968,7 @@
         <a:solidFill>
           <a:srgbClr val="0F172A"/>
         </a:solidFill>
+        <a:effectLst/>
       </p:bgPr>
     </p:bg>
     <p:spTree>
@@ -9239,7 +9028,7 @@
           <a:bodyPr wrap="square" lIns="0" tIns="0" rIns="0" bIns="0" rtlCol="0" anchor="ctr"/>
           <a:lstStyle/>
           <a:p>
-            <a:pPr indent="0" marL="0">
+            <a:pPr marL="0" indent="0">
               <a:buNone/>
             </a:pPr>
             <a:r>
@@ -9278,7 +9067,7 @@
           <a:bodyPr wrap="square" lIns="0" tIns="0" rIns="0" bIns="0" rtlCol="0" anchor="ctr"/>
           <a:lstStyle/>
           <a:p>
-            <a:pPr indent="0" marL="0">
+            <a:pPr marL="0" indent="0">
               <a:buNone/>
             </a:pPr>
             <a:r>
@@ -9357,7 +9146,7 @@
           <a:bodyPr wrap="square" lIns="0" tIns="0" rIns="0" bIns="0" rtlCol="0" anchor="ctr"/>
           <a:lstStyle/>
           <a:p>
-            <a:pPr algn="ctr" indent="0" marL="0">
+            <a:pPr marL="0" indent="0" algn="ctr">
               <a:buNone/>
             </a:pPr>
             <a:r>
@@ -9396,7 +9185,7 @@
           <a:bodyPr wrap="square" lIns="0" tIns="0" rIns="0" bIns="0" rtlCol="0" anchor="ctr"/>
           <a:lstStyle/>
           <a:p>
-            <a:pPr algn="ctr" indent="0" marL="0">
+            <a:pPr marL="0" indent="0" algn="ctr">
               <a:buNone/>
             </a:pPr>
             <a:r>
@@ -9435,7 +9224,7 @@
           <a:bodyPr wrap="square" lIns="0" tIns="0" rIns="0" bIns="0" rtlCol="0" anchor="ctr"/>
           <a:lstStyle/>
           <a:p>
-            <a:pPr algn="ctr" indent="0" marL="0">
+            <a:pPr marL="0" indent="0" algn="ctr">
               <a:buNone/>
             </a:pPr>
             <a:r>
@@ -9452,7 +9241,7 @@
             <a:endParaRPr lang="en-US" sz="1200" dirty="0"/>
           </a:p>
           <a:p>
-            <a:pPr algn="ctr" indent="0" marL="0">
+            <a:pPr marL="0" indent="0" algn="ctr">
               <a:buNone/>
             </a:pPr>
             <a:r>
@@ -9491,7 +9280,7 @@
           <a:bodyPr wrap="square" lIns="0" tIns="0" rIns="0" bIns="0" rtlCol="0" anchor="ctr"/>
           <a:lstStyle/>
           <a:p>
-            <a:pPr algn="ctr" indent="0" marL="0">
+            <a:pPr marL="0" indent="0" algn="ctr">
               <a:buNone/>
             </a:pPr>
             <a:r>
@@ -9567,7 +9356,7 @@
           <a:bodyPr wrap="square" lIns="0" tIns="0" rIns="0" bIns="0" rtlCol="0" anchor="ctr"/>
           <a:lstStyle/>
           <a:p>
-            <a:pPr algn="ctr" indent="0" marL="0">
+            <a:pPr marL="0" indent="0" algn="ctr">
               <a:buNone/>
             </a:pPr>
             <a:r>
@@ -9606,7 +9395,7 @@
           <a:bodyPr wrap="square" lIns="0" tIns="0" rIns="0" bIns="0" rtlCol="0" anchor="ctr"/>
           <a:lstStyle/>
           <a:p>
-            <a:pPr algn="ctr" indent="0" marL="0">
+            <a:pPr marL="0" indent="0" algn="ctr">
               <a:buNone/>
             </a:pPr>
             <a:r>
@@ -9645,7 +9434,7 @@
           <a:bodyPr wrap="square" lIns="0" tIns="0" rIns="0" bIns="0" rtlCol="0" anchor="ctr"/>
           <a:lstStyle/>
           <a:p>
-            <a:pPr algn="ctr" indent="0" marL="0">
+            <a:pPr marL="0" indent="0" algn="ctr">
               <a:buNone/>
             </a:pPr>
             <a:r>
@@ -9662,7 +9451,7 @@
             <a:endParaRPr lang="en-US" sz="1200" dirty="0"/>
           </a:p>
           <a:p>
-            <a:pPr algn="ctr" indent="0" marL="0">
+            <a:pPr marL="0" indent="0" algn="ctr">
               <a:buNone/>
             </a:pPr>
             <a:r>
@@ -9701,7 +9490,7 @@
           <a:bodyPr wrap="square" lIns="0" tIns="0" rIns="0" bIns="0" rtlCol="0" anchor="ctr"/>
           <a:lstStyle/>
           <a:p>
-            <a:pPr algn="ctr" indent="0" marL="0">
+            <a:pPr marL="0" indent="0" algn="ctr">
               <a:buNone/>
             </a:pPr>
             <a:r>
@@ -9779,7 +9568,7 @@
           <a:bodyPr wrap="square" lIns="0" tIns="0" rIns="0" bIns="0" rtlCol="0" anchor="ctr"/>
           <a:lstStyle/>
           <a:p>
-            <a:pPr algn="ctr" indent="0" marL="0">
+            <a:pPr marL="0" indent="0" algn="ctr">
               <a:buNone/>
             </a:pPr>
             <a:r>
@@ -9818,7 +9607,7 @@
           <a:bodyPr wrap="square" lIns="0" tIns="0" rIns="0" bIns="0" rtlCol="0" anchor="ctr"/>
           <a:lstStyle/>
           <a:p>
-            <a:pPr algn="ctr" indent="0" marL="0">
+            <a:pPr marL="0" indent="0" algn="ctr">
               <a:buNone/>
             </a:pPr>
             <a:r>
@@ -9857,7 +9646,7 @@
           <a:bodyPr wrap="square" lIns="0" tIns="0" rIns="0" bIns="0" rtlCol="0" anchor="ctr"/>
           <a:lstStyle/>
           <a:p>
-            <a:pPr algn="ctr" indent="0" marL="0">
+            <a:pPr marL="0" indent="0" algn="ctr">
               <a:buNone/>
             </a:pPr>
             <a:r>
@@ -9874,7 +9663,7 @@
             <a:endParaRPr lang="en-US" sz="1200" dirty="0"/>
           </a:p>
           <a:p>
-            <a:pPr algn="ctr" indent="0" marL="0">
+            <a:pPr marL="0" indent="0" algn="ctr">
               <a:buNone/>
             </a:pPr>
             <a:r>
@@ -9913,7 +9702,7 @@
           <a:bodyPr wrap="square" lIns="0" tIns="0" rIns="0" bIns="0" rtlCol="0" anchor="ctr"/>
           <a:lstStyle/>
           <a:p>
-            <a:pPr algn="ctr" indent="0" marL="0">
+            <a:pPr marL="0" indent="0" algn="ctr">
               <a:buNone/>
             </a:pPr>
             <a:r>
@@ -9947,6 +9736,7 @@
         <a:solidFill>
           <a:srgbClr val="F8FAFC"/>
         </a:solidFill>
+        <a:effectLst/>
       </p:bgPr>
     </p:bg>
     <p:spTree>
@@ -10004,11 +9794,11 @@
           <a:bodyPr wrap="square" lIns="0" tIns="0" rIns="0" bIns="0" rtlCol="0" anchor="ctr"/>
           <a:lstStyle/>
           <a:p>
-            <a:pPr indent="0" marL="0">
-              <a:buNone/>
-            </a:pPr>
-            <a:r>
-              <a:rPr lang="en-US" sz="3600" dirty="0">
+            <a:pPr marL="0" indent="0">
+              <a:buNone/>
+            </a:pPr>
+            <a:r>
+              <a:rPr lang="en-US" sz="2800" dirty="0">
                 <a:solidFill>
                   <a:srgbClr val="1E293B"/>
                 </a:solidFill>
@@ -10018,7 +9808,7 @@
               </a:rPr>
               <a:t>Rules — Project-Level Instructions</a:t>
             </a:r>
-            <a:endParaRPr lang="en-US" sz="3600" dirty="0"/>
+            <a:endParaRPr lang="en-US" sz="2800" dirty="0"/>
           </a:p>
         </p:txBody>
       </p:sp>
@@ -10030,7 +9820,7 @@
         </p:nvSpPr>
         <p:spPr>
           <a:xfrm>
-            <a:off x="640080" y="868680"/>
+            <a:off x="640080" y="1097280"/>
             <a:ext cx="7315200" cy="320040"/>
           </a:xfrm>
           <a:prstGeom prst="rect">
@@ -10043,7 +9833,7 @@
           <a:bodyPr wrap="square" lIns="0" tIns="0" rIns="0" bIns="0" rtlCol="0" anchor="ctr"/>
           <a:lstStyle/>
           <a:p>
-            <a:pPr indent="0" marL="0">
+            <a:pPr marL="0" indent="0">
               <a:buNone/>
             </a:pPr>
             <a:r>
@@ -10080,7 +9870,7 @@
           </a:solidFill>
           <a:ln/>
           <a:effectLst>
-            <a:outerShdw sx="100000" sy="100000" kx="0" ky="0" algn="bl" rotWithShape="0" blurRad="38100" dist="12700" dir="8100000">
+            <a:outerShdw blurRad="38100" dist="12700" dir="8100000" algn="bl" rotWithShape="0">
               <a:srgbClr val="000000">
                 <a:alpha val="6000"/>
               </a:srgbClr>
@@ -10129,7 +9919,7 @@
           <a:bodyPr wrap="square" lIns="0" tIns="0" rIns="0" bIns="0" rtlCol="0" anchor="ctr"/>
           <a:lstStyle/>
           <a:p>
-            <a:pPr indent="0" marL="0">
+            <a:pPr marL="0" indent="0">
               <a:buNone/>
             </a:pPr>
             <a:r>
@@ -10168,7 +9958,7 @@
           <a:bodyPr wrap="square" lIns="0" tIns="0" rIns="0" bIns="0" rtlCol="0" anchor="ctr"/>
           <a:lstStyle/>
           <a:p>
-            <a:pPr indent="0" marL="0">
+            <a:pPr marL="0" indent="0">
               <a:buNone/>
             </a:pPr>
             <a:r>
@@ -10185,7 +9975,7 @@
             <a:endParaRPr lang="en-US" sz="1300" dirty="0"/>
           </a:p>
           <a:p>
-            <a:pPr indent="0" marL="0">
+            <a:pPr marL="0" indent="0">
               <a:buNone/>
             </a:pPr>
             <a:r>
@@ -10222,7 +10012,7 @@
           </a:solidFill>
           <a:ln/>
           <a:effectLst>
-            <a:outerShdw sx="100000" sy="100000" kx="0" ky="0" algn="bl" rotWithShape="0" blurRad="38100" dist="12700" dir="8100000">
+            <a:outerShdw blurRad="38100" dist="12700" dir="8100000" algn="bl" rotWithShape="0">
               <a:srgbClr val="000000">
                 <a:alpha val="6000"/>
               </a:srgbClr>
@@ -10271,7 +10061,7 @@
           <a:bodyPr wrap="square" lIns="0" tIns="0" rIns="0" bIns="0" rtlCol="0" anchor="ctr"/>
           <a:lstStyle/>
           <a:p>
-            <a:pPr indent="0" marL="0">
+            <a:pPr marL="0" indent="0">
               <a:buNone/>
             </a:pPr>
             <a:r>
@@ -10310,7 +10100,7 @@
           <a:bodyPr wrap="square" lIns="0" tIns="0" rIns="0" bIns="0" rtlCol="0" anchor="ctr"/>
           <a:lstStyle/>
           <a:p>
-            <a:pPr indent="0" marL="0">
+            <a:pPr marL="0" indent="0">
               <a:buNone/>
             </a:pPr>
             <a:r>
@@ -10327,7 +10117,7 @@
             <a:endParaRPr lang="en-US" sz="1300" dirty="0"/>
           </a:p>
           <a:p>
-            <a:pPr indent="0" marL="0">
+            <a:pPr marL="0" indent="0">
               <a:buNone/>
             </a:pPr>
             <a:r>
@@ -10364,7 +10154,7 @@
           </a:solidFill>
           <a:ln/>
           <a:effectLst>
-            <a:outerShdw sx="100000" sy="100000" kx="0" ky="0" algn="bl" rotWithShape="0" blurRad="38100" dist="12700" dir="8100000">
+            <a:outerShdw blurRad="38100" dist="12700" dir="8100000" algn="bl" rotWithShape="0">
               <a:srgbClr val="000000">
                 <a:alpha val="6000"/>
               </a:srgbClr>
@@ -10413,7 +10203,7 @@
           <a:bodyPr wrap="square" lIns="0" tIns="0" rIns="0" bIns="0" rtlCol="0" anchor="ctr"/>
           <a:lstStyle/>
           <a:p>
-            <a:pPr indent="0" marL="0">
+            <a:pPr marL="0" indent="0">
               <a:buNone/>
             </a:pPr>
             <a:r>
@@ -10452,7 +10242,7 @@
           <a:bodyPr wrap="square" lIns="0" tIns="0" rIns="0" bIns="0" rtlCol="0" anchor="ctr"/>
           <a:lstStyle/>
           <a:p>
-            <a:pPr indent="0" marL="0">
+            <a:pPr marL="0" indent="0">
               <a:buNone/>
             </a:pPr>
             <a:r>
@@ -10469,7 +10259,7 @@
             <a:endParaRPr lang="en-US" sz="1300" dirty="0"/>
           </a:p>
           <a:p>
-            <a:pPr indent="0" marL="0">
+            <a:pPr marL="0" indent="0">
               <a:buNone/>
             </a:pPr>
             <a:r>
@@ -10528,7 +10318,7 @@
           <a:bodyPr wrap="square" rtlCol="0" anchor="t"/>
           <a:lstStyle/>
           <a:p>
-            <a:pPr indent="0" marL="0">
+            <a:pPr marL="0" indent="0">
               <a:buNone/>
             </a:pPr>
             <a:r>
@@ -10545,7 +10335,7 @@
             <a:endParaRPr lang="en-US" sz="1100" dirty="0"/>
           </a:p>
           <a:p>
-            <a:pPr indent="0" marL="0">
+            <a:pPr marL="0" indent="0">
               <a:buNone/>
             </a:pPr>
             <a:r>
@@ -10559,7 +10349,7 @@
             <a:endParaRPr lang="en-US" sz="1100" dirty="0"/>
           </a:p>
           <a:p>
-            <a:pPr indent="0" marL="0">
+            <a:pPr marL="0" indent="0">
               <a:buNone/>
             </a:pPr>
             <a:r>
@@ -10576,7 +10366,7 @@
             <a:endParaRPr lang="en-US" sz="1100" dirty="0"/>
           </a:p>
           <a:p>
-            <a:pPr indent="0" marL="0">
+            <a:pPr marL="0" indent="0">
               <a:buNone/>
             </a:pPr>
             <a:r>
@@ -10593,7 +10383,7 @@
             <a:endParaRPr lang="en-US" sz="1100" dirty="0"/>
           </a:p>
           <a:p>
-            <a:pPr indent="0" marL="0">
+            <a:pPr marL="0" indent="0">
               <a:buNone/>
             </a:pPr>
             <a:r>
@@ -10610,7 +10400,7 @@
             <a:endParaRPr lang="en-US" sz="1100" dirty="0"/>
           </a:p>
           <a:p>
-            <a:pPr indent="0" marL="0">
+            <a:pPr marL="0" indent="0">
               <a:buNone/>
             </a:pPr>
             <a:r>
@@ -10624,7 +10414,7 @@
             <a:endParaRPr lang="en-US" sz="1100" dirty="0"/>
           </a:p>
           <a:p>
-            <a:pPr indent="0" marL="0">
+            <a:pPr marL="0" indent="0">
               <a:buNone/>
             </a:pPr>
             <a:r>
@@ -10641,7 +10431,7 @@
             <a:endParaRPr lang="en-US" sz="1100" dirty="0"/>
           </a:p>
           <a:p>
-            <a:pPr indent="0" marL="0">
+            <a:pPr marL="0" indent="0">
               <a:buNone/>
             </a:pPr>
             <a:r>
@@ -10658,7 +10448,7 @@
             <a:endParaRPr lang="en-US" sz="1100" dirty="0"/>
           </a:p>
           <a:p>
-            <a:pPr indent="0" marL="0">
+            <a:pPr marL="0" indent="0">
               <a:buNone/>
             </a:pPr>
             <a:r>
@@ -10675,7 +10465,7 @@
             <a:endParaRPr lang="en-US" sz="1100" dirty="0"/>
           </a:p>
           <a:p>
-            <a:pPr indent="0" marL="0">
+            <a:pPr marL="0" indent="0">
               <a:buNone/>
             </a:pPr>
             <a:r>
@@ -10689,7 +10479,7 @@
             <a:endParaRPr lang="en-US" sz="1100" dirty="0"/>
           </a:p>
           <a:p>
-            <a:pPr indent="0" marL="0">
+            <a:pPr marL="0" indent="0">
               <a:buNone/>
             </a:pPr>
             <a:r>
@@ -10706,7 +10496,7 @@
             <a:endParaRPr lang="en-US" sz="1100" dirty="0"/>
           </a:p>
           <a:p>
-            <a:pPr indent="0" marL="0">
+            <a:pPr marL="0" indent="0">
               <a:buNone/>
             </a:pPr>
             <a:r>
@@ -10723,7 +10513,7 @@
             <a:endParaRPr lang="en-US" sz="1100" dirty="0"/>
           </a:p>
           <a:p>
-            <a:pPr indent="0" marL="0">
+            <a:pPr marL="0" indent="0">
               <a:buNone/>
             </a:pPr>
             <a:r>
@@ -10737,7 +10527,7 @@
             <a:endParaRPr lang="en-US" sz="1100" dirty="0"/>
           </a:p>
           <a:p>
-            <a:pPr indent="0" marL="0">
+            <a:pPr marL="0" indent="0">
               <a:buNone/>
             </a:pPr>
             <a:r>
@@ -10754,7 +10544,7 @@
             <a:endParaRPr lang="en-US" sz="1100" dirty="0"/>
           </a:p>
           <a:p>
-            <a:pPr indent="0" marL="0">
+            <a:pPr marL="0" indent="0">
               <a:buNone/>
             </a:pPr>
             <a:r>
@@ -10771,7 +10561,7 @@
             <a:endParaRPr lang="en-US" sz="1100" dirty="0"/>
           </a:p>
           <a:p>
-            <a:pPr indent="0" marL="0">
+            <a:pPr marL="0" indent="0">
               <a:buNone/>
             </a:pPr>
             <a:r>
@@ -10805,6 +10595,7 @@
         <a:solidFill>
           <a:srgbClr val="F8FAFC"/>
         </a:solidFill>
+        <a:effectLst/>
       </p:bgPr>
     </p:bg>
     <p:spTree>
@@ -10862,7 +10653,7 @@
           <a:bodyPr wrap="square" lIns="0" tIns="0" rIns="0" bIns="0" rtlCol="0" anchor="ctr"/>
           <a:lstStyle/>
           <a:p>
-            <a:pPr indent="0" marL="0">
+            <a:pPr marL="0" indent="0">
               <a:buNone/>
             </a:pPr>
             <a:r>
@@ -10921,7 +10712,7 @@
           <a:bodyPr wrap="square" lIns="0" tIns="0" rIns="0" bIns="0" rtlCol="0" anchor="ctr"/>
           <a:lstStyle/>
           <a:p>
-            <a:pPr algn="ctr" indent="0" marL="0">
+            <a:pPr marL="0" indent="0" algn="ctr">
               <a:buNone/>
             </a:pPr>
             <a:r>
@@ -10960,7 +10751,7 @@
           <a:bodyPr wrap="square" lIns="0" tIns="0" rIns="0" bIns="0" rtlCol="0" anchor="ctr"/>
           <a:lstStyle/>
           <a:p>
-            <a:pPr indent="0" marL="0">
+            <a:pPr marL="0" indent="0">
               <a:buNone/>
             </a:pPr>
             <a:r>
@@ -10977,7 +10768,7 @@
             <a:endParaRPr lang="en-US" sz="1400" dirty="0"/>
           </a:p>
           <a:p>
-            <a:pPr indent="0" marL="0">
+            <a:pPr marL="0" indent="0">
               <a:buNone/>
             </a:pPr>
             <a:r>
@@ -11059,7 +10850,7 @@
           <a:bodyPr wrap="square" lIns="0" tIns="0" rIns="0" bIns="0" rtlCol="0" anchor="ctr"/>
           <a:lstStyle/>
           <a:p>
-            <a:pPr algn="ctr" indent="0" marL="0">
+            <a:pPr marL="0" indent="0" algn="ctr">
               <a:buNone/>
             </a:pPr>
             <a:r>
@@ -11098,7 +10889,7 @@
           <a:bodyPr wrap="square" lIns="0" tIns="0" rIns="0" bIns="0" rtlCol="0" anchor="ctr"/>
           <a:lstStyle/>
           <a:p>
-            <a:pPr indent="0" marL="0">
+            <a:pPr marL="0" indent="0">
               <a:buNone/>
             </a:pPr>
             <a:r>
@@ -11115,7 +10906,7 @@
             <a:endParaRPr lang="en-US" sz="1400" dirty="0"/>
           </a:p>
           <a:p>
-            <a:pPr indent="0" marL="0">
+            <a:pPr marL="0" indent="0">
               <a:buNone/>
             </a:pPr>
             <a:r>
@@ -11197,7 +10988,7 @@
           <a:bodyPr wrap="square" lIns="0" tIns="0" rIns="0" bIns="0" rtlCol="0" anchor="ctr"/>
           <a:lstStyle/>
           <a:p>
-            <a:pPr algn="ctr" indent="0" marL="0">
+            <a:pPr marL="0" indent="0" algn="ctr">
               <a:buNone/>
             </a:pPr>
             <a:r>
@@ -11236,7 +11027,7 @@
           <a:bodyPr wrap="square" lIns="0" tIns="0" rIns="0" bIns="0" rtlCol="0" anchor="ctr"/>
           <a:lstStyle/>
           <a:p>
-            <a:pPr indent="0" marL="0">
+            <a:pPr marL="0" indent="0">
               <a:buNone/>
             </a:pPr>
             <a:r>
@@ -11253,7 +11044,7 @@
             <a:endParaRPr lang="en-US" sz="1400" dirty="0"/>
           </a:p>
           <a:p>
-            <a:pPr indent="0" marL="0">
+            <a:pPr marL="0" indent="0">
               <a:buNone/>
             </a:pPr>
             <a:r>
@@ -11335,7 +11126,7 @@
           <a:bodyPr wrap="square" lIns="0" tIns="0" rIns="0" bIns="0" rtlCol="0" anchor="ctr"/>
           <a:lstStyle/>
           <a:p>
-            <a:pPr algn="ctr" indent="0" marL="0">
+            <a:pPr marL="0" indent="0" algn="ctr">
               <a:buNone/>
             </a:pPr>
             <a:r>
@@ -11374,7 +11165,7 @@
           <a:bodyPr wrap="square" lIns="0" tIns="0" rIns="0" bIns="0" rtlCol="0" anchor="ctr"/>
           <a:lstStyle/>
           <a:p>
-            <a:pPr indent="0" marL="0">
+            <a:pPr marL="0" indent="0">
               <a:buNone/>
             </a:pPr>
             <a:r>
@@ -11391,7 +11182,7 @@
             <a:endParaRPr lang="en-US" sz="1400" dirty="0"/>
           </a:p>
           <a:p>
-            <a:pPr indent="0" marL="0">
+            <a:pPr marL="0" indent="0">
               <a:buNone/>
             </a:pPr>
             <a:r>
@@ -11470,7 +11261,7 @@
           <a:bodyPr wrap="square" lIns="0" tIns="0" rIns="0" bIns="0" rtlCol="0" anchor="ctr"/>
           <a:lstStyle/>
           <a:p>
-            <a:pPr indent="0" marL="0">
+            <a:pPr marL="0" indent="0">
               <a:buNone/>
             </a:pPr>
             <a:r>
@@ -11509,7 +11300,7 @@
           <a:bodyPr wrap="square" lIns="0" tIns="0" rIns="0" bIns="0" rtlCol="0" anchor="ctr"/>
           <a:lstStyle/>
           <a:p>
-            <a:pPr indent="0" marL="0">
+            <a:pPr marL="0" indent="0">
               <a:buNone/>
             </a:pPr>
             <a:r>
@@ -11526,7 +11317,7 @@
             <a:endParaRPr lang="en-US" sz="1100" dirty="0"/>
           </a:p>
           <a:p>
-            <a:pPr indent="0" marL="0">
+            <a:pPr marL="0" indent="0">
               <a:buNone/>
             </a:pPr>
             <a:r>
@@ -11605,7 +11396,7 @@
           <a:bodyPr wrap="square" lIns="0" tIns="0" rIns="0" bIns="0" rtlCol="0" anchor="ctr"/>
           <a:lstStyle/>
           <a:p>
-            <a:pPr indent="0" marL="0">
+            <a:pPr marL="0" indent="0">
               <a:buNone/>
             </a:pPr>
             <a:r>
@@ -11644,7 +11435,7 @@
           <a:bodyPr wrap="square" lIns="0" tIns="0" rIns="0" bIns="0" rtlCol="0" anchor="ctr"/>
           <a:lstStyle/>
           <a:p>
-            <a:pPr indent="0" marL="0">
+            <a:pPr marL="0" indent="0">
               <a:buNone/>
             </a:pPr>
             <a:r>
@@ -11661,7 +11452,7 @@
             <a:endParaRPr lang="en-US" sz="1100" dirty="0"/>
           </a:p>
           <a:p>
-            <a:pPr indent="0" marL="0">
+            <a:pPr marL="0" indent="0">
               <a:buNone/>
             </a:pPr>
             <a:r>
@@ -11700,7 +11491,7 @@
           <a:bodyPr wrap="square" lIns="0" tIns="0" rIns="0" bIns="0" rtlCol="0" anchor="ctr"/>
           <a:lstStyle/>
           <a:p>
-            <a:pPr indent="0" marL="0">
+            <a:pPr marL="0" indent="0">
               <a:buNone/>
             </a:pPr>
             <a:r>
@@ -11734,6 +11525,7 @@
         <a:solidFill>
           <a:srgbClr val="F8FAFC"/>
         </a:solidFill>
+        <a:effectLst/>
       </p:bgPr>
     </p:bg>
     <p:spTree>
@@ -11791,7 +11583,7 @@
           <a:bodyPr wrap="square" lIns="0" tIns="0" rIns="0" bIns="0" rtlCol="0" anchor="ctr"/>
           <a:lstStyle/>
           <a:p>
-            <a:pPr indent="0" marL="0">
+            <a:pPr marL="0" indent="0">
               <a:buNone/>
             </a:pPr>
             <a:r>
@@ -11830,7 +11622,7 @@
           <a:bodyPr wrap="square" lIns="0" tIns="0" rIns="0" bIns="0" rtlCol="0" anchor="ctr"/>
           <a:lstStyle/>
           <a:p>
-            <a:pPr indent="0" marL="0">
+            <a:pPr marL="0" indent="0">
               <a:buNone/>
             </a:pPr>
             <a:r>
@@ -11867,7 +11659,7 @@
           </a:solidFill>
           <a:ln/>
           <a:effectLst>
-            <a:outerShdw sx="100000" sy="100000" kx="0" ky="0" algn="bl" rotWithShape="0" blurRad="76200" dist="25400" dir="8100000">
+            <a:outerShdw blurRad="76200" dist="25400" dir="8100000" algn="bl" rotWithShape="0">
               <a:srgbClr val="000000">
                 <a:alpha val="10000"/>
               </a:srgbClr>
@@ -11896,7 +11688,7 @@
           <a:bodyPr wrap="square" lIns="0" tIns="0" rIns="0" bIns="0" rtlCol="0" anchor="ctr"/>
           <a:lstStyle/>
           <a:p>
-            <a:pPr indent="0" marL="0">
+            <a:pPr marL="0" indent="0">
               <a:buNone/>
             </a:pPr>
             <a:r>
@@ -11955,7 +11747,7 @@
           <a:bodyPr wrap="square" lIns="0" tIns="0" rIns="0" bIns="0" rtlCol="0" anchor="ctr"/>
           <a:lstStyle/>
           <a:p>
-            <a:pPr indent="0" marL="0">
+            <a:pPr marL="0" indent="0">
               <a:buNone/>
             </a:pPr>
             <a:r>
@@ -11994,7 +11786,7 @@
           <a:bodyPr wrap="square" lIns="0" tIns="0" rIns="0" bIns="0" rtlCol="0" anchor="ctr"/>
           <a:lstStyle/>
           <a:p>
-            <a:pPr indent="0" marL="0">
+            <a:pPr marL="0" indent="0">
               <a:buNone/>
             </a:pPr>
             <a:r>
@@ -12053,7 +11845,7 @@
           <a:bodyPr wrap="square" lIns="0" tIns="0" rIns="0" bIns="0" rtlCol="0" anchor="ctr"/>
           <a:lstStyle/>
           <a:p>
-            <a:pPr indent="0" marL="0">
+            <a:pPr marL="0" indent="0">
               <a:buNone/>
             </a:pPr>
             <a:r>
@@ -12092,7 +11884,7 @@
           <a:bodyPr wrap="square" lIns="0" tIns="0" rIns="0" bIns="0" rtlCol="0" anchor="ctr"/>
           <a:lstStyle/>
           <a:p>
-            <a:pPr indent="0" marL="0">
+            <a:pPr marL="0" indent="0">
               <a:buNone/>
             </a:pPr>
             <a:r>
@@ -12151,7 +11943,7 @@
           <a:bodyPr wrap="square" lIns="0" tIns="0" rIns="0" bIns="0" rtlCol="0" anchor="ctr"/>
           <a:lstStyle/>
           <a:p>
-            <a:pPr indent="0" marL="0">
+            <a:pPr marL="0" indent="0">
               <a:buNone/>
             </a:pPr>
             <a:r>
@@ -12190,7 +11982,7 @@
           <a:bodyPr wrap="square" lIns="0" tIns="0" rIns="0" bIns="0" rtlCol="0" anchor="ctr"/>
           <a:lstStyle/>
           <a:p>
-            <a:pPr indent="0" marL="0">
+            <a:pPr marL="0" indent="0">
               <a:buNone/>
             </a:pPr>
             <a:r>
@@ -12249,7 +12041,7 @@
           <a:bodyPr wrap="square" lIns="0" tIns="0" rIns="0" bIns="0" rtlCol="0" anchor="ctr"/>
           <a:lstStyle/>
           <a:p>
-            <a:pPr indent="0" marL="0">
+            <a:pPr marL="0" indent="0">
               <a:buNone/>
             </a:pPr>
             <a:r>
@@ -12288,7 +12080,7 @@
           <a:bodyPr wrap="square" lIns="0" tIns="0" rIns="0" bIns="0" rtlCol="0" anchor="ctr"/>
           <a:lstStyle/>
           <a:p>
-            <a:pPr indent="0" marL="0">
+            <a:pPr marL="0" indent="0">
               <a:buNone/>
             </a:pPr>
             <a:r>
@@ -12327,7 +12119,7 @@
           <a:bodyPr wrap="square" lIns="0" tIns="0" rIns="0" bIns="0" rtlCol="0" anchor="ctr"/>
           <a:lstStyle/>
           <a:p>
-            <a:pPr indent="0" marL="0">
+            <a:pPr marL="0" indent="0">
               <a:buNone/>
             </a:pPr>
             <a:r>
@@ -12406,7 +12198,7 @@
           <a:bodyPr wrap="square" rtlCol="0" anchor="ctr"/>
           <a:lstStyle/>
           <a:p>
-            <a:pPr indent="0" marL="0">
+            <a:pPr marL="0" indent="0">
               <a:buNone/>
             </a:pPr>
             <a:r>
@@ -12423,7 +12215,7 @@
             <a:endParaRPr lang="en-US" sz="1300" dirty="0"/>
           </a:p>
           <a:p>
-            <a:pPr indent="0" marL="0">
+            <a:pPr marL="0" indent="0">
               <a:buNone/>
             </a:pPr>
             <a:r>
@@ -12440,7 +12232,7 @@
             <a:endParaRPr lang="en-US" sz="1300" dirty="0"/>
           </a:p>
           <a:p>
-            <a:pPr indent="0" marL="0">
+            <a:pPr marL="0" indent="0">
               <a:buNone/>
             </a:pPr>
             <a:r>
@@ -12477,7 +12269,7 @@
           </a:solidFill>
           <a:ln/>
           <a:effectLst>
-            <a:outerShdw sx="100000" sy="100000" kx="0" ky="0" algn="bl" rotWithShape="0" blurRad="76200" dist="25400" dir="8100000">
+            <a:outerShdw blurRad="76200" dist="25400" dir="8100000" algn="bl" rotWithShape="0">
               <a:srgbClr val="000000">
                 <a:alpha val="10000"/>
               </a:srgbClr>
@@ -12526,7 +12318,7 @@
           <a:bodyPr wrap="square" rtlCol="0" anchor="ctr"/>
           <a:lstStyle/>
           <a:p>
-            <a:pPr indent="0" marL="0">
+            <a:pPr marL="0" indent="0">
               <a:buNone/>
             </a:pPr>
             <a:r>
@@ -12543,7 +12335,7 @@
             <a:endParaRPr lang="en-US" sz="1300" dirty="0"/>
           </a:p>
           <a:p>
-            <a:pPr indent="0" marL="0">
+            <a:pPr marL="0" indent="0">
               <a:buNone/>
             </a:pPr>
             <a:r>
@@ -12560,7 +12352,7 @@
             <a:endParaRPr lang="en-US" sz="1300" dirty="0"/>
           </a:p>
           <a:p>
-            <a:pPr indent="0" marL="0">
+            <a:pPr marL="0" indent="0">
               <a:buNone/>
             </a:pPr>
             <a:r>
@@ -12577,7 +12369,7 @@
             <a:endParaRPr lang="en-US" sz="1300" dirty="0"/>
           </a:p>
           <a:p>
-            <a:pPr indent="0" marL="0">
+            <a:pPr marL="0" indent="0">
               <a:buNone/>
             </a:pPr>
             <a:r>
@@ -12611,6 +12403,7 @@
         <a:solidFill>
           <a:srgbClr val="F8FAFC"/>
         </a:solidFill>
+        <a:effectLst/>
       </p:bgPr>
     </p:bg>
     <p:spTree>
@@ -12655,8 +12448,8 @@
         </p:nvSpPr>
         <p:spPr>
           <a:xfrm>
-            <a:off x="640080" y="320040"/>
-            <a:ext cx="7315200" cy="502920"/>
+            <a:off x="274320" y="320040"/>
+            <a:ext cx="8232518" cy="502920"/>
           </a:xfrm>
           <a:prstGeom prst="rect">
             <a:avLst/>
@@ -12668,7 +12461,7 @@
           <a:bodyPr wrap="square" lIns="0" tIns="0" rIns="0" bIns="0" rtlCol="0" anchor="ctr"/>
           <a:lstStyle/>
           <a:p>
-            <a:pPr indent="0" marL="0">
+            <a:pPr marL="0" indent="0">
               <a:buNone/>
             </a:pPr>
             <a:r>
@@ -12705,7 +12498,7 @@
           </a:solidFill>
           <a:ln/>
           <a:effectLst>
-            <a:outerShdw sx="100000" sy="100000" kx="0" ky="0" algn="bl" rotWithShape="0" blurRad="76200" dist="25400" dir="8100000">
+            <a:outerShdw blurRad="76200" dist="25400" dir="8100000" algn="bl" rotWithShape="0">
               <a:srgbClr val="000000">
                 <a:alpha val="10000"/>
               </a:srgbClr>
@@ -12754,7 +12547,7 @@
           <a:bodyPr wrap="square" lIns="0" tIns="0" rIns="0" bIns="0" rtlCol="0" anchor="ctr"/>
           <a:lstStyle/>
           <a:p>
-            <a:pPr indent="0" marL="0">
+            <a:pPr marL="0" indent="0">
               <a:buNone/>
             </a:pPr>
             <a:r>
@@ -12816,7 +12609,7 @@
           <a:bodyPr wrap="square" lIns="0" tIns="0" rIns="0" bIns="0" rtlCol="0" anchor="t"/>
           <a:lstStyle/>
           <a:p>
-            <a:pPr indent="0" marL="0">
+            <a:pPr marL="0" indent="0">
               <a:buNone/>
             </a:pPr>
             <a:r>
@@ -12833,7 +12626,7 @@
             <a:endParaRPr lang="en-US" sz="1300" dirty="0"/>
           </a:p>
           <a:p>
-            <a:pPr indent="0" marL="0">
+            <a:pPr marL="0" indent="0">
               <a:buNone/>
             </a:pPr>
             <a:r>
@@ -12850,7 +12643,7 @@
             <a:endParaRPr lang="en-US" sz="1300" dirty="0"/>
           </a:p>
           <a:p>
-            <a:pPr indent="0" marL="0">
+            <a:pPr marL="0" indent="0">
               <a:buNone/>
             </a:pPr>
             <a:r>
@@ -12867,7 +12660,7 @@
             <a:endParaRPr lang="en-US" sz="1300" dirty="0"/>
           </a:p>
           <a:p>
-            <a:pPr indent="0" marL="0">
+            <a:pPr marL="0" indent="0">
               <a:buNone/>
             </a:pPr>
             <a:r>
@@ -12904,7 +12697,7 @@
           </a:solidFill>
           <a:ln/>
           <a:effectLst>
-            <a:outerShdw sx="100000" sy="100000" kx="0" ky="0" algn="bl" rotWithShape="0" blurRad="76200" dist="25400" dir="8100000">
+            <a:outerShdw blurRad="76200" dist="25400" dir="8100000" algn="bl" rotWithShape="0">
               <a:srgbClr val="000000">
                 <a:alpha val="10000"/>
               </a:srgbClr>
@@ -12953,7 +12746,7 @@
           <a:bodyPr wrap="square" lIns="0" tIns="0" rIns="0" bIns="0" rtlCol="0" anchor="ctr"/>
           <a:lstStyle/>
           <a:p>
-            <a:pPr indent="0" marL="0">
+            <a:pPr marL="0" indent="0">
               <a:buNone/>
             </a:pPr>
             <a:r>
@@ -13015,7 +12808,7 @@
           <a:bodyPr wrap="square" lIns="0" tIns="0" rIns="0" bIns="0" rtlCol="0" anchor="t"/>
           <a:lstStyle/>
           <a:p>
-            <a:pPr indent="0" marL="0">
+            <a:pPr marL="0" indent="0">
               <a:buNone/>
             </a:pPr>
             <a:r>
@@ -13032,7 +12825,7 @@
             <a:endParaRPr lang="en-US" sz="1300" dirty="0"/>
           </a:p>
           <a:p>
-            <a:pPr indent="0" marL="0">
+            <a:pPr marL="0" indent="0">
               <a:buNone/>
             </a:pPr>
             <a:r>
@@ -13049,7 +12842,7 @@
             <a:endParaRPr lang="en-US" sz="1300" dirty="0"/>
           </a:p>
           <a:p>
-            <a:pPr indent="0" marL="0">
+            <a:pPr marL="0" indent="0">
               <a:buNone/>
             </a:pPr>
             <a:r>
@@ -13066,7 +12859,7 @@
             <a:endParaRPr lang="en-US" sz="1300" dirty="0"/>
           </a:p>
           <a:p>
-            <a:pPr indent="0" marL="0">
+            <a:pPr marL="0" indent="0">
               <a:buNone/>
             </a:pPr>
             <a:r>
@@ -13103,7 +12896,7 @@
           </a:solidFill>
           <a:ln/>
           <a:effectLst>
-            <a:outerShdw sx="100000" sy="100000" kx="0" ky="0" algn="bl" rotWithShape="0" blurRad="76200" dist="25400" dir="8100000">
+            <a:outerShdw blurRad="76200" dist="25400" dir="8100000" algn="bl" rotWithShape="0">
               <a:srgbClr val="000000">
                 <a:alpha val="10000"/>
               </a:srgbClr>
@@ -13152,7 +12945,7 @@
           <a:bodyPr wrap="square" lIns="0" tIns="0" rIns="0" bIns="0" rtlCol="0" anchor="ctr"/>
           <a:lstStyle/>
           <a:p>
-            <a:pPr indent="0" marL="0">
+            <a:pPr marL="0" indent="0">
               <a:buNone/>
             </a:pPr>
             <a:r>
@@ -13214,7 +13007,7 @@
           <a:bodyPr wrap="square" lIns="0" tIns="0" rIns="0" bIns="0" rtlCol="0" anchor="t"/>
           <a:lstStyle/>
           <a:p>
-            <a:pPr indent="0" marL="0">
+            <a:pPr marL="0" indent="0">
               <a:buNone/>
             </a:pPr>
             <a:r>
@@ -13231,7 +13024,7 @@
             <a:endParaRPr lang="en-US" sz="1300" dirty="0"/>
           </a:p>
           <a:p>
-            <a:pPr indent="0" marL="0">
+            <a:pPr marL="0" indent="0">
               <a:buNone/>
             </a:pPr>
             <a:r>
@@ -13248,7 +13041,7 @@
             <a:endParaRPr lang="en-US" sz="1300" dirty="0"/>
           </a:p>
           <a:p>
-            <a:pPr indent="0" marL="0">
+            <a:pPr marL="0" indent="0">
               <a:buNone/>
             </a:pPr>
             <a:r>
@@ -13265,7 +13058,7 @@
             <a:endParaRPr lang="en-US" sz="1300" dirty="0"/>
           </a:p>
           <a:p>
-            <a:pPr indent="0" marL="0">
+            <a:pPr marL="0" indent="0">
               <a:buNone/>
             </a:pPr>
             <a:r>
@@ -13324,7 +13117,7 @@
           <a:bodyPr wrap="square" lIns="0" tIns="0" rIns="0" bIns="0" rtlCol="0" anchor="ctr"/>
           <a:lstStyle/>
           <a:p>
-            <a:pPr indent="0" marL="0">
+            <a:pPr marL="0" indent="0">
               <a:buNone/>
             </a:pPr>
             <a:r>
@@ -13338,9 +13131,6 @@
               </a:rPr>
               <a:t> .windsurf/skills/</a:t>
             </a:r>
-            <a:pPr indent="0" marL="0">
-              <a:buNone/>
-            </a:pPr>
             <a:r>
               <a:rPr lang="en-US" sz="1000" dirty="0">
                 <a:solidFill>
@@ -13352,9 +13142,6 @@
               </a:rPr>
               <a:t>  dev/SKILL.md</a:t>
             </a:r>
-            <a:pPr indent="0" marL="0">
-              <a:buNone/>
-            </a:pPr>
             <a:r>
               <a:rPr lang="en-US" sz="1000" dirty="0">
                 <a:solidFill>
@@ -13366,9 +13153,6 @@
               </a:rPr>
               <a:t>  build/SKILL.md</a:t>
             </a:r>
-            <a:pPr indent="0" marL="0">
-              <a:buNone/>
-            </a:pPr>
             <a:r>
               <a:rPr lang="en-US" sz="1000" dirty="0">
                 <a:solidFill>
@@ -13400,6 +13184,7 @@
         <a:solidFill>
           <a:srgbClr val="F8FAFC"/>
         </a:solidFill>
+        <a:effectLst/>
       </p:bgPr>
     </p:bg>
     <p:spTree>
@@ -13444,8 +13229,8 @@
         </p:nvSpPr>
         <p:spPr>
           <a:xfrm>
-            <a:off x="640080" y="320040"/>
-            <a:ext cx="7315200" cy="594360"/>
+            <a:off x="369651" y="301752"/>
+            <a:ext cx="9445558" cy="594360"/>
           </a:xfrm>
           <a:prstGeom prst="rect">
             <a:avLst/>
@@ -13457,11 +13242,11 @@
           <a:bodyPr wrap="square" lIns="0" tIns="0" rIns="0" bIns="0" rtlCol="0" anchor="ctr"/>
           <a:lstStyle/>
           <a:p>
-            <a:pPr indent="0" marL="0">
-              <a:buNone/>
-            </a:pPr>
-            <a:r>
-              <a:rPr lang="en-US" sz="3600" dirty="0">
+            <a:pPr marL="0" indent="0">
+              <a:buNone/>
+            </a:pPr>
+            <a:r>
+              <a:rPr lang="en-US" sz="3200" dirty="0">
                 <a:solidFill>
                   <a:srgbClr val="1E293B"/>
                 </a:solidFill>
@@ -13471,7 +13256,7 @@
               </a:rPr>
               <a:t>Workflows — Process Orchestration</a:t>
             </a:r>
-            <a:endParaRPr lang="en-US" sz="3600" dirty="0"/>
+            <a:endParaRPr lang="en-US" sz="3200" dirty="0"/>
           </a:p>
         </p:txBody>
       </p:sp>
@@ -13496,7 +13281,7 @@
           <a:bodyPr wrap="square" lIns="0" tIns="0" rIns="0" bIns="0" rtlCol="0" anchor="ctr"/>
           <a:lstStyle/>
           <a:p>
-            <a:pPr indent="0" marL="0">
+            <a:pPr marL="0" indent="0">
               <a:buNone/>
             </a:pPr>
             <a:r>
@@ -13555,7 +13340,7 @@
           <a:bodyPr wrap="square" rtlCol="0" anchor="ctr"/>
           <a:lstStyle/>
           <a:p>
-            <a:pPr indent="0" marL="0">
+            <a:pPr marL="0" indent="0">
               <a:buNone/>
             </a:pPr>
             <a:r>
@@ -13572,7 +13357,7 @@
             <a:endParaRPr lang="en-US" sz="1400" dirty="0"/>
           </a:p>
           <a:p>
-            <a:pPr indent="0" marL="0">
+            <a:pPr marL="0" indent="0">
               <a:buNone/>
             </a:pPr>
             <a:r>
@@ -13589,7 +13374,7 @@
             <a:endParaRPr lang="en-US" sz="1400" dirty="0"/>
           </a:p>
           <a:p>
-            <a:pPr indent="0" marL="0">
+            <a:pPr marL="0" indent="0">
               <a:buNone/>
             </a:pPr>
             <a:r>
@@ -13626,7 +13411,7 @@
           </a:solidFill>
           <a:ln/>
           <a:effectLst>
-            <a:outerShdw sx="100000" sy="100000" kx="0" ky="0" algn="bl" rotWithShape="0" blurRad="76200" dist="25400" dir="8100000">
+            <a:outerShdw blurRad="76200" dist="25400" dir="8100000" algn="bl" rotWithShape="0">
               <a:srgbClr val="000000">
                 <a:alpha val="10000"/>
               </a:srgbClr>
@@ -13675,7 +13460,7 @@
           <a:bodyPr wrap="square" rtlCol="0" anchor="ctr"/>
           <a:lstStyle/>
           <a:p>
-            <a:pPr indent="0" marL="0">
+            <a:pPr marL="0" indent="0">
               <a:buNone/>
             </a:pPr>
             <a:r>
@@ -13692,7 +13477,7 @@
             <a:endParaRPr lang="en-US" sz="1400" dirty="0"/>
           </a:p>
           <a:p>
-            <a:pPr indent="0" marL="0">
+            <a:pPr marL="0" indent="0">
               <a:buNone/>
             </a:pPr>
             <a:r>
@@ -13709,7 +13494,7 @@
             <a:endParaRPr lang="en-US" sz="1400" dirty="0"/>
           </a:p>
           <a:p>
-            <a:pPr indent="0" marL="0">
+            <a:pPr marL="0" indent="0">
               <a:buNone/>
             </a:pPr>
             <a:r>
@@ -13748,7 +13533,7 @@
           <a:bodyPr wrap="square" lIns="0" tIns="0" rIns="0" bIns="0" rtlCol="0" anchor="ctr"/>
           <a:lstStyle/>
           <a:p>
-            <a:pPr indent="0" marL="0">
+            <a:pPr marL="0" indent="0">
               <a:buNone/>
             </a:pPr>
             <a:r>
@@ -13807,7 +13592,7 @@
           <a:bodyPr wrap="square" lIns="0" tIns="0" rIns="0" bIns="0" rtlCol="0" anchor="ctr"/>
           <a:lstStyle/>
           <a:p>
-            <a:pPr algn="ctr" indent="0" marL="0">
+            <a:pPr marL="0" indent="0" algn="ctr">
               <a:buNone/>
             </a:pPr>
             <a:r>
@@ -13846,7 +13631,7 @@
           <a:bodyPr wrap="square" lIns="0" tIns="0" rIns="0" bIns="0" rtlCol="0" anchor="ctr"/>
           <a:lstStyle/>
           <a:p>
-            <a:pPr algn="ctr" indent="0" marL="0">
+            <a:pPr marL="0" indent="0" algn="ctr">
               <a:buNone/>
             </a:pPr>
             <a:r>
@@ -13902,7 +13687,7 @@
           <a:bodyPr wrap="square" lIns="0" tIns="0" rIns="0" bIns="0" rtlCol="0" anchor="ctr"/>
           <a:lstStyle/>
           <a:p>
-            <a:pPr algn="ctr" indent="0" marL="0">
+            <a:pPr marL="0" indent="0" algn="ctr">
               <a:buNone/>
             </a:pPr>
             <a:r>
@@ -13941,7 +13726,7 @@
           <a:bodyPr wrap="square" lIns="0" tIns="0" rIns="0" bIns="0" rtlCol="0" anchor="ctr"/>
           <a:lstStyle/>
           <a:p>
-            <a:pPr algn="ctr" indent="0" marL="0">
+            <a:pPr marL="0" indent="0" algn="ctr">
               <a:buNone/>
             </a:pPr>
             <a:r>
@@ -13997,7 +13782,7 @@
           <a:bodyPr wrap="square" lIns="0" tIns="0" rIns="0" bIns="0" rtlCol="0" anchor="ctr"/>
           <a:lstStyle/>
           <a:p>
-            <a:pPr algn="ctr" indent="0" marL="0">
+            <a:pPr marL="0" indent="0" algn="ctr">
               <a:buNone/>
             </a:pPr>
             <a:r>
@@ -14036,7 +13821,7 @@
           <a:bodyPr wrap="square" lIns="0" tIns="0" rIns="0" bIns="0" rtlCol="0" anchor="ctr"/>
           <a:lstStyle/>
           <a:p>
-            <a:pPr algn="ctr" indent="0" marL="0">
+            <a:pPr marL="0" indent="0" algn="ctr">
               <a:buNone/>
             </a:pPr>
             <a:r>
@@ -14092,7 +13877,7 @@
           <a:bodyPr wrap="square" lIns="0" tIns="0" rIns="0" bIns="0" rtlCol="0" anchor="ctr"/>
           <a:lstStyle/>
           <a:p>
-            <a:pPr algn="ctr" indent="0" marL="0">
+            <a:pPr marL="0" indent="0" algn="ctr">
               <a:buNone/>
             </a:pPr>
             <a:r>
@@ -14131,7 +13916,7 @@
           <a:bodyPr wrap="square" lIns="0" tIns="0" rIns="0" bIns="0" rtlCol="0" anchor="ctr"/>
           <a:lstStyle/>
           <a:p>
-            <a:pPr algn="ctr" indent="0" marL="0">
+            <a:pPr marL="0" indent="0" algn="ctr">
               <a:buNone/>
             </a:pPr>
             <a:r>
@@ -14187,7 +13972,7 @@
           <a:bodyPr wrap="square" lIns="0" tIns="0" rIns="0" bIns="0" rtlCol="0" anchor="ctr"/>
           <a:lstStyle/>
           <a:p>
-            <a:pPr algn="ctr" indent="0" marL="0">
+            <a:pPr marL="0" indent="0" algn="ctr">
               <a:buNone/>
             </a:pPr>
             <a:r>
@@ -14226,7 +14011,7 @@
           <a:bodyPr wrap="square" lIns="0" tIns="0" rIns="0" bIns="0" rtlCol="0" anchor="ctr"/>
           <a:lstStyle/>
           <a:p>
-            <a:pPr algn="ctr" indent="0" marL="0">
+            <a:pPr marL="0" indent="0" algn="ctr">
               <a:buNone/>
             </a:pPr>
             <a:r>
@@ -14282,7 +14067,7 @@
           <a:bodyPr wrap="square" lIns="0" tIns="0" rIns="0" bIns="0" rtlCol="0" anchor="ctr"/>
           <a:lstStyle/>
           <a:p>
-            <a:pPr algn="ctr" indent="0" marL="0">
+            <a:pPr marL="0" indent="0" algn="ctr">
               <a:buNone/>
             </a:pPr>
             <a:r>
@@ -14321,7 +14106,7 @@
           <a:bodyPr wrap="square" lIns="0" tIns="0" rIns="0" bIns="0" rtlCol="0" anchor="ctr"/>
           <a:lstStyle/>
           <a:p>
-            <a:pPr indent="0" marL="0">
+            <a:pPr marL="0" indent="0">
               <a:buNone/>
             </a:pPr>
             <a:r>
@@ -14380,7 +14165,7 @@
           <a:bodyPr wrap="square" lIns="0" tIns="0" rIns="0" bIns="0" rtlCol="0" anchor="ctr"/>
           <a:lstStyle/>
           <a:p>
-            <a:pPr algn="ctr" indent="0" marL="0">
+            <a:pPr marL="0" indent="0" algn="ctr">
               <a:buNone/>
             </a:pPr>
             <a:r>
@@ -14439,7 +14224,7 @@
           <a:bodyPr wrap="square" lIns="0" tIns="0" rIns="0" bIns="0" rtlCol="0" anchor="ctr"/>
           <a:lstStyle/>
           <a:p>
-            <a:pPr algn="ctr" indent="0" marL="0">
+            <a:pPr marL="0" indent="0" algn="ctr">
               <a:buNone/>
             </a:pPr>
             <a:r>
@@ -14498,7 +14283,7 @@
           <a:bodyPr wrap="square" lIns="0" tIns="0" rIns="0" bIns="0" rtlCol="0" anchor="ctr"/>
           <a:lstStyle/>
           <a:p>
-            <a:pPr algn="ctr" indent="0" marL="0">
+            <a:pPr marL="0" indent="0" algn="ctr">
               <a:buNone/>
             </a:pPr>
             <a:r>
@@ -14557,7 +14342,7 @@
           <a:bodyPr wrap="square" lIns="0" tIns="0" rIns="0" bIns="0" rtlCol="0" anchor="ctr"/>
           <a:lstStyle/>
           <a:p>
-            <a:pPr algn="ctr" indent="0" marL="0">
+            <a:pPr marL="0" indent="0" algn="ctr">
               <a:buNone/>
             </a:pPr>
             <a:r>
@@ -14876,4 +14661,299 @@
     </a:ext>
   </a:extLst>
 </a:theme>
+</file>
+
+<file path=ppt/theme/theme2.xml><?xml version="1.0" encoding="utf-8"?>
+<a:theme xmlns:a="http://schemas.openxmlformats.org/drawingml/2006/main" name="Office 主题​​">
+  <a:themeElements>
+    <a:clrScheme name="Office">
+      <a:dk1>
+        <a:sysClr val="windowText" lastClr="000000"/>
+      </a:dk1>
+      <a:lt1>
+        <a:sysClr val="window" lastClr="FFFFFF"/>
+      </a:lt1>
+      <a:dk2>
+        <a:srgbClr val="44546A"/>
+      </a:dk2>
+      <a:lt2>
+        <a:srgbClr val="E7E6E6"/>
+      </a:lt2>
+      <a:accent1>
+        <a:srgbClr val="4472C4"/>
+      </a:accent1>
+      <a:accent2>
+        <a:srgbClr val="ED7D31"/>
+      </a:accent2>
+      <a:accent3>
+        <a:srgbClr val="A5A5A5"/>
+      </a:accent3>
+      <a:accent4>
+        <a:srgbClr val="FFC000"/>
+      </a:accent4>
+      <a:accent5>
+        <a:srgbClr val="5B9BD5"/>
+      </a:accent5>
+      <a:accent6>
+        <a:srgbClr val="70AD47"/>
+      </a:accent6>
+      <a:hlink>
+        <a:srgbClr val="0563C1"/>
+      </a:hlink>
+      <a:folHlink>
+        <a:srgbClr val="954F72"/>
+      </a:folHlink>
+    </a:clrScheme>
+    <a:fontScheme name="Office">
+      <a:majorFont>
+        <a:latin typeface="等线 Light" panose="020F0302020204030204"/>
+        <a:ea typeface=""/>
+        <a:cs typeface=""/>
+        <a:font script="Jpan" typeface="游ゴシック Light"/>
+        <a:font script="Hang" typeface="맑은 고딕"/>
+        <a:font script="Hans" typeface="等线 Light"/>
+        <a:font script="Hant" typeface="新細明體"/>
+        <a:font script="Arab" typeface="Times New Roman"/>
+        <a:font script="Hebr" typeface="Times New Roman"/>
+        <a:font script="Thai" typeface="Angsana New"/>
+        <a:font script="Ethi" typeface="Nyala"/>
+        <a:font script="Beng" typeface="Vrinda"/>
+        <a:font script="Gujr" typeface="Shruti"/>
+        <a:font script="Khmr" typeface="MoolBoran"/>
+        <a:font script="Knda" typeface="Tunga"/>
+        <a:font script="Guru" typeface="Raavi"/>
+        <a:font script="Cans" typeface="Euphemia"/>
+        <a:font script="Cher" typeface="Plantagenet Cherokee"/>
+        <a:font script="Yiii" typeface="Microsoft Yi Baiti"/>
+        <a:font script="Tibt" typeface="Microsoft Himalaya"/>
+        <a:font script="Thaa" typeface="MV Boli"/>
+        <a:font script="Deva" typeface="Mangal"/>
+        <a:font script="Telu" typeface="Gautami"/>
+        <a:font script="Taml" typeface="Latha"/>
+        <a:font script="Syrc" typeface="Estrangelo Edessa"/>
+        <a:font script="Orya" typeface="Kalinga"/>
+        <a:font script="Mlym" typeface="Kartika"/>
+        <a:font script="Laoo" typeface="DokChampa"/>
+        <a:font script="Sinh" typeface="Iskoola Pota"/>
+        <a:font script="Mong" typeface="Mongolian Baiti"/>
+        <a:font script="Viet" typeface="Times New Roman"/>
+        <a:font script="Uigh" typeface="Microsoft Uighur"/>
+        <a:font script="Geor" typeface="Sylfaen"/>
+        <a:font script="Armn" typeface="Arial"/>
+        <a:font script="Bugi" typeface="Leelawadee UI"/>
+        <a:font script="Bopo" typeface="Microsoft JhengHei"/>
+        <a:font script="Java" typeface="Javanese Text"/>
+        <a:font script="Lisu" typeface="Segoe UI"/>
+        <a:font script="Mymr" typeface="Myanmar Text"/>
+        <a:font script="Nkoo" typeface="Ebrima"/>
+        <a:font script="Olck" typeface="Nirmala UI"/>
+        <a:font script="Osma" typeface="Ebrima"/>
+        <a:font script="Phag" typeface="Phagspa"/>
+        <a:font script="Syrn" typeface="Estrangelo Edessa"/>
+        <a:font script="Syrj" typeface="Estrangelo Edessa"/>
+        <a:font script="Syre" typeface="Estrangelo Edessa"/>
+        <a:font script="Sora" typeface="Nirmala UI"/>
+        <a:font script="Tale" typeface="Microsoft Tai Le"/>
+        <a:font script="Talu" typeface="Microsoft New Tai Lue"/>
+        <a:font script="Tfng" typeface="Ebrima"/>
+      </a:majorFont>
+      <a:minorFont>
+        <a:latin typeface="等线" panose="020F0502020204030204"/>
+        <a:ea typeface=""/>
+        <a:cs typeface=""/>
+        <a:font script="Jpan" typeface="游ゴシック"/>
+        <a:font script="Hang" typeface="맑은 고딕"/>
+        <a:font script="Hans" typeface="等线"/>
+        <a:font script="Hant" typeface="新細明體"/>
+        <a:font script="Arab" typeface="Arial"/>
+        <a:font script="Hebr" typeface="Arial"/>
+        <a:font script="Thai" typeface="Cordia New"/>
+        <a:font script="Ethi" typeface="Nyala"/>
+        <a:font script="Beng" typeface="Vrinda"/>
+        <a:font script="Gujr" typeface="Shruti"/>
+        <a:font script="Khmr" typeface="DaunPenh"/>
+        <a:font script="Knda" typeface="Tunga"/>
+        <a:font script="Guru" typeface="Raavi"/>
+        <a:font script="Cans" typeface="Euphemia"/>
+        <a:font script="Cher" typeface="Plantagenet Cherokee"/>
+        <a:font script="Yiii" typeface="Microsoft Yi Baiti"/>
+        <a:font script="Tibt" typeface="Microsoft Himalaya"/>
+        <a:font script="Thaa" typeface="MV Boli"/>
+        <a:font script="Deva" typeface="Mangal"/>
+        <a:font script="Telu" typeface="Gautami"/>
+        <a:font script="Taml" typeface="Latha"/>
+        <a:font script="Syrc" typeface="Estrangelo Edessa"/>
+        <a:font script="Orya" typeface="Kalinga"/>
+        <a:font script="Mlym" typeface="Kartika"/>
+        <a:font script="Laoo" typeface="DokChampa"/>
+        <a:font script="Sinh" typeface="Iskoola Pota"/>
+        <a:font script="Mong" typeface="Mongolian Baiti"/>
+        <a:font script="Viet" typeface="Arial"/>
+        <a:font script="Uigh" typeface="Microsoft Uighur"/>
+        <a:font script="Geor" typeface="Sylfaen"/>
+        <a:font script="Armn" typeface="Arial"/>
+        <a:font script="Bugi" typeface="Leelawadee UI"/>
+        <a:font script="Bopo" typeface="Microsoft JhengHei"/>
+        <a:font script="Java" typeface="Javanese Text"/>
+        <a:font script="Lisu" typeface="Segoe UI"/>
+        <a:font script="Mymr" typeface="Myanmar Text"/>
+        <a:font script="Nkoo" typeface="Ebrima"/>
+        <a:font script="Olck" typeface="Nirmala UI"/>
+        <a:font script="Osma" typeface="Ebrima"/>
+        <a:font script="Phag" typeface="Phagspa"/>
+        <a:font script="Syrn" typeface="Estrangelo Edessa"/>
+        <a:font script="Syrj" typeface="Estrangelo Edessa"/>
+        <a:font script="Syre" typeface="Estrangelo Edessa"/>
+        <a:font script="Sora" typeface="Nirmala UI"/>
+        <a:font script="Tale" typeface="Microsoft Tai Le"/>
+        <a:font script="Talu" typeface="Microsoft New Tai Lue"/>
+        <a:font script="Tfng" typeface="Ebrima"/>
+      </a:minorFont>
+    </a:fontScheme>
+    <a:fmtScheme name="Office">
+      <a:fillStyleLst>
+        <a:solidFill>
+          <a:schemeClr val="phClr"/>
+        </a:solidFill>
+        <a:gradFill rotWithShape="1">
+          <a:gsLst>
+            <a:gs pos="0">
+              <a:schemeClr val="phClr">
+                <a:lumMod val="110000"/>
+                <a:satMod val="105000"/>
+                <a:tint val="67000"/>
+              </a:schemeClr>
+            </a:gs>
+            <a:gs pos="50000">
+              <a:schemeClr val="phClr">
+                <a:lumMod val="105000"/>
+                <a:satMod val="103000"/>
+                <a:tint val="73000"/>
+              </a:schemeClr>
+            </a:gs>
+            <a:gs pos="100000">
+              <a:schemeClr val="phClr">
+                <a:lumMod val="105000"/>
+                <a:satMod val="109000"/>
+                <a:tint val="81000"/>
+              </a:schemeClr>
+            </a:gs>
+          </a:gsLst>
+          <a:lin ang="5400000" scaled="0"/>
+        </a:gradFill>
+        <a:gradFill rotWithShape="1">
+          <a:gsLst>
+            <a:gs pos="0">
+              <a:schemeClr val="phClr">
+                <a:satMod val="103000"/>
+                <a:lumMod val="102000"/>
+                <a:tint val="94000"/>
+              </a:schemeClr>
+            </a:gs>
+            <a:gs pos="50000">
+              <a:schemeClr val="phClr">
+                <a:satMod val="110000"/>
+                <a:lumMod val="100000"/>
+                <a:shade val="100000"/>
+              </a:schemeClr>
+            </a:gs>
+            <a:gs pos="100000">
+              <a:schemeClr val="phClr">
+                <a:lumMod val="99000"/>
+                <a:satMod val="120000"/>
+                <a:shade val="78000"/>
+              </a:schemeClr>
+            </a:gs>
+          </a:gsLst>
+          <a:lin ang="5400000" scaled="0"/>
+        </a:gradFill>
+      </a:fillStyleLst>
+      <a:lnStyleLst>
+        <a:ln w="6350" cap="flat" cmpd="sng" algn="ctr">
+          <a:solidFill>
+            <a:schemeClr val="phClr"/>
+          </a:solidFill>
+          <a:prstDash val="solid"/>
+          <a:miter lim="800000"/>
+        </a:ln>
+        <a:ln w="12700" cap="flat" cmpd="sng" algn="ctr">
+          <a:solidFill>
+            <a:schemeClr val="phClr"/>
+          </a:solidFill>
+          <a:prstDash val="solid"/>
+          <a:miter lim="800000"/>
+        </a:ln>
+        <a:ln w="19050" cap="flat" cmpd="sng" algn="ctr">
+          <a:solidFill>
+            <a:schemeClr val="phClr"/>
+          </a:solidFill>
+          <a:prstDash val="solid"/>
+          <a:miter lim="800000"/>
+        </a:ln>
+      </a:lnStyleLst>
+      <a:effectStyleLst>
+        <a:effectStyle>
+          <a:effectLst/>
+        </a:effectStyle>
+        <a:effectStyle>
+          <a:effectLst/>
+        </a:effectStyle>
+        <a:effectStyle>
+          <a:effectLst>
+            <a:outerShdw blurRad="57150" dist="19050" dir="5400000" algn="ctr" rotWithShape="0">
+              <a:srgbClr val="000000">
+                <a:alpha val="63000"/>
+              </a:srgbClr>
+            </a:outerShdw>
+          </a:effectLst>
+        </a:effectStyle>
+      </a:effectStyleLst>
+      <a:bgFillStyleLst>
+        <a:solidFill>
+          <a:schemeClr val="phClr"/>
+        </a:solidFill>
+        <a:solidFill>
+          <a:schemeClr val="phClr">
+            <a:tint val="95000"/>
+            <a:satMod val="170000"/>
+          </a:schemeClr>
+        </a:solidFill>
+        <a:gradFill rotWithShape="1">
+          <a:gsLst>
+            <a:gs pos="0">
+              <a:schemeClr val="phClr">
+                <a:tint val="93000"/>
+                <a:satMod val="150000"/>
+                <a:shade val="98000"/>
+                <a:lumMod val="102000"/>
+              </a:schemeClr>
+            </a:gs>
+            <a:gs pos="50000">
+              <a:schemeClr val="phClr">
+                <a:tint val="98000"/>
+                <a:satMod val="130000"/>
+                <a:shade val="90000"/>
+                <a:lumMod val="103000"/>
+              </a:schemeClr>
+            </a:gs>
+            <a:gs pos="100000">
+              <a:schemeClr val="phClr">
+                <a:shade val="63000"/>
+                <a:satMod val="120000"/>
+              </a:schemeClr>
+            </a:gs>
+          </a:gsLst>
+          <a:lin ang="5400000" scaled="0"/>
+        </a:gradFill>
+      </a:bgFillStyleLst>
+    </a:fmtScheme>
+  </a:themeElements>
+  <a:objectDefaults/>
+  <a:extraClrSchemeLst/>
+  <a:extLst>
+    <a:ext uri="{05A4C25C-085E-4340-85A3-A5531E510DB2}">
+      <thm15:themeFamily xmlns:thm15="http://schemas.microsoft.com/office/thememl/2012/main" name="Office Theme" id="{62F939B6-93AF-4DB8-9C6B-D6C7DFDC589F}" vid="{4A3C46E8-61CC-4603-A589-7422A47A8E4A}"/>
+    </a:ext>
+  </a:extLst>
+</a:theme>
 </file>
</xml_diff>

<commit_message>
refactor: rename .windsurf/ to .devin/ across all files
</commit_message>
<xml_diff>
--- a/AI_Getting_Started_with_AI_Tools.pptx
+++ b/AI_Getting_Started_with_AI_Tools.pptx
@@ -4,9 +4,6 @@
   <p:sldMasterIdLst>
     <p:sldMasterId id="2147483648" r:id="rId1"/>
   </p:sldMasterIdLst>
-  <p:notesMasterIdLst>
-    <p:notesMasterId r:id="rId17"/>
-  </p:notesMasterIdLst>
   <p:sldIdLst>
     <p:sldId id="256" r:id="rId2"/>
     <p:sldId id="257" r:id="rId3"/>
@@ -24,7 +21,10 @@
     <p:sldId id="269" r:id="rId15"/>
     <p:sldId id="270" r:id="rId16"/>
   </p:sldIdLst>
-  <p:sldSz cx="9144000" cy="5143500" type="screen16x9"/>
+  <p:notesMasterIdLst>
+    <p:notesMasterId r:id="rId17"/>
+  </p:notesMasterIdLst>
+  <p:sldSz cx="9144000" cy="5143500"/>
   <p:notesSz cx="5143500" cy="9144000"/>
   <p:defaultTextStyle>
     <a:lvl1pPr marL="0" algn="l" defTabSz="914400" rtl="0" eaLnBrk="1" latinLnBrk="0" hangingPunct="1">
@@ -118,11 +118,6 @@
       </a:defRPr>
     </a:lvl9pPr>
   </p:defaultTextStyle>
-  <p:extLst>
-    <p:ext uri="{EFAFB233-063F-42B5-8137-9DF3F51BA10A}">
-      <p15:sldGuideLst xmlns:p15="http://schemas.microsoft.com/office/powerpoint/2012/main"/>
-    </p:ext>
-  </p:extLst>
 </p:presentation>
 </file>
 
@@ -148,10 +143,234 @@
           <a:chExt cx="0" cy="0"/>
         </a:xfrm>
       </p:grpSpPr>
+      <p:sp>
+        <p:nvSpPr>
+          <p:cNvPr id="2" name="Header Placeholder 1"/>
+          <p:cNvSpPr>
+            <a:spLocks noGrp="1"/>
+          </p:cNvSpPr>
+          <p:nvPr>
+            <p:ph type="hdr" sz="quarter"/>
+          </p:nvPr>
+        </p:nvSpPr>
+        <p:spPr>
+          <a:xfrm>
+            <a:off x="0" y="0"/>
+            <a:ext cx="2971800" cy="458788"/>
+          </a:xfrm>
+          <a:prstGeom prst="rect">
+            <a:avLst/>
+          </a:prstGeom>
+        </p:spPr>
+        <p:txBody>
+          <a:bodyPr vert="horz" lIns="91440" tIns="45720" rIns="91440" bIns="45720" rtlCol="0"/>
+          <a:lstStyle>
+            <a:lvl1pPr algn="l">
+              <a:defRPr sz="1200"/>
+            </a:lvl1pPr>
+          </a:lstStyle>
+          <a:p>
+            <a:endParaRPr lang="en-US"/>
+          </a:p>
+        </p:txBody>
+      </p:sp>
+      <p:sp>
+        <p:nvSpPr>
+          <p:cNvPr id="3" name="Date Placeholder 2"/>
+          <p:cNvSpPr>
+            <a:spLocks noGrp="1"/>
+          </p:cNvSpPr>
+          <p:nvPr>
+            <p:ph type="dt" idx="1"/>
+          </p:nvPr>
+        </p:nvSpPr>
+        <p:spPr>
+          <a:xfrm>
+            <a:off x="3884613" y="0"/>
+            <a:ext cx="2971800" cy="458788"/>
+          </a:xfrm>
+          <a:prstGeom prst="rect">
+            <a:avLst/>
+          </a:prstGeom>
+        </p:spPr>
+        <p:txBody>
+          <a:bodyPr vert="horz" lIns="91440" tIns="45720" rIns="91440" bIns="45720" rtlCol="0"/>
+          <a:lstStyle>
+            <a:lvl1pPr algn="r">
+              <a:defRPr sz="1200"/>
+            </a:lvl1pPr>
+          </a:lstStyle>
+          <a:p>
+            <a:fld id="{5282F153-3F37-0F45-9E97-73ACFA13230C}" type="datetimeFigureOut">
+              <a:rPr lang="en-US"/>
+              <a:t>7/23/19</a:t>
+            </a:fld>
+            <a:endParaRPr lang="en-US"/>
+          </a:p>
+        </p:txBody>
+      </p:sp>
+      <p:sp>
+        <p:nvSpPr>
+          <p:cNvPr id="4" name="Slide Image Placeholder 3"/>
+          <p:cNvSpPr>
+            <a:spLocks noGrp="1" noRot="1" noChangeAspect="1"/>
+          </p:cNvSpPr>
+          <p:nvPr>
+            <p:ph type="sldImg" idx="2"/>
+          </p:nvPr>
+        </p:nvSpPr>
+        <p:spPr>
+          <a:xfrm>
+            <a:off x="685800" y="1143000"/>
+            <a:ext cx="5486400" cy="3086100"/>
+          </a:xfrm>
+          <a:prstGeom prst="rect">
+            <a:avLst/>
+          </a:prstGeom>
+          <a:noFill/>
+          <a:ln w="12700">
+            <a:solidFill>
+              <a:prstClr val="black"/>
+            </a:solidFill>
+          </a:ln>
+        </p:spPr>
+        <p:txBody>
+          <a:bodyPr vert="horz" lIns="91440" tIns="45720" rIns="91440" bIns="45720" rtlCol="0" anchor="ctr"/>
+          <a:lstStyle/>
+          <a:p>
+            <a:endParaRPr lang="en-US"/>
+          </a:p>
+        </p:txBody>
+      </p:sp>
+      <p:sp>
+        <p:nvSpPr>
+          <p:cNvPr id="5" name="Notes Placeholder 4"/>
+          <p:cNvSpPr>
+            <a:spLocks noGrp="1"/>
+          </p:cNvSpPr>
+          <p:nvPr>
+            <p:ph type="body" sz="quarter" idx="3"/>
+          </p:nvPr>
+        </p:nvSpPr>
+        <p:spPr>
+          <a:xfrm>
+            <a:off x="685800" y="4400550"/>
+            <a:ext cx="5486400" cy="3600450"/>
+          </a:xfrm>
+          <a:prstGeom prst="rect">
+            <a:avLst/>
+          </a:prstGeom>
+        </p:spPr>
+        <p:txBody>
+          <a:bodyPr vert="horz" lIns="91440" tIns="45720" rIns="91440" bIns="45720" rtlCol="0"/>
+          <a:lstStyle/>
+          <a:p>
+            <a:pPr lvl="0"/>
+            <a:r>
+              <a:rPr lang="en-US"/>
+              <a:t>Click to edit Master text styles</a:t>
+            </a:r>
+          </a:p>
+          <a:p>
+            <a:pPr lvl="1"/>
+            <a:r>
+              <a:rPr lang="en-US"/>
+              <a:t>Second level</a:t>
+            </a:r>
+          </a:p>
+          <a:p>
+            <a:pPr lvl="2"/>
+            <a:r>
+              <a:rPr lang="en-US"/>
+              <a:t>Third level</a:t>
+            </a:r>
+          </a:p>
+          <a:p>
+            <a:pPr lvl="3"/>
+            <a:r>
+              <a:rPr lang="en-US"/>
+              <a:t>Fourth level</a:t>
+            </a:r>
+          </a:p>
+          <a:p>
+            <a:pPr lvl="4"/>
+            <a:r>
+              <a:rPr lang="en-US"/>
+              <a:t>Fifth level</a:t>
+            </a:r>
+          </a:p>
+        </p:txBody>
+      </p:sp>
+      <p:sp>
+        <p:nvSpPr>
+          <p:cNvPr id="6" name="Footer Placeholder 5"/>
+          <p:cNvSpPr>
+            <a:spLocks noGrp="1"/>
+          </p:cNvSpPr>
+          <p:nvPr>
+            <p:ph type="ftr" sz="quarter" idx="4"/>
+          </p:nvPr>
+        </p:nvSpPr>
+        <p:spPr>
+          <a:xfrm>
+            <a:off x="0" y="8685213"/>
+            <a:ext cx="2971800" cy="458787"/>
+          </a:xfrm>
+          <a:prstGeom prst="rect">
+            <a:avLst/>
+          </a:prstGeom>
+        </p:spPr>
+        <p:txBody>
+          <a:bodyPr vert="horz" lIns="91440" tIns="45720" rIns="91440" bIns="45720" rtlCol="0" anchor="b"/>
+          <a:lstStyle>
+            <a:lvl1pPr algn="l">
+              <a:defRPr sz="1200"/>
+            </a:lvl1pPr>
+          </a:lstStyle>
+          <a:p>
+            <a:endParaRPr lang="en-US"/>
+          </a:p>
+        </p:txBody>
+      </p:sp>
+      <p:sp>
+        <p:nvSpPr>
+          <p:cNvPr id="7" name="Slide Number Placeholder 6"/>
+          <p:cNvSpPr>
+            <a:spLocks noGrp="1"/>
+          </p:cNvSpPr>
+          <p:nvPr>
+            <p:ph type="sldNum" sz="quarter" idx="5"/>
+          </p:nvPr>
+        </p:nvSpPr>
+        <p:spPr>
+          <a:xfrm>
+            <a:off x="3884613" y="8685213"/>
+            <a:ext cx="2971800" cy="458787"/>
+          </a:xfrm>
+          <a:prstGeom prst="rect">
+            <a:avLst/>
+          </a:prstGeom>
+        </p:spPr>
+        <p:txBody>
+          <a:bodyPr vert="horz" lIns="91440" tIns="45720" rIns="91440" bIns="45720" rtlCol="0" anchor="b"/>
+          <a:lstStyle>
+            <a:lvl1pPr algn="r">
+              <a:defRPr sz="1200"/>
+            </a:lvl1pPr>
+          </a:lstStyle>
+          <a:p>
+            <a:fld id="{CE5E9CC1-C706-0F49-92D6-E571CC5EEA8F}" type="slidenum">
+              <a:rPr lang="en-US"/>
+              <a:t>‹#›</a:t>
+            </a:fld>
+            <a:endParaRPr lang="en-US"/>
+          </a:p>
+        </p:txBody>
+      </p:sp>
     </p:spTree>
     <p:extLst>
       <p:ext uri="{BB962C8B-B14F-4D97-AF65-F5344CB8AC3E}">
-        <p14:creationId xmlns:p14="http://schemas.microsoft.com/office/powerpoint/2010/main" val="1176429320"/>
+        <p14:creationId xmlns:p14="http://schemas.microsoft.com/office/powerpoint/2010/main" val="1024086991"/>
       </p:ext>
     </p:extLst>
   </p:cSld>
@@ -295,6 +514,10 @@
           <a:bodyPr/>
           <a:lstStyle/>
           <a:p>
+            <a:r>
+              <a:rPr lang="en-US" dirty="0"/>
+              <a:t/>
+            </a:r>
             <a:endParaRPr lang="en-US" dirty="0"/>
           </a:p>
         </p:txBody>
@@ -379,6 +602,10 @@
           <a:bodyPr/>
           <a:lstStyle/>
           <a:p>
+            <a:r>
+              <a:rPr lang="en-US" dirty="0"/>
+              <a:t/>
+            </a:r>
             <a:endParaRPr lang="en-US" dirty="0"/>
           </a:p>
         </p:txBody>
@@ -463,6 +690,10 @@
           <a:bodyPr/>
           <a:lstStyle/>
           <a:p>
+            <a:r>
+              <a:rPr lang="en-US" dirty="0"/>
+              <a:t/>
+            </a:r>
             <a:endParaRPr lang="en-US" dirty="0"/>
           </a:p>
         </p:txBody>
@@ -547,6 +778,10 @@
           <a:bodyPr/>
           <a:lstStyle/>
           <a:p>
+            <a:r>
+              <a:rPr lang="en-US" dirty="0"/>
+              <a:t/>
+            </a:r>
             <a:endParaRPr lang="en-US" dirty="0"/>
           </a:p>
         </p:txBody>
@@ -631,6 +866,10 @@
           <a:bodyPr/>
           <a:lstStyle/>
           <a:p>
+            <a:r>
+              <a:rPr lang="en-US" dirty="0"/>
+              <a:t/>
+            </a:r>
             <a:endParaRPr lang="en-US" dirty="0"/>
           </a:p>
         </p:txBody>
@@ -715,6 +954,10 @@
           <a:bodyPr/>
           <a:lstStyle/>
           <a:p>
+            <a:r>
+              <a:rPr lang="en-US" dirty="0"/>
+              <a:t/>
+            </a:r>
             <a:endParaRPr lang="en-US" dirty="0"/>
           </a:p>
         </p:txBody>
@@ -799,6 +1042,10 @@
           <a:bodyPr/>
           <a:lstStyle/>
           <a:p>
+            <a:r>
+              <a:rPr lang="en-US" dirty="0"/>
+              <a:t/>
+            </a:r>
             <a:endParaRPr lang="en-US" dirty="0"/>
           </a:p>
         </p:txBody>
@@ -883,6 +1130,10 @@
           <a:bodyPr/>
           <a:lstStyle/>
           <a:p>
+            <a:r>
+              <a:rPr lang="en-US" dirty="0"/>
+              <a:t/>
+            </a:r>
             <a:endParaRPr lang="en-US" dirty="0"/>
           </a:p>
         </p:txBody>
@@ -967,6 +1218,10 @@
           <a:bodyPr/>
           <a:lstStyle/>
           <a:p>
+            <a:r>
+              <a:rPr lang="en-US" dirty="0"/>
+              <a:t/>
+            </a:r>
             <a:endParaRPr lang="en-US" dirty="0"/>
           </a:p>
         </p:txBody>
@@ -1051,6 +1306,10 @@
           <a:bodyPr/>
           <a:lstStyle/>
           <a:p>
+            <a:r>
+              <a:rPr lang="en-US" dirty="0"/>
+              <a:t/>
+            </a:r>
             <a:endParaRPr lang="en-US" dirty="0"/>
           </a:p>
         </p:txBody>
@@ -1135,6 +1394,10 @@
           <a:bodyPr/>
           <a:lstStyle/>
           <a:p>
+            <a:r>
+              <a:rPr lang="en-US" dirty="0"/>
+              <a:t/>
+            </a:r>
             <a:endParaRPr lang="en-US" dirty="0"/>
           </a:p>
         </p:txBody>
@@ -1219,6 +1482,10 @@
           <a:bodyPr/>
           <a:lstStyle/>
           <a:p>
+            <a:r>
+              <a:rPr lang="en-US" dirty="0"/>
+              <a:t/>
+            </a:r>
             <a:endParaRPr lang="en-US" dirty="0"/>
           </a:p>
         </p:txBody>
@@ -1303,6 +1570,10 @@
           <a:bodyPr/>
           <a:lstStyle/>
           <a:p>
+            <a:r>
+              <a:rPr lang="en-US" dirty="0"/>
+              <a:t/>
+            </a:r>
             <a:endParaRPr lang="en-US" dirty="0"/>
           </a:p>
         </p:txBody>
@@ -1387,6 +1658,10 @@
           <a:bodyPr/>
           <a:lstStyle/>
           <a:p>
+            <a:r>
+              <a:rPr lang="en-US" dirty="0"/>
+              <a:t/>
+            </a:r>
             <a:endParaRPr lang="en-US" dirty="0"/>
           </a:p>
         </p:txBody>
@@ -1471,6 +1746,10 @@
           <a:bodyPr/>
           <a:lstStyle/>
           <a:p>
+            <a:r>
+              <a:rPr lang="en-US" dirty="0"/>
+              <a:t/>
+            </a:r>
             <a:endParaRPr lang="en-US" dirty="0"/>
           </a:p>
         </p:txBody>
@@ -1544,11 +1823,6 @@
 <file path=ppt/slideMasters/slideMaster1.xml><?xml version="1.0" encoding="utf-8"?>
 <p:sldMaster xmlns:a="http://schemas.openxmlformats.org/drawingml/2006/main" xmlns:r="http://schemas.openxmlformats.org/officeDocument/2006/relationships" xmlns:p="http://schemas.openxmlformats.org/presentationml/2006/main">
   <p:cSld>
-    <p:bg>
-      <p:bgRef idx="1001">
-        <a:schemeClr val="bg1"/>
-      </p:bgRef>
-    </p:bg>
     <p:spTree>
       <p:nvGrpSpPr>
         <p:cNvPr id="1" name=""/>
@@ -1831,7 +2105,6 @@
         <a:solidFill>
           <a:srgbClr val="0F172A"/>
         </a:solidFill>
-        <a:effectLst/>
       </p:bgPr>
     </p:bg>
     <p:spTree>
@@ -1913,7 +2186,7 @@
           <a:bodyPr wrap="square" lIns="0" tIns="0" rIns="0" bIns="0" rtlCol="0" anchor="ctr"/>
           <a:lstStyle/>
           <a:p>
-            <a:pPr marL="0" indent="0">
+            <a:pPr indent="0" marL="0">
               <a:buNone/>
             </a:pPr>
             <a:r>
@@ -1925,7 +2198,7 @@
                 <a:ea typeface="Arial Black" pitchFamily="34" charset="-122"/>
                 <a:cs typeface="Arial Black" pitchFamily="34" charset="-120"/>
               </a:rPr>
-              <a:t>AI Coding Tools</a:t>
+              <a:t>AI Coding Tools 101</a:t>
             </a:r>
             <a:endParaRPr lang="en-US" sz="4800" dirty="0"/>
           </a:p>
@@ -1952,7 +2225,7 @@
           <a:bodyPr wrap="square" lIns="0" tIns="0" rIns="0" bIns="0" rtlCol="0" anchor="ctr"/>
           <a:lstStyle/>
           <a:p>
-            <a:pPr marL="0" indent="0">
+            <a:pPr indent="0" marL="0">
               <a:buNone/>
             </a:pPr>
             <a:r>
@@ -2014,7 +2287,7 @@
           <a:bodyPr wrap="square" lIns="0" tIns="0" rIns="0" bIns="0" rtlCol="0" anchor="ctr"/>
           <a:lstStyle/>
           <a:p>
-            <a:pPr marL="0" indent="0">
+            <a:pPr indent="0" marL="0">
               <a:buNone/>
             </a:pPr>
             <a:r>
@@ -2053,7 +2326,7 @@
           <a:bodyPr wrap="square" lIns="0" tIns="0" rIns="0" bIns="0" rtlCol="0" anchor="ctr"/>
           <a:lstStyle/>
           <a:p>
-            <a:pPr marL="0" indent="0">
+            <a:pPr indent="0" marL="0">
               <a:buNone/>
             </a:pPr>
             <a:r>
@@ -2087,7 +2360,6 @@
         <a:solidFill>
           <a:srgbClr val="F8FAFC"/>
         </a:solidFill>
-        <a:effectLst/>
       </p:bgPr>
     </p:bg>
     <p:spTree>
@@ -2132,8 +2404,8 @@
         </p:nvSpPr>
         <p:spPr>
           <a:xfrm>
-            <a:off x="572002" y="306324"/>
-            <a:ext cx="8137155" cy="502920"/>
+            <a:off x="640080" y="320040"/>
+            <a:ext cx="7315200" cy="502920"/>
           </a:xfrm>
           <a:prstGeom prst="rect">
             <a:avLst/>
@@ -2145,11 +2417,11 @@
           <a:bodyPr wrap="square" lIns="0" tIns="0" rIns="0" bIns="0" rtlCol="0" anchor="ctr"/>
           <a:lstStyle/>
           <a:p>
-            <a:pPr marL="0" indent="0">
-              <a:buNone/>
-            </a:pPr>
-            <a:r>
-              <a:rPr lang="en-US" sz="2800" dirty="0">
+            <a:pPr indent="0" marL="0">
+              <a:buNone/>
+            </a:pPr>
+            <a:r>
+              <a:rPr lang="en-US" sz="3200" dirty="0">
                 <a:solidFill>
                   <a:srgbClr val="1E293B"/>
                 </a:solidFill>
@@ -2159,7 +2431,7 @@
               </a:rPr>
               <a:t>Workflows Demo — Orchestrating Skills</a:t>
             </a:r>
-            <a:endParaRPr lang="en-US" sz="2800" dirty="0"/>
+            <a:endParaRPr lang="en-US" sz="3200" dirty="0"/>
           </a:p>
         </p:txBody>
       </p:sp>
@@ -2182,7 +2454,7 @@
           </a:solidFill>
           <a:ln/>
           <a:effectLst>
-            <a:outerShdw blurRad="76200" dist="25400" dir="8100000" algn="bl" rotWithShape="0">
+            <a:outerShdw sx="100000" sy="100000" kx="0" ky="0" algn="bl" rotWithShape="0" blurRad="76200" dist="25400" dir="8100000">
               <a:srgbClr val="000000">
                 <a:alpha val="10000"/>
               </a:srgbClr>
@@ -2231,7 +2503,7 @@
           <a:bodyPr wrap="square" lIns="0" tIns="0" rIns="0" bIns="0" rtlCol="0" anchor="ctr"/>
           <a:lstStyle/>
           <a:p>
-            <a:pPr marL="0" indent="0">
+            <a:pPr indent="0" marL="0">
               <a:buNone/>
             </a:pPr>
             <a:r>
@@ -2290,7 +2562,7 @@
           <a:bodyPr wrap="square" lIns="0" tIns="0" rIns="0" bIns="0" rtlCol="0" anchor="ctr"/>
           <a:lstStyle/>
           <a:p>
-            <a:pPr marL="0" indent="0" algn="ctr">
+            <a:pPr algn="ctr" indent="0" marL="0">
               <a:buNone/>
             </a:pPr>
             <a:r>
@@ -2307,7 +2579,7 @@
             <a:endParaRPr lang="en-US" sz="1100" dirty="0"/>
           </a:p>
           <a:p>
-            <a:pPr marL="0" indent="0" algn="ctr">
+            <a:pPr algn="ctr" indent="0" marL="0">
               <a:buNone/>
             </a:pPr>
             <a:r>
@@ -2366,7 +2638,7 @@
           <a:bodyPr wrap="square" lIns="0" tIns="0" rIns="0" bIns="0" rtlCol="0" anchor="ctr"/>
           <a:lstStyle/>
           <a:p>
-            <a:pPr marL="0" indent="0" algn="ctr">
+            <a:pPr algn="ctr" indent="0" marL="0">
               <a:buNone/>
             </a:pPr>
             <a:r>
@@ -2383,7 +2655,7 @@
             <a:endParaRPr lang="en-US" sz="1100" dirty="0"/>
           </a:p>
           <a:p>
-            <a:pPr marL="0" indent="0" algn="ctr">
+            <a:pPr algn="ctr" indent="0" marL="0">
               <a:buNone/>
             </a:pPr>
             <a:r>
@@ -2442,7 +2714,7 @@
           <a:bodyPr wrap="square" lIns="0" tIns="0" rIns="0" bIns="0" rtlCol="0" anchor="ctr"/>
           <a:lstStyle/>
           <a:p>
-            <a:pPr marL="0" indent="0" algn="ctr">
+            <a:pPr algn="ctr" indent="0" marL="0">
               <a:buNone/>
             </a:pPr>
             <a:r>
@@ -2459,7 +2731,7 @@
             <a:endParaRPr lang="en-US" sz="1100" dirty="0"/>
           </a:p>
           <a:p>
-            <a:pPr marL="0" indent="0" algn="ctr">
+            <a:pPr algn="ctr" indent="0" marL="0">
               <a:buNone/>
             </a:pPr>
             <a:r>
@@ -2518,7 +2790,7 @@
           <a:bodyPr wrap="square" lIns="0" tIns="0" rIns="0" bIns="0" rtlCol="0" anchor="ctr"/>
           <a:lstStyle/>
           <a:p>
-            <a:pPr marL="0" indent="0" algn="ctr">
+            <a:pPr algn="ctr" indent="0" marL="0">
               <a:buNone/>
             </a:pPr>
             <a:r>
@@ -2535,7 +2807,7 @@
             <a:endParaRPr lang="en-US" sz="1100" dirty="0"/>
           </a:p>
           <a:p>
-            <a:pPr marL="0" indent="0" algn="ctr">
+            <a:pPr algn="ctr" indent="0" marL="0">
               <a:buNone/>
             </a:pPr>
             <a:r>
@@ -2594,7 +2866,7 @@
           <a:bodyPr wrap="square" lIns="0" tIns="0" rIns="0" bIns="0" rtlCol="0" anchor="ctr"/>
           <a:lstStyle/>
           <a:p>
-            <a:pPr marL="0" indent="0" algn="ctr">
+            <a:pPr algn="ctr" indent="0" marL="0">
               <a:buNone/>
             </a:pPr>
             <a:r>
@@ -2611,7 +2883,7 @@
             <a:endParaRPr lang="en-US" sz="1100" dirty="0"/>
           </a:p>
           <a:p>
-            <a:pPr marL="0" indent="0" algn="ctr">
+            <a:pPr algn="ctr" indent="0" marL="0">
               <a:buNone/>
             </a:pPr>
             <a:r>
@@ -2670,7 +2942,7 @@
           <a:bodyPr wrap="square" lIns="0" tIns="0" rIns="0" bIns="0" rtlCol="0" anchor="ctr"/>
           <a:lstStyle/>
           <a:p>
-            <a:pPr marL="0" indent="0" algn="ctr">
+            <a:pPr algn="ctr" indent="0" marL="0">
               <a:buNone/>
             </a:pPr>
             <a:r>
@@ -2687,7 +2959,7 @@
             <a:endParaRPr lang="en-US" sz="1100" dirty="0"/>
           </a:p>
           <a:p>
-            <a:pPr marL="0" indent="0" algn="ctr">
+            <a:pPr algn="ctr" indent="0" marL="0">
               <a:buNone/>
             </a:pPr>
             <a:r>
@@ -2746,7 +3018,7 @@
           <a:bodyPr wrap="square" lIns="0" tIns="0" rIns="0" bIns="0" rtlCol="0" anchor="ctr"/>
           <a:lstStyle/>
           <a:p>
-            <a:pPr marL="0" indent="0" algn="ctr">
+            <a:pPr algn="ctr" indent="0" marL="0">
               <a:buNone/>
             </a:pPr>
             <a:r>
@@ -2763,7 +3035,7 @@
             <a:endParaRPr lang="en-US" sz="1100" dirty="0"/>
           </a:p>
           <a:p>
-            <a:pPr marL="0" indent="0" algn="ctr">
+            <a:pPr algn="ctr" indent="0" marL="0">
               <a:buNone/>
             </a:pPr>
             <a:r>
@@ -2802,7 +3074,7 @@
           <a:bodyPr wrap="square" lIns="0" tIns="0" rIns="0" bIns="0" rtlCol="0" anchor="ctr"/>
           <a:lstStyle/>
           <a:p>
-            <a:pPr marL="0" indent="0" algn="ctr">
+            <a:pPr algn="ctr" indent="0" marL="0">
               <a:buNone/>
             </a:pPr>
             <a:r>
@@ -2838,7 +3110,7 @@
           <a:bodyPr wrap="square" lIns="0" tIns="0" rIns="0" bIns="0" rtlCol="0" anchor="ctr"/>
           <a:lstStyle/>
           <a:p>
-            <a:pPr marL="0" indent="0" algn="ctr">
+            <a:pPr algn="ctr" indent="0" marL="0">
               <a:buNone/>
             </a:pPr>
             <a:r>
@@ -2874,7 +3146,7 @@
           <a:bodyPr wrap="square" lIns="0" tIns="0" rIns="0" bIns="0" rtlCol="0" anchor="ctr"/>
           <a:lstStyle/>
           <a:p>
-            <a:pPr marL="0" indent="0" algn="ctr">
+            <a:pPr algn="ctr" indent="0" marL="0">
               <a:buNone/>
             </a:pPr>
             <a:r>
@@ -2910,7 +3182,7 @@
           <a:bodyPr wrap="square" lIns="0" tIns="0" rIns="0" bIns="0" rtlCol="0" anchor="ctr"/>
           <a:lstStyle/>
           <a:p>
-            <a:pPr marL="0" indent="0" algn="ctr">
+            <a:pPr algn="ctr" indent="0" marL="0">
               <a:buNone/>
             </a:pPr>
             <a:r>
@@ -2946,7 +3218,7 @@
           <a:bodyPr wrap="square" lIns="0" tIns="0" rIns="0" bIns="0" rtlCol="0" anchor="ctr"/>
           <a:lstStyle/>
           <a:p>
-            <a:pPr marL="0" indent="0" algn="ctr">
+            <a:pPr algn="ctr" indent="0" marL="0">
               <a:buNone/>
             </a:pPr>
             <a:r>
@@ -2982,7 +3254,7 @@
           <a:bodyPr wrap="square" lIns="0" tIns="0" rIns="0" bIns="0" rtlCol="0" anchor="ctr"/>
           <a:lstStyle/>
           <a:p>
-            <a:pPr marL="0" indent="0" algn="ctr">
+            <a:pPr algn="ctr" indent="0" marL="0">
               <a:buNone/>
             </a:pPr>
             <a:r>
@@ -3038,7 +3310,7 @@
           <a:bodyPr wrap="square" lIns="0" tIns="0" rIns="0" bIns="0" rtlCol="0" anchor="ctr"/>
           <a:lstStyle/>
           <a:p>
-            <a:pPr marL="0" indent="0">
+            <a:pPr indent="0" marL="0">
               <a:buNone/>
             </a:pPr>
             <a:r>
@@ -3050,12 +3322,12 @@
                 <a:ea typeface="Consolas" pitchFamily="34" charset="-122"/>
                 <a:cs typeface="Consolas" pitchFamily="34" charset="-120"/>
               </a:rPr>
-              <a:t># .windsurf/workflows/ci-pipeline.md</a:t>
+              <a:t># .devin/workflows/ci-pipeline.md</a:t>
             </a:r>
             <a:endParaRPr lang="en-US" sz="1000" dirty="0"/>
           </a:p>
           <a:p>
-            <a:pPr marL="0" indent="0">
+            <a:pPr indent="0" marL="0">
               <a:buNone/>
             </a:pPr>
             <a:r>
@@ -3069,6 +3341,9 @@
               </a:rPr>
               <a:t>Invoke: </a:t>
             </a:r>
+            <a:pPr indent="0" marL="0">
+              <a:buNone/>
+            </a:pPr>
             <a:r>
               <a:rPr lang="en-US" sz="1000" dirty="0">
                 <a:solidFill>
@@ -3080,6 +3355,9 @@
               </a:rPr>
               <a:t>/ci-pipeline</a:t>
             </a:r>
+            <a:pPr indent="0" marL="0">
+              <a:buNone/>
+            </a:pPr>
             <a:r>
               <a:rPr lang="en-US" sz="1000" dirty="0">
                 <a:solidFill>
@@ -3116,7 +3394,7 @@
           <a:bodyPr wrap="square" lIns="0" tIns="0" rIns="0" bIns="0" rtlCol="0" anchor="ctr"/>
           <a:lstStyle/>
           <a:p>
-            <a:pPr marL="0" indent="0">
+            <a:pPr indent="0" marL="0">
               <a:buNone/>
             </a:pPr>
             <a:r>
@@ -3150,7 +3428,6 @@
         <a:solidFill>
           <a:srgbClr val="F8FAFC"/>
         </a:solidFill>
-        <a:effectLst/>
       </p:bgPr>
     </p:bg>
     <p:spTree>
@@ -3208,11 +3485,11 @@
           <a:bodyPr wrap="square" lIns="0" tIns="0" rIns="0" bIns="0" rtlCol="0" anchor="ctr"/>
           <a:lstStyle/>
           <a:p>
-            <a:pPr marL="0" indent="0">
-              <a:buNone/>
-            </a:pPr>
-            <a:r>
-              <a:rPr lang="en-US" sz="3200" dirty="0">
+            <a:pPr indent="0" marL="0">
+              <a:buNone/>
+            </a:pPr>
+            <a:r>
+              <a:rPr lang="en-US" sz="3600" dirty="0">
                 <a:solidFill>
                   <a:srgbClr val="1E293B"/>
                 </a:solidFill>
@@ -3222,7 +3499,7 @@
               </a:rPr>
               <a:t>MCP — Model Context Protocol</a:t>
             </a:r>
-            <a:endParaRPr lang="en-US" sz="3200" dirty="0"/>
+            <a:endParaRPr lang="en-US" sz="3600" dirty="0"/>
           </a:p>
         </p:txBody>
       </p:sp>
@@ -3247,7 +3524,7 @@
           <a:bodyPr wrap="square" lIns="0" tIns="0" rIns="0" bIns="0" rtlCol="0" anchor="ctr"/>
           <a:lstStyle/>
           <a:p>
-            <a:pPr marL="0" indent="0">
+            <a:pPr indent="0" marL="0">
               <a:buNone/>
             </a:pPr>
             <a:r>
@@ -3306,7 +3583,7 @@
           <a:bodyPr wrap="square" lIns="0" tIns="0" rIns="0" bIns="0" rtlCol="0" anchor="ctr"/>
           <a:lstStyle/>
           <a:p>
-            <a:pPr marL="0" indent="0" algn="ctr">
+            <a:pPr algn="ctr" indent="0" marL="0">
               <a:buNone/>
             </a:pPr>
             <a:r>
@@ -3345,7 +3622,7 @@
           <a:bodyPr wrap="square" lIns="0" tIns="0" rIns="0" bIns="0" rtlCol="0" anchor="ctr"/>
           <a:lstStyle/>
           <a:p>
-            <a:pPr marL="0" indent="0" algn="ctr">
+            <a:pPr algn="ctr" indent="0" marL="0">
               <a:buNone/>
             </a:pPr>
             <a:r>
@@ -3362,7 +3639,7 @@
             <a:endParaRPr lang="en-US" sz="1300" dirty="0"/>
           </a:p>
           <a:p>
-            <a:pPr marL="0" indent="0" algn="ctr">
+            <a:pPr algn="ctr" indent="0" marL="0">
               <a:buNone/>
             </a:pPr>
             <a:r>
@@ -3423,7 +3700,7 @@
           <a:bodyPr wrap="square" lIns="0" tIns="0" rIns="0" bIns="0" rtlCol="0" anchor="ctr"/>
           <a:lstStyle/>
           <a:p>
-            <a:pPr marL="0" indent="0" algn="ctr">
+            <a:pPr algn="ctr" indent="0" marL="0">
               <a:buNone/>
             </a:pPr>
             <a:r>
@@ -3462,7 +3739,7 @@
           <a:bodyPr wrap="square" lIns="0" tIns="0" rIns="0" bIns="0" rtlCol="0" anchor="ctr"/>
           <a:lstStyle/>
           <a:p>
-            <a:pPr marL="0" indent="0" algn="ctr">
+            <a:pPr algn="ctr" indent="0" marL="0">
               <a:buNone/>
             </a:pPr>
             <a:r>
@@ -3479,7 +3756,7 @@
             <a:endParaRPr lang="en-US" sz="1200" dirty="0"/>
           </a:p>
           <a:p>
-            <a:pPr marL="0" indent="0" algn="ctr">
+            <a:pPr algn="ctr" indent="0" marL="0">
               <a:buNone/>
             </a:pPr>
             <a:r>
@@ -3516,7 +3793,7 @@
           </a:solidFill>
           <a:ln/>
           <a:effectLst>
-            <a:outerShdw blurRad="76200" dist="25400" dir="8100000" algn="bl" rotWithShape="0">
+            <a:outerShdw sx="100000" sy="100000" kx="0" ky="0" algn="bl" rotWithShape="0" blurRad="76200" dist="25400" dir="8100000">
               <a:srgbClr val="000000">
                 <a:alpha val="10000"/>
               </a:srgbClr>
@@ -3545,7 +3822,7 @@
           <a:bodyPr wrap="square" lIns="0" tIns="0" rIns="0" bIns="0" rtlCol="0" anchor="ctr"/>
           <a:lstStyle/>
           <a:p>
-            <a:pPr marL="0" indent="0" algn="ctr">
+            <a:pPr algn="ctr" indent="0" marL="0">
               <a:buNone/>
             </a:pPr>
             <a:r>
@@ -3584,7 +3861,7 @@
           <a:bodyPr wrap="square" lIns="0" tIns="0" rIns="0" bIns="0" rtlCol="0" anchor="ctr"/>
           <a:lstStyle/>
           <a:p>
-            <a:pPr marL="0" indent="0" algn="ctr">
+            <a:pPr algn="ctr" indent="0" marL="0">
               <a:buNone/>
             </a:pPr>
             <a:r>
@@ -3601,7 +3878,7 @@
             <a:endParaRPr lang="en-US" sz="1300" dirty="0"/>
           </a:p>
           <a:p>
-            <a:pPr marL="0" indent="0" algn="ctr">
+            <a:pPr algn="ctr" indent="0" marL="0">
               <a:buNone/>
             </a:pPr>
             <a:r>
@@ -3640,7 +3917,7 @@
           <a:bodyPr wrap="square" lIns="0" tIns="0" rIns="0" bIns="0" rtlCol="0" anchor="ctr"/>
           <a:lstStyle/>
           <a:p>
-            <a:pPr marL="0" indent="0" algn="ctr">
+            <a:pPr algn="ctr" indent="0" marL="0">
               <a:buNone/>
             </a:pPr>
             <a:r>
@@ -3676,7 +3953,7 @@
           <a:bodyPr wrap="square" lIns="0" tIns="0" rIns="0" bIns="0" rtlCol="0" anchor="ctr"/>
           <a:lstStyle/>
           <a:p>
-            <a:pPr marL="0" indent="0" algn="ctr">
+            <a:pPr algn="ctr" indent="0" marL="0">
               <a:buNone/>
             </a:pPr>
             <a:r>
@@ -3712,7 +3989,7 @@
           <a:bodyPr wrap="square" lIns="0" tIns="0" rIns="0" bIns="0" rtlCol="0" anchor="ctr"/>
           <a:lstStyle/>
           <a:p>
-            <a:pPr marL="0" indent="0">
+            <a:pPr indent="0" marL="0">
               <a:buNone/>
             </a:pPr>
             <a:r>
@@ -3751,7 +4028,7 @@
           <a:bodyPr wrap="square" lIns="0" tIns="0" rIns="0" bIns="0" rtlCol="0" anchor="ctr"/>
           <a:lstStyle/>
           <a:p>
-            <a:pPr marL="0" indent="0">
+            <a:pPr indent="0" marL="0">
               <a:buNone/>
             </a:pPr>
             <a:r>
@@ -3790,7 +4067,7 @@
           <a:bodyPr wrap="square" lIns="0" tIns="0" rIns="0" bIns="0" rtlCol="0" anchor="ctr"/>
           <a:lstStyle/>
           <a:p>
-            <a:pPr marL="0" indent="0">
+            <a:pPr indent="0" marL="0">
               <a:buNone/>
             </a:pPr>
             <a:r>
@@ -3829,7 +4106,7 @@
           <a:bodyPr wrap="square" lIns="0" tIns="0" rIns="0" bIns="0" rtlCol="0" anchor="ctr"/>
           <a:lstStyle/>
           <a:p>
-            <a:pPr marL="0" indent="0">
+            <a:pPr indent="0" marL="0">
               <a:buNone/>
             </a:pPr>
             <a:r>
@@ -3868,7 +4145,7 @@
           <a:bodyPr wrap="square" lIns="0" tIns="0" rIns="0" bIns="0" rtlCol="0" anchor="ctr"/>
           <a:lstStyle/>
           <a:p>
-            <a:pPr marL="0" indent="0">
+            <a:pPr indent="0" marL="0">
               <a:buNone/>
             </a:pPr>
             <a:r>
@@ -3907,7 +4184,7 @@
           <a:bodyPr wrap="square" lIns="0" tIns="0" rIns="0" bIns="0" rtlCol="0" anchor="ctr"/>
           <a:lstStyle/>
           <a:p>
-            <a:pPr marL="0" indent="0">
+            <a:pPr indent="0" marL="0">
               <a:buNone/>
             </a:pPr>
             <a:r>
@@ -3946,7 +4223,7 @@
           <a:bodyPr wrap="square" lIns="0" tIns="0" rIns="0" bIns="0" rtlCol="0" anchor="ctr"/>
           <a:lstStyle/>
           <a:p>
-            <a:pPr marL="0" indent="0">
+            <a:pPr indent="0" marL="0">
               <a:buNone/>
             </a:pPr>
             <a:r>
@@ -3985,7 +4262,7 @@
           <a:bodyPr wrap="square" lIns="0" tIns="0" rIns="0" bIns="0" rtlCol="0" anchor="ctr"/>
           <a:lstStyle/>
           <a:p>
-            <a:pPr marL="0" indent="0">
+            <a:pPr indent="0" marL="0">
               <a:buNone/>
             </a:pPr>
             <a:r>
@@ -4024,7 +4301,7 @@
           <a:bodyPr wrap="square" lIns="0" tIns="0" rIns="0" bIns="0" rtlCol="0" anchor="ctr"/>
           <a:lstStyle/>
           <a:p>
-            <a:pPr marL="0" indent="0">
+            <a:pPr indent="0" marL="0">
               <a:buNone/>
             </a:pPr>
             <a:r>
@@ -4063,7 +4340,7 @@
           <a:bodyPr wrap="square" lIns="0" tIns="0" rIns="0" bIns="0" rtlCol="0" anchor="ctr"/>
           <a:lstStyle/>
           <a:p>
-            <a:pPr marL="0" indent="0">
+            <a:pPr indent="0" marL="0">
               <a:buNone/>
             </a:pPr>
             <a:r>
@@ -4102,7 +4379,7 @@
           <a:bodyPr wrap="square" lIns="0" tIns="0" rIns="0" bIns="0" rtlCol="0" anchor="ctr"/>
           <a:lstStyle/>
           <a:p>
-            <a:pPr marL="0" indent="0">
+            <a:pPr indent="0" marL="0">
               <a:buNone/>
             </a:pPr>
             <a:r>
@@ -4141,7 +4418,7 @@
           <a:bodyPr wrap="square" lIns="0" tIns="0" rIns="0" bIns="0" rtlCol="0" anchor="ctr"/>
           <a:lstStyle/>
           <a:p>
-            <a:pPr marL="0" indent="0">
+            <a:pPr indent="0" marL="0">
               <a:buNone/>
             </a:pPr>
             <a:r>
@@ -4180,7 +4457,7 @@
           <a:bodyPr wrap="square" lIns="0" tIns="0" rIns="0" bIns="0" rtlCol="0" anchor="ctr"/>
           <a:lstStyle/>
           <a:p>
-            <a:pPr marL="0" indent="0">
+            <a:pPr indent="0" marL="0">
               <a:buNone/>
             </a:pPr>
             <a:r>
@@ -4214,7 +4491,6 @@
         <a:solidFill>
           <a:srgbClr val="F8FAFC"/>
         </a:solidFill>
-        <a:effectLst/>
       </p:bgPr>
     </p:bg>
     <p:spTree>
@@ -4259,8 +4535,8 @@
         </p:nvSpPr>
         <p:spPr>
           <a:xfrm>
-            <a:off x="640079" y="320040"/>
-            <a:ext cx="8007809" cy="502920"/>
+            <a:off x="640080" y="320040"/>
+            <a:ext cx="7315200" cy="502920"/>
           </a:xfrm>
           <a:prstGeom prst="rect">
             <a:avLst/>
@@ -4272,11 +4548,11 @@
           <a:bodyPr wrap="square" lIns="0" tIns="0" rIns="0" bIns="0" rtlCol="0" anchor="ctr"/>
           <a:lstStyle/>
           <a:p>
-            <a:pPr marL="0" indent="0">
-              <a:buNone/>
-            </a:pPr>
-            <a:r>
-              <a:rPr lang="en-US" sz="2800" dirty="0">
+            <a:pPr indent="0" marL="0">
+              <a:buNone/>
+            </a:pPr>
+            <a:r>
+              <a:rPr lang="en-US" sz="3200" dirty="0">
                 <a:solidFill>
                   <a:srgbClr val="1E293B"/>
                 </a:solidFill>
@@ -4286,7 +4562,7 @@
               </a:rPr>
               <a:t>MCP Demo — Expanding AI Capabilities</a:t>
             </a:r>
-            <a:endParaRPr lang="en-US" sz="2800" dirty="0"/>
+            <a:endParaRPr lang="en-US" sz="3200" dirty="0"/>
           </a:p>
         </p:txBody>
       </p:sp>
@@ -4351,7 +4627,7 @@
           <a:bodyPr wrap="square" lIns="0" tIns="0" rIns="0" bIns="0" rtlCol="0" anchor="ctr"/>
           <a:lstStyle/>
           <a:p>
-            <a:pPr marL="0" indent="0">
+            <a:pPr indent="0" marL="0">
               <a:buNone/>
             </a:pPr>
             <a:r>
@@ -4520,7 +4796,7 @@
           <a:bodyPr wrap="square" lIns="0" tIns="0" rIns="0" bIns="0" rtlCol="0" anchor="ctr"/>
           <a:lstStyle/>
           <a:p>
-            <a:pPr marL="0" indent="0" algn="ctr">
+            <a:pPr algn="ctr" indent="0" marL="0">
               <a:buNone/>
             </a:pPr>
             <a:r>
@@ -4599,7 +4875,7 @@
           <a:bodyPr wrap="square" lIns="0" tIns="0" rIns="0" bIns="0" rtlCol="0" anchor="ctr"/>
           <a:lstStyle/>
           <a:p>
-            <a:pPr marL="0" indent="0">
+            <a:pPr indent="0" marL="0">
               <a:buNone/>
             </a:pPr>
             <a:r>
@@ -4768,7 +5044,7 @@
           <a:bodyPr wrap="square" lIns="0" tIns="0" rIns="0" bIns="0" rtlCol="0" anchor="ctr"/>
           <a:lstStyle/>
           <a:p>
-            <a:pPr marL="0" indent="0">
+            <a:pPr indent="0" marL="0">
               <a:buNone/>
             </a:pPr>
             <a:r>
@@ -4802,7 +5078,6 @@
         <a:solidFill>
           <a:srgbClr val="F8FAFC"/>
         </a:solidFill>
-        <a:effectLst/>
       </p:bgPr>
     </p:bg>
     <p:spTree>
@@ -4860,7 +5135,7 @@
           <a:bodyPr wrap="square" lIns="0" tIns="0" rIns="0" bIns="0" rtlCol="0" anchor="ctr"/>
           <a:lstStyle/>
           <a:p>
-            <a:pPr marL="0" indent="0">
+            <a:pPr indent="0" marL="0">
               <a:buNone/>
             </a:pPr>
             <a:r>
@@ -4901,34 +5176,10 @@
             <a:tbl>
               <a:tblPr/>
               <a:tblGrid>
-                <a:gridCol w="1828800">
-                  <a:extLst>
-                    <a:ext uri="{9D8B030D-6E8A-4147-A177-3AD203B41FA5}">
-                      <a16:colId xmlns:a16="http://schemas.microsoft.com/office/drawing/2014/main" val="20000"/>
-                    </a:ext>
-                  </a:extLst>
-                </a:gridCol>
-                <a:gridCol w="2130552">
-                  <a:extLst>
-                    <a:ext uri="{9D8B030D-6E8A-4147-A177-3AD203B41FA5}">
-                      <a16:colId xmlns:a16="http://schemas.microsoft.com/office/drawing/2014/main" val="20001"/>
-                    </a:ext>
-                  </a:extLst>
-                </a:gridCol>
-                <a:gridCol w="2130552">
-                  <a:extLst>
-                    <a:ext uri="{9D8B030D-6E8A-4147-A177-3AD203B41FA5}">
-                      <a16:colId xmlns:a16="http://schemas.microsoft.com/office/drawing/2014/main" val="20002"/>
-                    </a:ext>
-                  </a:extLst>
-                </a:gridCol>
-                <a:gridCol w="2130552">
-                  <a:extLst>
-                    <a:ext uri="{9D8B030D-6E8A-4147-A177-3AD203B41FA5}">
-                      <a16:colId xmlns:a16="http://schemas.microsoft.com/office/drawing/2014/main" val="20003"/>
-                    </a:ext>
-                  </a:extLst>
-                </a:gridCol>
+                <a:gridCol w="1828800"/>
+                <a:gridCol w="2130552"/>
+                <a:gridCol w="2130552"/>
+                <a:gridCol w="2130552"/>
               </a:tblGrid>
               <a:tr h="457200">
                 <a:tc>
@@ -4936,7 +5187,7 @@
                     <a:bodyPr/>
                     <a:lstStyle/>
                     <a:p>
-                      <a:pPr marL="0" indent="0" algn="ctr">
+                      <a:pPr algn="ctr" indent="0" marL="0">
                         <a:buNone/>
                       </a:pPr>
                       <a:r>
@@ -4957,7 +5208,7 @@
                       </a:endParaRPr>
                     </a:p>
                   </a:txBody>
-                  <a:tcPr anchor="ctr">
+                  <a:tcPr marL="91440" marR="91440" marT="45720" marB="45720" anchor="ctr">
                     <a:lnL w="6350" cap="flat" cmpd="sng" algn="ctr">
                       <a:solidFill>
                         <a:srgbClr val="E2E8F0"/>
@@ -5004,7 +5255,7 @@
                     <a:bodyPr/>
                     <a:lstStyle/>
                     <a:p>
-                      <a:pPr marL="0" indent="0" algn="ctr">
+                      <a:pPr algn="ctr" indent="0" marL="0">
                         <a:buNone/>
                       </a:pPr>
                       <a:r>
@@ -5025,7 +5276,7 @@
                       </a:endParaRPr>
                     </a:p>
                   </a:txBody>
-                  <a:tcPr anchor="ctr">
+                  <a:tcPr marL="91440" marR="91440" marT="45720" marB="45720" anchor="ctr">
                     <a:lnL w="6350" cap="flat" cmpd="sng" algn="ctr">
                       <a:solidFill>
                         <a:srgbClr val="E2E8F0"/>
@@ -5072,7 +5323,7 @@
                     <a:bodyPr/>
                     <a:lstStyle/>
                     <a:p>
-                      <a:pPr marL="0" indent="0" algn="ctr">
+                      <a:pPr algn="ctr" indent="0" marL="0">
                         <a:buNone/>
                       </a:pPr>
                       <a:r>
@@ -5093,7 +5344,7 @@
                       </a:endParaRPr>
                     </a:p>
                   </a:txBody>
-                  <a:tcPr anchor="ctr">
+                  <a:tcPr marL="91440" marR="91440" marT="45720" marB="45720" anchor="ctr">
                     <a:lnL w="6350" cap="flat" cmpd="sng" algn="ctr">
                       <a:solidFill>
                         <a:srgbClr val="E2E8F0"/>
@@ -5140,7 +5391,7 @@
                     <a:bodyPr/>
                     <a:lstStyle/>
                     <a:p>
-                      <a:pPr marL="0" indent="0" algn="ctr">
+                      <a:pPr algn="ctr" indent="0" marL="0">
                         <a:buNone/>
                       </a:pPr>
                       <a:r>
@@ -5161,7 +5412,7 @@
                       </a:endParaRPr>
                     </a:p>
                   </a:txBody>
-                  <a:tcPr anchor="ctr">
+                  <a:tcPr marL="91440" marR="91440" marT="45720" marB="45720" anchor="ctr">
                     <a:lnL w="6350" cap="flat" cmpd="sng" algn="ctr">
                       <a:solidFill>
                         <a:srgbClr val="E2E8F0"/>
@@ -5203,11 +5454,6 @@
                     </a:solidFill>
                   </a:tcPr>
                 </a:tc>
-                <a:extLst>
-                  <a:ext uri="{0D108BD9-81ED-4DB2-BD59-A6C34878D82A}">
-                    <a16:rowId xmlns:a16="http://schemas.microsoft.com/office/drawing/2014/main" val="10000"/>
-                  </a:ext>
-                </a:extLst>
               </a:tr>
               <a:tr h="384048">
                 <a:tc>
@@ -5215,7 +5461,7 @@
                     <a:bodyPr/>
                     <a:lstStyle/>
                     <a:p>
-                      <a:pPr marL="0" indent="0" algn="ctr">
+                      <a:pPr algn="ctr" indent="0" marL="0">
                         <a:buNone/>
                       </a:pPr>
                       <a:r>
@@ -5236,7 +5482,7 @@
                       </a:endParaRPr>
                     </a:p>
                   </a:txBody>
-                  <a:tcPr anchor="ctr">
+                  <a:tcPr marL="91440" marR="91440" marT="45720" marB="45720" anchor="ctr">
                     <a:lnL w="6350" cap="flat" cmpd="sng" algn="ctr">
                       <a:solidFill>
                         <a:srgbClr val="E2E8F0"/>
@@ -5283,7 +5529,7 @@
                     <a:bodyPr/>
                     <a:lstStyle/>
                     <a:p>
-                      <a:pPr marL="0" indent="0" algn="ctr">
+                      <a:pPr algn="ctr" indent="0" marL="0">
                         <a:buNone/>
                       </a:pPr>
                       <a:r>
@@ -5304,7 +5550,7 @@
                       </a:endParaRPr>
                     </a:p>
                   </a:txBody>
-                  <a:tcPr anchor="ctr">
+                  <a:tcPr marL="91440" marR="91440" marT="45720" marB="45720" anchor="ctr">
                     <a:lnL w="6350" cap="flat" cmpd="sng" algn="ctr">
                       <a:solidFill>
                         <a:srgbClr val="E2E8F0"/>
@@ -5351,7 +5597,7 @@
                     <a:bodyPr/>
                     <a:lstStyle/>
                     <a:p>
-                      <a:pPr marL="0" indent="0" algn="ctr">
+                      <a:pPr algn="ctr" indent="0" marL="0">
                         <a:buNone/>
                       </a:pPr>
                       <a:r>
@@ -5372,7 +5618,7 @@
                       </a:endParaRPr>
                     </a:p>
                   </a:txBody>
-                  <a:tcPr anchor="ctr">
+                  <a:tcPr marL="91440" marR="91440" marT="45720" marB="45720" anchor="ctr">
                     <a:lnL w="6350" cap="flat" cmpd="sng" algn="ctr">
                       <a:solidFill>
                         <a:srgbClr val="E2E8F0"/>
@@ -5419,7 +5665,7 @@
                     <a:bodyPr/>
                     <a:lstStyle/>
                     <a:p>
-                      <a:pPr marL="0" indent="0" algn="ctr">
+                      <a:pPr algn="ctr" indent="0" marL="0">
                         <a:buNone/>
                       </a:pPr>
                       <a:r>
@@ -5440,7 +5686,7 @@
                       </a:endParaRPr>
                     </a:p>
                   </a:txBody>
-                  <a:tcPr anchor="ctr">
+                  <a:tcPr marL="91440" marR="91440" marT="45720" marB="45720" anchor="ctr">
                     <a:lnL w="6350" cap="flat" cmpd="sng" algn="ctr">
                       <a:solidFill>
                         <a:srgbClr val="E2E8F0"/>
@@ -5484,11 +5730,6 @@
                     </a:solidFill>
                   </a:tcPr>
                 </a:tc>
-                <a:extLst>
-                  <a:ext uri="{0D108BD9-81ED-4DB2-BD59-A6C34878D82A}">
-                    <a16:rowId xmlns:a16="http://schemas.microsoft.com/office/drawing/2014/main" val="10001"/>
-                  </a:ext>
-                </a:extLst>
               </a:tr>
               <a:tr h="384048">
                 <a:tc>
@@ -5496,7 +5737,7 @@
                     <a:bodyPr/>
                     <a:lstStyle/>
                     <a:p>
-                      <a:pPr marL="0" indent="0" algn="ctr">
+                      <a:pPr algn="ctr" indent="0" marL="0">
                         <a:buNone/>
                       </a:pPr>
                       <a:r>
@@ -5517,7 +5758,7 @@
                       </a:endParaRPr>
                     </a:p>
                   </a:txBody>
-                  <a:tcPr anchor="ctr">
+                  <a:tcPr marL="91440" marR="91440" marT="45720" marB="45720" anchor="ctr">
                     <a:lnL w="6350" cap="flat" cmpd="sng" algn="ctr">
                       <a:solidFill>
                         <a:srgbClr val="E2E8F0"/>
@@ -5564,7 +5805,7 @@
                     <a:bodyPr/>
                     <a:lstStyle/>
                     <a:p>
-                      <a:pPr marL="0" indent="0" algn="ctr">
+                      <a:pPr algn="ctr" indent="0" marL="0">
                         <a:buNone/>
                       </a:pPr>
                       <a:r>
@@ -5585,7 +5826,7 @@
                       </a:endParaRPr>
                     </a:p>
                   </a:txBody>
-                  <a:tcPr anchor="ctr">
+                  <a:tcPr marL="91440" marR="91440" marT="45720" marB="45720" anchor="ctr">
                     <a:lnL w="6350" cap="flat" cmpd="sng" algn="ctr">
                       <a:solidFill>
                         <a:srgbClr val="E2E8F0"/>
@@ -5632,7 +5873,7 @@
                     <a:bodyPr/>
                     <a:lstStyle/>
                     <a:p>
-                      <a:pPr marL="0" indent="0" algn="ctr">
+                      <a:pPr algn="ctr" indent="0" marL="0">
                         <a:buNone/>
                       </a:pPr>
                       <a:r>
@@ -5653,7 +5894,7 @@
                       </a:endParaRPr>
                     </a:p>
                   </a:txBody>
-                  <a:tcPr anchor="ctr">
+                  <a:tcPr marL="91440" marR="91440" marT="45720" marB="45720" anchor="ctr">
                     <a:lnL w="6350" cap="flat" cmpd="sng" algn="ctr">
                       <a:solidFill>
                         <a:srgbClr val="E2E8F0"/>
@@ -5700,7 +5941,7 @@
                     <a:bodyPr/>
                     <a:lstStyle/>
                     <a:p>
-                      <a:pPr marL="0" indent="0" algn="ctr">
+                      <a:pPr algn="ctr" indent="0" marL="0">
                         <a:buNone/>
                       </a:pPr>
                       <a:r>
@@ -5721,7 +5962,7 @@
                       </a:endParaRPr>
                     </a:p>
                   </a:txBody>
-                  <a:tcPr anchor="ctr">
+                  <a:tcPr marL="91440" marR="91440" marT="45720" marB="45720" anchor="ctr">
                     <a:lnL w="6350" cap="flat" cmpd="sng" algn="ctr">
                       <a:solidFill>
                         <a:srgbClr val="E2E8F0"/>
@@ -5765,11 +6006,6 @@
                     </a:solidFill>
                   </a:tcPr>
                 </a:tc>
-                <a:extLst>
-                  <a:ext uri="{0D108BD9-81ED-4DB2-BD59-A6C34878D82A}">
-                    <a16:rowId xmlns:a16="http://schemas.microsoft.com/office/drawing/2014/main" val="10002"/>
-                  </a:ext>
-                </a:extLst>
               </a:tr>
               <a:tr h="384048">
                 <a:tc>
@@ -5777,7 +6013,7 @@
                     <a:bodyPr/>
                     <a:lstStyle/>
                     <a:p>
-                      <a:pPr marL="0" indent="0" algn="ctr">
+                      <a:pPr algn="ctr" indent="0" marL="0">
                         <a:buNone/>
                       </a:pPr>
                       <a:r>
@@ -5798,7 +6034,7 @@
                       </a:endParaRPr>
                     </a:p>
                   </a:txBody>
-                  <a:tcPr anchor="ctr">
+                  <a:tcPr marL="91440" marR="91440" marT="45720" marB="45720" anchor="ctr">
                     <a:lnL w="6350" cap="flat" cmpd="sng" algn="ctr">
                       <a:solidFill>
                         <a:srgbClr val="E2E8F0"/>
@@ -5845,7 +6081,7 @@
                     <a:bodyPr/>
                     <a:lstStyle/>
                     <a:p>
-                      <a:pPr marL="0" indent="0" algn="ctr">
+                      <a:pPr algn="ctr" indent="0" marL="0">
                         <a:buNone/>
                       </a:pPr>
                       <a:r>
@@ -5866,7 +6102,7 @@
                       </a:endParaRPr>
                     </a:p>
                   </a:txBody>
-                  <a:tcPr anchor="ctr">
+                  <a:tcPr marL="91440" marR="91440" marT="45720" marB="45720" anchor="ctr">
                     <a:lnL w="6350" cap="flat" cmpd="sng" algn="ctr">
                       <a:solidFill>
                         <a:srgbClr val="E2E8F0"/>
@@ -5913,7 +6149,7 @@
                     <a:bodyPr/>
                     <a:lstStyle/>
                     <a:p>
-                      <a:pPr marL="0" indent="0" algn="ctr">
+                      <a:pPr algn="ctr" indent="0" marL="0">
                         <a:buNone/>
                       </a:pPr>
                       <a:r>
@@ -5934,7 +6170,7 @@
                       </a:endParaRPr>
                     </a:p>
                   </a:txBody>
-                  <a:tcPr anchor="ctr">
+                  <a:tcPr marL="91440" marR="91440" marT="45720" marB="45720" anchor="ctr">
                     <a:lnL w="6350" cap="flat" cmpd="sng" algn="ctr">
                       <a:solidFill>
                         <a:srgbClr val="E2E8F0"/>
@@ -5981,7 +6217,7 @@
                     <a:bodyPr/>
                     <a:lstStyle/>
                     <a:p>
-                      <a:pPr marL="0" indent="0" algn="ctr">
+                      <a:pPr algn="ctr" indent="0" marL="0">
                         <a:buNone/>
                       </a:pPr>
                       <a:r>
@@ -6002,7 +6238,7 @@
                       </a:endParaRPr>
                     </a:p>
                   </a:txBody>
-                  <a:tcPr anchor="ctr">
+                  <a:tcPr marL="91440" marR="91440" marT="45720" marB="45720" anchor="ctr">
                     <a:lnL w="6350" cap="flat" cmpd="sng" algn="ctr">
                       <a:solidFill>
                         <a:srgbClr val="E2E8F0"/>
@@ -6046,11 +6282,6 @@
                     </a:solidFill>
                   </a:tcPr>
                 </a:tc>
-                <a:extLst>
-                  <a:ext uri="{0D108BD9-81ED-4DB2-BD59-A6C34878D82A}">
-                    <a16:rowId xmlns:a16="http://schemas.microsoft.com/office/drawing/2014/main" val="10003"/>
-                  </a:ext>
-                </a:extLst>
               </a:tr>
               <a:tr h="384048">
                 <a:tc>
@@ -6058,7 +6289,7 @@
                     <a:bodyPr/>
                     <a:lstStyle/>
                     <a:p>
-                      <a:pPr marL="0" indent="0" algn="ctr">
+                      <a:pPr algn="ctr" indent="0" marL="0">
                         <a:buNone/>
                       </a:pPr>
                       <a:r>
@@ -6079,7 +6310,7 @@
                       </a:endParaRPr>
                     </a:p>
                   </a:txBody>
-                  <a:tcPr anchor="ctr">
+                  <a:tcPr marL="91440" marR="91440" marT="45720" marB="45720" anchor="ctr">
                     <a:lnL w="6350" cap="flat" cmpd="sng" algn="ctr">
                       <a:solidFill>
                         <a:srgbClr val="E2E8F0"/>
@@ -6126,7 +6357,7 @@
                     <a:bodyPr/>
                     <a:lstStyle/>
                     <a:p>
-                      <a:pPr marL="0" indent="0" algn="ctr">
+                      <a:pPr algn="ctr" indent="0" marL="0">
                         <a:buNone/>
                       </a:pPr>
                       <a:r>
@@ -6147,7 +6378,7 @@
                       </a:endParaRPr>
                     </a:p>
                   </a:txBody>
-                  <a:tcPr anchor="ctr">
+                  <a:tcPr marL="91440" marR="91440" marT="45720" marB="45720" anchor="ctr">
                     <a:lnL w="6350" cap="flat" cmpd="sng" algn="ctr">
                       <a:solidFill>
                         <a:srgbClr val="E2E8F0"/>
@@ -6194,7 +6425,7 @@
                     <a:bodyPr/>
                     <a:lstStyle/>
                     <a:p>
-                      <a:pPr marL="0" indent="0" algn="ctr">
+                      <a:pPr algn="ctr" indent="0" marL="0">
                         <a:buNone/>
                       </a:pPr>
                       <a:r>
@@ -6215,7 +6446,7 @@
                       </a:endParaRPr>
                     </a:p>
                   </a:txBody>
-                  <a:tcPr anchor="ctr">
+                  <a:tcPr marL="91440" marR="91440" marT="45720" marB="45720" anchor="ctr">
                     <a:lnL w="6350" cap="flat" cmpd="sng" algn="ctr">
                       <a:solidFill>
                         <a:srgbClr val="E2E8F0"/>
@@ -6262,7 +6493,7 @@
                     <a:bodyPr/>
                     <a:lstStyle/>
                     <a:p>
-                      <a:pPr marL="0" indent="0" algn="ctr">
+                      <a:pPr algn="ctr" indent="0" marL="0">
                         <a:buNone/>
                       </a:pPr>
                       <a:r>
@@ -6283,7 +6514,7 @@
                       </a:endParaRPr>
                     </a:p>
                   </a:txBody>
-                  <a:tcPr anchor="ctr">
+                  <a:tcPr marL="91440" marR="91440" marT="45720" marB="45720" anchor="ctr">
                     <a:lnL w="6350" cap="flat" cmpd="sng" algn="ctr">
                       <a:solidFill>
                         <a:srgbClr val="E2E8F0"/>
@@ -6327,11 +6558,6 @@
                     </a:solidFill>
                   </a:tcPr>
                 </a:tc>
-                <a:extLst>
-                  <a:ext uri="{0D108BD9-81ED-4DB2-BD59-A6C34878D82A}">
-                    <a16:rowId xmlns:a16="http://schemas.microsoft.com/office/drawing/2014/main" val="10004"/>
-                  </a:ext>
-                </a:extLst>
               </a:tr>
               <a:tr h="384048">
                 <a:tc>
@@ -6339,7 +6565,7 @@
                     <a:bodyPr/>
                     <a:lstStyle/>
                     <a:p>
-                      <a:pPr marL="0" indent="0" algn="ctr">
+                      <a:pPr algn="ctr" indent="0" marL="0">
                         <a:buNone/>
                       </a:pPr>
                       <a:r>
@@ -6360,7 +6586,7 @@
                       </a:endParaRPr>
                     </a:p>
                   </a:txBody>
-                  <a:tcPr anchor="ctr">
+                  <a:tcPr marL="91440" marR="91440" marT="45720" marB="45720" anchor="ctr">
                     <a:lnL w="6350" cap="flat" cmpd="sng" algn="ctr">
                       <a:solidFill>
                         <a:srgbClr val="E2E8F0"/>
@@ -6407,7 +6633,7 @@
                     <a:bodyPr/>
                     <a:lstStyle/>
                     <a:p>
-                      <a:pPr marL="0" indent="0" algn="ctr">
+                      <a:pPr algn="ctr" indent="0" marL="0">
                         <a:buNone/>
                       </a:pPr>
                       <a:r>
@@ -6428,7 +6654,7 @@
                       </a:endParaRPr>
                     </a:p>
                   </a:txBody>
-                  <a:tcPr anchor="ctr">
+                  <a:tcPr marL="91440" marR="91440" marT="45720" marB="45720" anchor="ctr">
                     <a:lnL w="6350" cap="flat" cmpd="sng" algn="ctr">
                       <a:solidFill>
                         <a:srgbClr val="E2E8F0"/>
@@ -6475,7 +6701,7 @@
                     <a:bodyPr/>
                     <a:lstStyle/>
                     <a:p>
-                      <a:pPr marL="0" indent="0" algn="ctr">
+                      <a:pPr algn="ctr" indent="0" marL="0">
                         <a:buNone/>
                       </a:pPr>
                       <a:r>
@@ -6496,7 +6722,7 @@
                       </a:endParaRPr>
                     </a:p>
                   </a:txBody>
-                  <a:tcPr anchor="ctr">
+                  <a:tcPr marL="91440" marR="91440" marT="45720" marB="45720" anchor="ctr">
                     <a:lnL w="6350" cap="flat" cmpd="sng" algn="ctr">
                       <a:solidFill>
                         <a:srgbClr val="E2E8F0"/>
@@ -6543,7 +6769,7 @@
                     <a:bodyPr/>
                     <a:lstStyle/>
                     <a:p>
-                      <a:pPr marL="0" indent="0" algn="ctr">
+                      <a:pPr algn="ctr" indent="0" marL="0">
                         <a:buNone/>
                       </a:pPr>
                       <a:r>
@@ -6564,7 +6790,7 @@
                       </a:endParaRPr>
                     </a:p>
                   </a:txBody>
-                  <a:tcPr anchor="ctr">
+                  <a:tcPr marL="91440" marR="91440" marT="45720" marB="45720" anchor="ctr">
                     <a:lnL w="6350" cap="flat" cmpd="sng" algn="ctr">
                       <a:solidFill>
                         <a:srgbClr val="E2E8F0"/>
@@ -6608,11 +6834,6 @@
                     </a:solidFill>
                   </a:tcPr>
                 </a:tc>
-                <a:extLst>
-                  <a:ext uri="{0D108BD9-81ED-4DB2-BD59-A6C34878D82A}">
-                    <a16:rowId xmlns:a16="http://schemas.microsoft.com/office/drawing/2014/main" val="10005"/>
-                  </a:ext>
-                </a:extLst>
               </a:tr>
               <a:tr h="384048">
                 <a:tc>
@@ -6620,7 +6841,7 @@
                     <a:bodyPr/>
                     <a:lstStyle/>
                     <a:p>
-                      <a:pPr marL="0" indent="0" algn="ctr">
+                      <a:pPr algn="ctr" indent="0" marL="0">
                         <a:buNone/>
                       </a:pPr>
                       <a:r>
@@ -6641,7 +6862,7 @@
                       </a:endParaRPr>
                     </a:p>
                   </a:txBody>
-                  <a:tcPr anchor="ctr">
+                  <a:tcPr marL="91440" marR="91440" marT="45720" marB="45720" anchor="ctr">
                     <a:lnL w="6350" cap="flat" cmpd="sng" algn="ctr">
                       <a:solidFill>
                         <a:srgbClr val="E2E8F0"/>
@@ -6688,7 +6909,7 @@
                     <a:bodyPr/>
                     <a:lstStyle/>
                     <a:p>
-                      <a:pPr marL="0" indent="0" algn="ctr">
+                      <a:pPr algn="ctr" indent="0" marL="0">
                         <a:buNone/>
                       </a:pPr>
                       <a:r>
@@ -6709,7 +6930,7 @@
                       </a:endParaRPr>
                     </a:p>
                   </a:txBody>
-                  <a:tcPr anchor="ctr">
+                  <a:tcPr marL="91440" marR="91440" marT="45720" marB="45720" anchor="ctr">
                     <a:lnL w="6350" cap="flat" cmpd="sng" algn="ctr">
                       <a:solidFill>
                         <a:srgbClr val="E2E8F0"/>
@@ -6756,7 +6977,7 @@
                     <a:bodyPr/>
                     <a:lstStyle/>
                     <a:p>
-                      <a:pPr marL="0" indent="0" algn="ctr">
+                      <a:pPr algn="ctr" indent="0" marL="0">
                         <a:buNone/>
                       </a:pPr>
                       <a:r>
@@ -6777,7 +6998,7 @@
                       </a:endParaRPr>
                     </a:p>
                   </a:txBody>
-                  <a:tcPr anchor="ctr">
+                  <a:tcPr marL="91440" marR="91440" marT="45720" marB="45720" anchor="ctr">
                     <a:lnL w="6350" cap="flat" cmpd="sng" algn="ctr">
                       <a:solidFill>
                         <a:srgbClr val="E2E8F0"/>
@@ -6824,7 +7045,7 @@
                     <a:bodyPr/>
                     <a:lstStyle/>
                     <a:p>
-                      <a:pPr marL="0" indent="0" algn="ctr">
+                      <a:pPr algn="ctr" indent="0" marL="0">
                         <a:buNone/>
                       </a:pPr>
                       <a:r>
@@ -6845,7 +7066,7 @@
                       </a:endParaRPr>
                     </a:p>
                   </a:txBody>
-                  <a:tcPr anchor="ctr">
+                  <a:tcPr marL="91440" marR="91440" marT="45720" marB="45720" anchor="ctr">
                     <a:lnL w="6350" cap="flat" cmpd="sng" algn="ctr">
                       <a:solidFill>
                         <a:srgbClr val="E2E8F0"/>
@@ -6889,11 +7110,6 @@
                     </a:solidFill>
                   </a:tcPr>
                 </a:tc>
-                <a:extLst>
-                  <a:ext uri="{0D108BD9-81ED-4DB2-BD59-A6C34878D82A}">
-                    <a16:rowId xmlns:a16="http://schemas.microsoft.com/office/drawing/2014/main" val="10006"/>
-                  </a:ext>
-                </a:extLst>
               </a:tr>
             </a:tbl>
           </a:graphicData>
@@ -6960,7 +7176,7 @@
           <a:bodyPr wrap="square" lIns="0" tIns="0" rIns="0" bIns="0" rtlCol="0" anchor="ctr"/>
           <a:lstStyle/>
           <a:p>
-            <a:pPr marL="0" indent="0">
+            <a:pPr indent="0" marL="0">
               <a:buNone/>
             </a:pPr>
             <a:r>
@@ -6994,7 +7210,6 @@
         <a:solidFill>
           <a:srgbClr val="F8FAFC"/>
         </a:solidFill>
-        <a:effectLst/>
       </p:bgPr>
     </p:bg>
     <p:spTree>
@@ -7052,7 +7267,7 @@
           <a:bodyPr wrap="square" lIns="0" tIns="0" rIns="0" bIns="0" rtlCol="0" anchor="ctr"/>
           <a:lstStyle/>
           <a:p>
-            <a:pPr marL="0" indent="0">
+            <a:pPr indent="0" marL="0">
               <a:buNone/>
             </a:pPr>
             <a:r>
@@ -7091,7 +7306,7 @@
           <a:bodyPr wrap="square" lIns="0" tIns="0" rIns="0" bIns="0" rtlCol="0" anchor="ctr"/>
           <a:lstStyle/>
           <a:p>
-            <a:pPr marL="0" indent="0">
+            <a:pPr indent="0" marL="0">
               <a:buNone/>
             </a:pPr>
             <a:r>
@@ -7150,7 +7365,7 @@
           <a:bodyPr wrap="square" lIns="0" tIns="0" rIns="0" bIns="0" rtlCol="0" anchor="ctr"/>
           <a:lstStyle/>
           <a:p>
-            <a:pPr marL="0" indent="0" algn="ctr">
+            <a:pPr algn="ctr" indent="0" marL="0">
               <a:buNone/>
             </a:pPr>
             <a:r>
@@ -7209,7 +7424,7 @@
           <a:bodyPr wrap="square" lIns="0" tIns="0" rIns="0" bIns="0" rtlCol="0" anchor="ctr"/>
           <a:lstStyle/>
           <a:p>
-            <a:pPr marL="0" indent="0" algn="ctr">
+            <a:pPr algn="ctr" indent="0" marL="0">
               <a:buNone/>
             </a:pPr>
             <a:r>
@@ -7268,7 +7483,7 @@
           <a:bodyPr wrap="square" lIns="0" tIns="0" rIns="0" bIns="0" rtlCol="0" anchor="ctr"/>
           <a:lstStyle/>
           <a:p>
-            <a:pPr marL="0" indent="0" algn="ctr">
+            <a:pPr algn="ctr" indent="0" marL="0">
               <a:buNone/>
             </a:pPr>
             <a:r>
@@ -7327,7 +7542,7 @@
           <a:bodyPr wrap="square" lIns="0" tIns="0" rIns="0" bIns="0" rtlCol="0" anchor="ctr"/>
           <a:lstStyle/>
           <a:p>
-            <a:pPr marL="0" indent="0" algn="ctr">
+            <a:pPr algn="ctr" indent="0" marL="0">
               <a:buNone/>
             </a:pPr>
             <a:r>
@@ -7366,7 +7581,7 @@
           <a:bodyPr wrap="square" lIns="0" tIns="0" rIns="0" bIns="0" rtlCol="0" anchor="ctr"/>
           <a:lstStyle/>
           <a:p>
-            <a:pPr marL="0" indent="0">
+            <a:pPr indent="0" marL="0">
               <a:buNone/>
             </a:pPr>
             <a:r>
@@ -7425,7 +7640,7 @@
           <a:bodyPr wrap="square" lIns="0" tIns="0" rIns="0" bIns="0" rtlCol="0" anchor="ctr"/>
           <a:lstStyle/>
           <a:p>
-            <a:pPr marL="0" indent="0">
+            <a:pPr indent="0" marL="0">
               <a:buNone/>
             </a:pPr>
             <a:r>
@@ -7484,7 +7699,7 @@
           <a:bodyPr wrap="square" lIns="0" tIns="0" rIns="0" bIns="0" rtlCol="0" anchor="ctr"/>
           <a:lstStyle/>
           <a:p>
-            <a:pPr marL="0" indent="0">
+            <a:pPr indent="0" marL="0">
               <a:buNone/>
             </a:pPr>
             <a:r>
@@ -7543,7 +7758,7 @@
           <a:bodyPr wrap="square" lIns="0" tIns="0" rIns="0" bIns="0" rtlCol="0" anchor="ctr"/>
           <a:lstStyle/>
           <a:p>
-            <a:pPr marL="0" indent="0">
+            <a:pPr indent="0" marL="0">
               <a:buNone/>
             </a:pPr>
             <a:r>
@@ -7577,7 +7792,6 @@
         <a:solidFill>
           <a:srgbClr val="0F172A"/>
         </a:solidFill>
-        <a:effectLst/>
       </p:bgPr>
     </p:bg>
     <p:spTree>
@@ -7659,7 +7873,7 @@
           <a:bodyPr wrap="square" lIns="0" tIns="0" rIns="0" bIns="0" rtlCol="0" anchor="ctr"/>
           <a:lstStyle/>
           <a:p>
-            <a:pPr marL="0" indent="0" algn="ctr">
+            <a:pPr algn="ctr" indent="0" marL="0">
               <a:buNone/>
             </a:pPr>
             <a:r>
@@ -7721,7 +7935,7 @@
           <a:bodyPr wrap="square" lIns="0" tIns="0" rIns="0" bIns="0" rtlCol="0" anchor="ctr"/>
           <a:lstStyle/>
           <a:p>
-            <a:pPr marL="0" indent="0" algn="ctr">
+            <a:pPr algn="ctr" indent="0" marL="0">
               <a:buNone/>
             </a:pPr>
             <a:r>
@@ -7760,7 +7974,7 @@
           <a:bodyPr wrap="square" lIns="0" tIns="0" rIns="0" bIns="0" rtlCol="0" anchor="ctr"/>
           <a:lstStyle/>
           <a:p>
-            <a:pPr marL="0" indent="0" algn="ctr">
+            <a:pPr algn="ctr" indent="0" marL="0">
               <a:buNone/>
             </a:pPr>
             <a:r>
@@ -7794,7 +8008,6 @@
         <a:solidFill>
           <a:srgbClr val="F8FAFC"/>
         </a:solidFill>
-        <a:effectLst/>
       </p:bgPr>
     </p:bg>
     <p:spTree>
@@ -7852,7 +8065,7 @@
           <a:bodyPr wrap="square" lIns="0" tIns="0" rIns="0" bIns="0" rtlCol="0" anchor="ctr"/>
           <a:lstStyle/>
           <a:p>
-            <a:pPr marL="0" indent="0">
+            <a:pPr indent="0" marL="0">
               <a:buNone/>
             </a:pPr>
             <a:r>
@@ -7891,7 +8104,7 @@
           <a:bodyPr wrap="square" lIns="0" tIns="0" rIns="0" bIns="0" rtlCol="0" anchor="ctr"/>
           <a:lstStyle/>
           <a:p>
-            <a:pPr marL="0" indent="0">
+            <a:pPr indent="0" marL="0">
               <a:buNone/>
             </a:pPr>
             <a:r>
@@ -7930,7 +8143,7 @@
           <a:bodyPr wrap="square" rtlCol="0" anchor="t"/>
           <a:lstStyle/>
           <a:p>
-            <a:pPr marL="0" indent="0">
+            <a:pPr indent="0" marL="0">
               <a:buNone/>
             </a:pPr>
             <a:r>
@@ -7947,7 +8160,7 @@
             <a:endParaRPr lang="en-US" sz="2000" dirty="0"/>
           </a:p>
           <a:p>
-            <a:pPr marL="0" indent="0">
+            <a:pPr indent="0" marL="0">
               <a:buNone/>
             </a:pPr>
             <a:r>
@@ -7961,7 +8174,7 @@
             <a:endParaRPr lang="en-US" sz="2000" dirty="0"/>
           </a:p>
           <a:p>
-            <a:pPr marL="0" indent="0">
+            <a:pPr indent="0" marL="0">
               <a:buNone/>
             </a:pPr>
             <a:r>
@@ -7978,7 +8191,7 @@
             <a:endParaRPr lang="en-US" sz="2000" dirty="0"/>
           </a:p>
           <a:p>
-            <a:pPr marL="0" indent="0">
+            <a:pPr indent="0" marL="0">
               <a:buNone/>
             </a:pPr>
             <a:r>
@@ -7995,7 +8208,7 @@
             <a:endParaRPr lang="en-US" sz="2000" dirty="0"/>
           </a:p>
           <a:p>
-            <a:pPr marL="0" indent="0">
+            <a:pPr indent="0" marL="0">
               <a:buNone/>
             </a:pPr>
             <a:r>
@@ -8009,7 +8222,7 @@
             <a:endParaRPr lang="en-US" sz="2000" dirty="0"/>
           </a:p>
           <a:p>
-            <a:pPr marL="0" indent="0">
+            <a:pPr indent="0" marL="0">
               <a:buNone/>
             </a:pPr>
             <a:r>
@@ -8026,7 +8239,7 @@
             <a:endParaRPr lang="en-US" sz="2000" dirty="0"/>
           </a:p>
           <a:p>
-            <a:pPr marL="0" indent="0">
+            <a:pPr indent="0" marL="0">
               <a:buNone/>
             </a:pPr>
             <a:r>
@@ -8114,7 +8327,7 @@
           </a:solidFill>
           <a:ln/>
           <a:effectLst>
-            <a:outerShdw blurRad="76200" dist="25400" dir="8100000" algn="bl" rotWithShape="0">
+            <a:outerShdw sx="100000" sy="100000" kx="0" ky="0" algn="bl" rotWithShape="0" blurRad="76200" dist="25400" dir="8100000">
               <a:srgbClr val="000000">
                 <a:alpha val="10000"/>
               </a:srgbClr>
@@ -8163,7 +8376,7 @@
           <a:bodyPr wrap="square" lIns="0" tIns="0" rIns="0" bIns="0" rtlCol="0" anchor="ctr"/>
           <a:lstStyle/>
           <a:p>
-            <a:pPr marL="0" indent="0">
+            <a:pPr indent="0" marL="0">
               <a:buNone/>
             </a:pPr>
             <a:r>
@@ -8222,7 +8435,7 @@
           <a:bodyPr wrap="square" rtlCol="0" anchor="t"/>
           <a:lstStyle/>
           <a:p>
-            <a:pPr marL="0" indent="0">
+            <a:pPr indent="0" marL="0">
               <a:buNone/>
             </a:pPr>
             <a:r>
@@ -8239,7 +8452,7 @@
             <a:endParaRPr lang="en-US" sz="1000" dirty="0"/>
           </a:p>
           <a:p>
-            <a:pPr marL="0" indent="0">
+            <a:pPr indent="0" marL="0">
               <a:buNone/>
             </a:pPr>
             <a:r>
@@ -8256,7 +8469,7 @@
             <a:endParaRPr lang="en-US" sz="1000" dirty="0"/>
           </a:p>
           <a:p>
-            <a:pPr marL="0" indent="0">
+            <a:pPr indent="0" marL="0">
               <a:buNone/>
             </a:pPr>
             <a:r>
@@ -8270,7 +8483,7 @@
             <a:endParaRPr lang="en-US" sz="1000" dirty="0"/>
           </a:p>
           <a:p>
-            <a:pPr marL="0" indent="0">
+            <a:pPr indent="0" marL="0">
               <a:buNone/>
             </a:pPr>
             <a:r>
@@ -8287,7 +8500,7 @@
             <a:endParaRPr lang="en-US" sz="1000" dirty="0"/>
           </a:p>
           <a:p>
-            <a:pPr marL="0" indent="0">
+            <a:pPr indent="0" marL="0">
               <a:buNone/>
             </a:pPr>
             <a:r>
@@ -8321,7 +8534,6 @@
         <a:solidFill>
           <a:srgbClr val="F8FAFC"/>
         </a:solidFill>
-        <a:effectLst/>
       </p:bgPr>
     </p:bg>
     <p:spTree>
@@ -8379,7 +8591,7 @@
           <a:bodyPr wrap="square" lIns="0" tIns="0" rIns="0" bIns="0" rtlCol="0" anchor="ctr"/>
           <a:lstStyle/>
           <a:p>
-            <a:pPr marL="0" indent="0">
+            <a:pPr indent="0" marL="0">
               <a:buNone/>
             </a:pPr>
             <a:r>
@@ -8418,7 +8630,7 @@
           <a:bodyPr wrap="square" lIns="0" tIns="0" rIns="0" bIns="0" rtlCol="0" anchor="ctr"/>
           <a:lstStyle/>
           <a:p>
-            <a:pPr marL="0" indent="0">
+            <a:pPr indent="0" marL="0">
               <a:buNone/>
             </a:pPr>
             <a:r>
@@ -8455,7 +8667,7 @@
           </a:solidFill>
           <a:ln/>
           <a:effectLst>
-            <a:outerShdw blurRad="76200" dist="25400" dir="8100000" algn="bl" rotWithShape="0">
+            <a:outerShdw sx="100000" sy="100000" kx="0" ky="0" algn="bl" rotWithShape="0" blurRad="76200" dist="25400" dir="8100000">
               <a:srgbClr val="000000">
                 <a:alpha val="10000"/>
               </a:srgbClr>
@@ -8504,7 +8716,7 @@
           <a:bodyPr wrap="square" lIns="0" tIns="0" rIns="0" bIns="0" rtlCol="0" anchor="ctr"/>
           <a:lstStyle/>
           <a:p>
-            <a:pPr marL="0" indent="0">
+            <a:pPr indent="0" marL="0">
               <a:buNone/>
             </a:pPr>
             <a:r>
@@ -8543,7 +8755,7 @@
           <a:bodyPr wrap="square" lIns="0" tIns="0" rIns="0" bIns="0" rtlCol="0" anchor="t"/>
           <a:lstStyle/>
           <a:p>
-            <a:pPr marL="0" indent="0">
+            <a:pPr indent="0" marL="0">
               <a:buNone/>
             </a:pPr>
             <a:r>
@@ -8560,7 +8772,7 @@
             <a:endParaRPr lang="en-US" sz="1300" dirty="0"/>
           </a:p>
           <a:p>
-            <a:pPr marL="0" indent="0">
+            <a:pPr indent="0" marL="0">
               <a:buNone/>
             </a:pPr>
             <a:r>
@@ -8577,7 +8789,7 @@
             <a:endParaRPr lang="en-US" sz="1300" dirty="0"/>
           </a:p>
           <a:p>
-            <a:pPr marL="0" indent="0">
+            <a:pPr indent="0" marL="0">
               <a:buNone/>
             </a:pPr>
             <a:r>
@@ -8614,7 +8826,7 @@
           </a:solidFill>
           <a:ln/>
           <a:effectLst>
-            <a:outerShdw blurRad="76200" dist="25400" dir="8100000" algn="bl" rotWithShape="0">
+            <a:outerShdw sx="100000" sy="100000" kx="0" ky="0" algn="bl" rotWithShape="0" blurRad="76200" dist="25400" dir="8100000">
               <a:srgbClr val="000000">
                 <a:alpha val="10000"/>
               </a:srgbClr>
@@ -8663,7 +8875,7 @@
           <a:bodyPr wrap="square" lIns="0" tIns="0" rIns="0" bIns="0" rtlCol="0" anchor="ctr"/>
           <a:lstStyle/>
           <a:p>
-            <a:pPr marL="0" indent="0">
+            <a:pPr indent="0" marL="0">
               <a:buNone/>
             </a:pPr>
             <a:r>
@@ -8702,7 +8914,7 @@
           <a:bodyPr wrap="square" lIns="0" tIns="0" rIns="0" bIns="0" rtlCol="0" anchor="t"/>
           <a:lstStyle/>
           <a:p>
-            <a:pPr marL="0" indent="0">
+            <a:pPr indent="0" marL="0">
               <a:buNone/>
             </a:pPr>
             <a:r>
@@ -8719,7 +8931,7 @@
             <a:endParaRPr lang="en-US" sz="1300" dirty="0"/>
           </a:p>
           <a:p>
-            <a:pPr marL="0" indent="0">
+            <a:pPr indent="0" marL="0">
               <a:buNone/>
             </a:pPr>
             <a:r>
@@ -8736,7 +8948,7 @@
             <a:endParaRPr lang="en-US" sz="1300" dirty="0"/>
           </a:p>
           <a:p>
-            <a:pPr marL="0" indent="0">
+            <a:pPr indent="0" marL="0">
               <a:buNone/>
             </a:pPr>
             <a:r>
@@ -8773,7 +8985,7 @@
           </a:solidFill>
           <a:ln/>
           <a:effectLst>
-            <a:outerShdw blurRad="76200" dist="25400" dir="8100000" algn="bl" rotWithShape="0">
+            <a:outerShdw sx="100000" sy="100000" kx="0" ky="0" algn="bl" rotWithShape="0" blurRad="76200" dist="25400" dir="8100000">
               <a:srgbClr val="000000">
                 <a:alpha val="10000"/>
               </a:srgbClr>
@@ -8822,7 +9034,7 @@
           <a:bodyPr wrap="square" lIns="0" tIns="0" rIns="0" bIns="0" rtlCol="0" anchor="ctr"/>
           <a:lstStyle/>
           <a:p>
-            <a:pPr marL="0" indent="0">
+            <a:pPr indent="0" marL="0">
               <a:buNone/>
             </a:pPr>
             <a:r>
@@ -8861,7 +9073,7 @@
           <a:bodyPr wrap="square" lIns="0" tIns="0" rIns="0" bIns="0" rtlCol="0" anchor="t"/>
           <a:lstStyle/>
           <a:p>
-            <a:pPr marL="0" indent="0">
+            <a:pPr indent="0" marL="0">
               <a:buNone/>
             </a:pPr>
             <a:r>
@@ -8878,7 +9090,7 @@
             <a:endParaRPr lang="en-US" sz="1300" dirty="0"/>
           </a:p>
           <a:p>
-            <a:pPr marL="0" indent="0">
+            <a:pPr indent="0" marL="0">
               <a:buNone/>
             </a:pPr>
             <a:r>
@@ -8895,7 +9107,7 @@
             <a:endParaRPr lang="en-US" sz="1300" dirty="0"/>
           </a:p>
           <a:p>
-            <a:pPr marL="0" indent="0">
+            <a:pPr indent="0" marL="0">
               <a:buNone/>
             </a:pPr>
             <a:r>
@@ -8934,7 +9146,7 @@
           <a:bodyPr wrap="square" lIns="0" tIns="0" rIns="0" bIns="0" rtlCol="0" anchor="ctr"/>
           <a:lstStyle/>
           <a:p>
-            <a:pPr marL="0" indent="0" algn="ctr">
+            <a:pPr algn="ctr" indent="0" marL="0">
               <a:buNone/>
             </a:pPr>
             <a:r>
@@ -8968,7 +9180,6 @@
         <a:solidFill>
           <a:srgbClr val="0F172A"/>
         </a:solidFill>
-        <a:effectLst/>
       </p:bgPr>
     </p:bg>
     <p:spTree>
@@ -9028,7 +9239,7 @@
           <a:bodyPr wrap="square" lIns="0" tIns="0" rIns="0" bIns="0" rtlCol="0" anchor="ctr"/>
           <a:lstStyle/>
           <a:p>
-            <a:pPr marL="0" indent="0">
+            <a:pPr indent="0" marL="0">
               <a:buNone/>
             </a:pPr>
             <a:r>
@@ -9067,7 +9278,7 @@
           <a:bodyPr wrap="square" lIns="0" tIns="0" rIns="0" bIns="0" rtlCol="0" anchor="ctr"/>
           <a:lstStyle/>
           <a:p>
-            <a:pPr marL="0" indent="0">
+            <a:pPr indent="0" marL="0">
               <a:buNone/>
             </a:pPr>
             <a:r>
@@ -9146,7 +9357,7 @@
           <a:bodyPr wrap="square" lIns="0" tIns="0" rIns="0" bIns="0" rtlCol="0" anchor="ctr"/>
           <a:lstStyle/>
           <a:p>
-            <a:pPr marL="0" indent="0" algn="ctr">
+            <a:pPr algn="ctr" indent="0" marL="0">
               <a:buNone/>
             </a:pPr>
             <a:r>
@@ -9185,7 +9396,7 @@
           <a:bodyPr wrap="square" lIns="0" tIns="0" rIns="0" bIns="0" rtlCol="0" anchor="ctr"/>
           <a:lstStyle/>
           <a:p>
-            <a:pPr marL="0" indent="0" algn="ctr">
+            <a:pPr algn="ctr" indent="0" marL="0">
               <a:buNone/>
             </a:pPr>
             <a:r>
@@ -9224,7 +9435,7 @@
           <a:bodyPr wrap="square" lIns="0" tIns="0" rIns="0" bIns="0" rtlCol="0" anchor="ctr"/>
           <a:lstStyle/>
           <a:p>
-            <a:pPr marL="0" indent="0" algn="ctr">
+            <a:pPr algn="ctr" indent="0" marL="0">
               <a:buNone/>
             </a:pPr>
             <a:r>
@@ -9241,7 +9452,7 @@
             <a:endParaRPr lang="en-US" sz="1200" dirty="0"/>
           </a:p>
           <a:p>
-            <a:pPr marL="0" indent="0" algn="ctr">
+            <a:pPr algn="ctr" indent="0" marL="0">
               <a:buNone/>
             </a:pPr>
             <a:r>
@@ -9280,7 +9491,7 @@
           <a:bodyPr wrap="square" lIns="0" tIns="0" rIns="0" bIns="0" rtlCol="0" anchor="ctr"/>
           <a:lstStyle/>
           <a:p>
-            <a:pPr marL="0" indent="0" algn="ctr">
+            <a:pPr algn="ctr" indent="0" marL="0">
               <a:buNone/>
             </a:pPr>
             <a:r>
@@ -9356,7 +9567,7 @@
           <a:bodyPr wrap="square" lIns="0" tIns="0" rIns="0" bIns="0" rtlCol="0" anchor="ctr"/>
           <a:lstStyle/>
           <a:p>
-            <a:pPr marL="0" indent="0" algn="ctr">
+            <a:pPr algn="ctr" indent="0" marL="0">
               <a:buNone/>
             </a:pPr>
             <a:r>
@@ -9395,7 +9606,7 @@
           <a:bodyPr wrap="square" lIns="0" tIns="0" rIns="0" bIns="0" rtlCol="0" anchor="ctr"/>
           <a:lstStyle/>
           <a:p>
-            <a:pPr marL="0" indent="0" algn="ctr">
+            <a:pPr algn="ctr" indent="0" marL="0">
               <a:buNone/>
             </a:pPr>
             <a:r>
@@ -9434,7 +9645,7 @@
           <a:bodyPr wrap="square" lIns="0" tIns="0" rIns="0" bIns="0" rtlCol="0" anchor="ctr"/>
           <a:lstStyle/>
           <a:p>
-            <a:pPr marL="0" indent="0" algn="ctr">
+            <a:pPr algn="ctr" indent="0" marL="0">
               <a:buNone/>
             </a:pPr>
             <a:r>
@@ -9451,7 +9662,7 @@
             <a:endParaRPr lang="en-US" sz="1200" dirty="0"/>
           </a:p>
           <a:p>
-            <a:pPr marL="0" indent="0" algn="ctr">
+            <a:pPr algn="ctr" indent="0" marL="0">
               <a:buNone/>
             </a:pPr>
             <a:r>
@@ -9490,7 +9701,7 @@
           <a:bodyPr wrap="square" lIns="0" tIns="0" rIns="0" bIns="0" rtlCol="0" anchor="ctr"/>
           <a:lstStyle/>
           <a:p>
-            <a:pPr marL="0" indent="0" algn="ctr">
+            <a:pPr algn="ctr" indent="0" marL="0">
               <a:buNone/>
             </a:pPr>
             <a:r>
@@ -9568,7 +9779,7 @@
           <a:bodyPr wrap="square" lIns="0" tIns="0" rIns="0" bIns="0" rtlCol="0" anchor="ctr"/>
           <a:lstStyle/>
           <a:p>
-            <a:pPr marL="0" indent="0" algn="ctr">
+            <a:pPr algn="ctr" indent="0" marL="0">
               <a:buNone/>
             </a:pPr>
             <a:r>
@@ -9607,7 +9818,7 @@
           <a:bodyPr wrap="square" lIns="0" tIns="0" rIns="0" bIns="0" rtlCol="0" anchor="ctr"/>
           <a:lstStyle/>
           <a:p>
-            <a:pPr marL="0" indent="0" algn="ctr">
+            <a:pPr algn="ctr" indent="0" marL="0">
               <a:buNone/>
             </a:pPr>
             <a:r>
@@ -9646,7 +9857,7 @@
           <a:bodyPr wrap="square" lIns="0" tIns="0" rIns="0" bIns="0" rtlCol="0" anchor="ctr"/>
           <a:lstStyle/>
           <a:p>
-            <a:pPr marL="0" indent="0" algn="ctr">
+            <a:pPr algn="ctr" indent="0" marL="0">
               <a:buNone/>
             </a:pPr>
             <a:r>
@@ -9663,7 +9874,7 @@
             <a:endParaRPr lang="en-US" sz="1200" dirty="0"/>
           </a:p>
           <a:p>
-            <a:pPr marL="0" indent="0" algn="ctr">
+            <a:pPr algn="ctr" indent="0" marL="0">
               <a:buNone/>
             </a:pPr>
             <a:r>
@@ -9702,7 +9913,7 @@
           <a:bodyPr wrap="square" lIns="0" tIns="0" rIns="0" bIns="0" rtlCol="0" anchor="ctr"/>
           <a:lstStyle/>
           <a:p>
-            <a:pPr marL="0" indent="0" algn="ctr">
+            <a:pPr algn="ctr" indent="0" marL="0">
               <a:buNone/>
             </a:pPr>
             <a:r>
@@ -9736,7 +9947,6 @@
         <a:solidFill>
           <a:srgbClr val="F8FAFC"/>
         </a:solidFill>
-        <a:effectLst/>
       </p:bgPr>
     </p:bg>
     <p:spTree>
@@ -9794,11 +10004,11 @@
           <a:bodyPr wrap="square" lIns="0" tIns="0" rIns="0" bIns="0" rtlCol="0" anchor="ctr"/>
           <a:lstStyle/>
           <a:p>
-            <a:pPr marL="0" indent="0">
-              <a:buNone/>
-            </a:pPr>
-            <a:r>
-              <a:rPr lang="en-US" sz="2800" dirty="0">
+            <a:pPr indent="0" marL="0">
+              <a:buNone/>
+            </a:pPr>
+            <a:r>
+              <a:rPr lang="en-US" sz="3600" dirty="0">
                 <a:solidFill>
                   <a:srgbClr val="1E293B"/>
                 </a:solidFill>
@@ -9808,7 +10018,7 @@
               </a:rPr>
               <a:t>Rules — Project-Level Instructions</a:t>
             </a:r>
-            <a:endParaRPr lang="en-US" sz="2800" dirty="0"/>
+            <a:endParaRPr lang="en-US" sz="3600" dirty="0"/>
           </a:p>
         </p:txBody>
       </p:sp>
@@ -9820,7 +10030,7 @@
         </p:nvSpPr>
         <p:spPr>
           <a:xfrm>
-            <a:off x="640080" y="1097280"/>
+            <a:off x="640080" y="868680"/>
             <a:ext cx="7315200" cy="320040"/>
           </a:xfrm>
           <a:prstGeom prst="rect">
@@ -9833,7 +10043,7 @@
           <a:bodyPr wrap="square" lIns="0" tIns="0" rIns="0" bIns="0" rtlCol="0" anchor="ctr"/>
           <a:lstStyle/>
           <a:p>
-            <a:pPr marL="0" indent="0">
+            <a:pPr indent="0" marL="0">
               <a:buNone/>
             </a:pPr>
             <a:r>
@@ -9870,7 +10080,7 @@
           </a:solidFill>
           <a:ln/>
           <a:effectLst>
-            <a:outerShdw blurRad="38100" dist="12700" dir="8100000" algn="bl" rotWithShape="0">
+            <a:outerShdw sx="100000" sy="100000" kx="0" ky="0" algn="bl" rotWithShape="0" blurRad="38100" dist="12700" dir="8100000">
               <a:srgbClr val="000000">
                 <a:alpha val="6000"/>
               </a:srgbClr>
@@ -9919,7 +10129,7 @@
           <a:bodyPr wrap="square" lIns="0" tIns="0" rIns="0" bIns="0" rtlCol="0" anchor="ctr"/>
           <a:lstStyle/>
           <a:p>
-            <a:pPr marL="0" indent="0">
+            <a:pPr indent="0" marL="0">
               <a:buNone/>
             </a:pPr>
             <a:r>
@@ -9958,7 +10168,7 @@
           <a:bodyPr wrap="square" lIns="0" tIns="0" rIns="0" bIns="0" rtlCol="0" anchor="ctr"/>
           <a:lstStyle/>
           <a:p>
-            <a:pPr marL="0" indent="0">
+            <a:pPr indent="0" marL="0">
               <a:buNone/>
             </a:pPr>
             <a:r>
@@ -9975,7 +10185,7 @@
             <a:endParaRPr lang="en-US" sz="1300" dirty="0"/>
           </a:p>
           <a:p>
-            <a:pPr marL="0" indent="0">
+            <a:pPr indent="0" marL="0">
               <a:buNone/>
             </a:pPr>
             <a:r>
@@ -10012,7 +10222,7 @@
           </a:solidFill>
           <a:ln/>
           <a:effectLst>
-            <a:outerShdw blurRad="38100" dist="12700" dir="8100000" algn="bl" rotWithShape="0">
+            <a:outerShdw sx="100000" sy="100000" kx="0" ky="0" algn="bl" rotWithShape="0" blurRad="38100" dist="12700" dir="8100000">
               <a:srgbClr val="000000">
                 <a:alpha val="6000"/>
               </a:srgbClr>
@@ -10061,7 +10271,7 @@
           <a:bodyPr wrap="square" lIns="0" tIns="0" rIns="0" bIns="0" rtlCol="0" anchor="ctr"/>
           <a:lstStyle/>
           <a:p>
-            <a:pPr marL="0" indent="0">
+            <a:pPr indent="0" marL="0">
               <a:buNone/>
             </a:pPr>
             <a:r>
@@ -10100,7 +10310,7 @@
           <a:bodyPr wrap="square" lIns="0" tIns="0" rIns="0" bIns="0" rtlCol="0" anchor="ctr"/>
           <a:lstStyle/>
           <a:p>
-            <a:pPr marL="0" indent="0">
+            <a:pPr indent="0" marL="0">
               <a:buNone/>
             </a:pPr>
             <a:r>
@@ -10117,7 +10327,7 @@
             <a:endParaRPr lang="en-US" sz="1300" dirty="0"/>
           </a:p>
           <a:p>
-            <a:pPr marL="0" indent="0">
+            <a:pPr indent="0" marL="0">
               <a:buNone/>
             </a:pPr>
             <a:r>
@@ -10154,7 +10364,7 @@
           </a:solidFill>
           <a:ln/>
           <a:effectLst>
-            <a:outerShdw blurRad="38100" dist="12700" dir="8100000" algn="bl" rotWithShape="0">
+            <a:outerShdw sx="100000" sy="100000" kx="0" ky="0" algn="bl" rotWithShape="0" blurRad="38100" dist="12700" dir="8100000">
               <a:srgbClr val="000000">
                 <a:alpha val="6000"/>
               </a:srgbClr>
@@ -10203,7 +10413,7 @@
           <a:bodyPr wrap="square" lIns="0" tIns="0" rIns="0" bIns="0" rtlCol="0" anchor="ctr"/>
           <a:lstStyle/>
           <a:p>
-            <a:pPr marL="0" indent="0">
+            <a:pPr indent="0" marL="0">
               <a:buNone/>
             </a:pPr>
             <a:r>
@@ -10242,7 +10452,7 @@
           <a:bodyPr wrap="square" lIns="0" tIns="0" rIns="0" bIns="0" rtlCol="0" anchor="ctr"/>
           <a:lstStyle/>
           <a:p>
-            <a:pPr marL="0" indent="0">
+            <a:pPr indent="0" marL="0">
               <a:buNone/>
             </a:pPr>
             <a:r>
@@ -10259,7 +10469,7 @@
             <a:endParaRPr lang="en-US" sz="1300" dirty="0"/>
           </a:p>
           <a:p>
-            <a:pPr marL="0" indent="0">
+            <a:pPr indent="0" marL="0">
               <a:buNone/>
             </a:pPr>
             <a:r>
@@ -10318,7 +10528,7 @@
           <a:bodyPr wrap="square" rtlCol="0" anchor="t"/>
           <a:lstStyle/>
           <a:p>
-            <a:pPr marL="0" indent="0">
+            <a:pPr indent="0" marL="0">
               <a:buNone/>
             </a:pPr>
             <a:r>
@@ -10330,12 +10540,12 @@
                 <a:ea typeface="Consolas" pitchFamily="34" charset="-122"/>
                 <a:cs typeface="Consolas" pitchFamily="34" charset="-120"/>
               </a:rPr>
-              <a:t>.windsurf/rules/logdash.md</a:t>
+              <a:t>.devin/rules/logdash.md</a:t>
             </a:r>
             <a:endParaRPr lang="en-US" sz="1100" dirty="0"/>
           </a:p>
           <a:p>
-            <a:pPr marL="0" indent="0">
+            <a:pPr indent="0" marL="0">
               <a:buNone/>
             </a:pPr>
             <a:r>
@@ -10349,7 +10559,7 @@
             <a:endParaRPr lang="en-US" sz="1100" dirty="0"/>
           </a:p>
           <a:p>
-            <a:pPr marL="0" indent="0">
+            <a:pPr indent="0" marL="0">
               <a:buNone/>
             </a:pPr>
             <a:r>
@@ -10366,7 +10576,7 @@
             <a:endParaRPr lang="en-US" sz="1100" dirty="0"/>
           </a:p>
           <a:p>
-            <a:pPr marL="0" indent="0">
+            <a:pPr indent="0" marL="0">
               <a:buNone/>
             </a:pPr>
             <a:r>
@@ -10383,7 +10593,7 @@
             <a:endParaRPr lang="en-US" sz="1100" dirty="0"/>
           </a:p>
           <a:p>
-            <a:pPr marL="0" indent="0">
+            <a:pPr indent="0" marL="0">
               <a:buNone/>
             </a:pPr>
             <a:r>
@@ -10400,7 +10610,7 @@
             <a:endParaRPr lang="en-US" sz="1100" dirty="0"/>
           </a:p>
           <a:p>
-            <a:pPr marL="0" indent="0">
+            <a:pPr indent="0" marL="0">
               <a:buNone/>
             </a:pPr>
             <a:r>
@@ -10414,7 +10624,7 @@
             <a:endParaRPr lang="en-US" sz="1100" dirty="0"/>
           </a:p>
           <a:p>
-            <a:pPr marL="0" indent="0">
+            <a:pPr indent="0" marL="0">
               <a:buNone/>
             </a:pPr>
             <a:r>
@@ -10431,7 +10641,7 @@
             <a:endParaRPr lang="en-US" sz="1100" dirty="0"/>
           </a:p>
           <a:p>
-            <a:pPr marL="0" indent="0">
+            <a:pPr indent="0" marL="0">
               <a:buNone/>
             </a:pPr>
             <a:r>
@@ -10448,7 +10658,7 @@
             <a:endParaRPr lang="en-US" sz="1100" dirty="0"/>
           </a:p>
           <a:p>
-            <a:pPr marL="0" indent="0">
+            <a:pPr indent="0" marL="0">
               <a:buNone/>
             </a:pPr>
             <a:r>
@@ -10465,7 +10675,7 @@
             <a:endParaRPr lang="en-US" sz="1100" dirty="0"/>
           </a:p>
           <a:p>
-            <a:pPr marL="0" indent="0">
+            <a:pPr indent="0" marL="0">
               <a:buNone/>
             </a:pPr>
             <a:r>
@@ -10479,7 +10689,7 @@
             <a:endParaRPr lang="en-US" sz="1100" dirty="0"/>
           </a:p>
           <a:p>
-            <a:pPr marL="0" indent="0">
+            <a:pPr indent="0" marL="0">
               <a:buNone/>
             </a:pPr>
             <a:r>
@@ -10496,7 +10706,7 @@
             <a:endParaRPr lang="en-US" sz="1100" dirty="0"/>
           </a:p>
           <a:p>
-            <a:pPr marL="0" indent="0">
+            <a:pPr indent="0" marL="0">
               <a:buNone/>
             </a:pPr>
             <a:r>
@@ -10513,7 +10723,7 @@
             <a:endParaRPr lang="en-US" sz="1100" dirty="0"/>
           </a:p>
           <a:p>
-            <a:pPr marL="0" indent="0">
+            <a:pPr indent="0" marL="0">
               <a:buNone/>
             </a:pPr>
             <a:r>
@@ -10527,7 +10737,7 @@
             <a:endParaRPr lang="en-US" sz="1100" dirty="0"/>
           </a:p>
           <a:p>
-            <a:pPr marL="0" indent="0">
+            <a:pPr indent="0" marL="0">
               <a:buNone/>
             </a:pPr>
             <a:r>
@@ -10544,7 +10754,7 @@
             <a:endParaRPr lang="en-US" sz="1100" dirty="0"/>
           </a:p>
           <a:p>
-            <a:pPr marL="0" indent="0">
+            <a:pPr indent="0" marL="0">
               <a:buNone/>
             </a:pPr>
             <a:r>
@@ -10561,7 +10771,7 @@
             <a:endParaRPr lang="en-US" sz="1100" dirty="0"/>
           </a:p>
           <a:p>
-            <a:pPr marL="0" indent="0">
+            <a:pPr indent="0" marL="0">
               <a:buNone/>
             </a:pPr>
             <a:r>
@@ -10595,7 +10805,6 @@
         <a:solidFill>
           <a:srgbClr val="F8FAFC"/>
         </a:solidFill>
-        <a:effectLst/>
       </p:bgPr>
     </p:bg>
     <p:spTree>
@@ -10653,7 +10862,7 @@
           <a:bodyPr wrap="square" lIns="0" tIns="0" rIns="0" bIns="0" rtlCol="0" anchor="ctr"/>
           <a:lstStyle/>
           <a:p>
-            <a:pPr marL="0" indent="0">
+            <a:pPr indent="0" marL="0">
               <a:buNone/>
             </a:pPr>
             <a:r>
@@ -10712,7 +10921,7 @@
           <a:bodyPr wrap="square" lIns="0" tIns="0" rIns="0" bIns="0" rtlCol="0" anchor="ctr"/>
           <a:lstStyle/>
           <a:p>
-            <a:pPr marL="0" indent="0" algn="ctr">
+            <a:pPr algn="ctr" indent="0" marL="0">
               <a:buNone/>
             </a:pPr>
             <a:r>
@@ -10751,7 +10960,7 @@
           <a:bodyPr wrap="square" lIns="0" tIns="0" rIns="0" bIns="0" rtlCol="0" anchor="ctr"/>
           <a:lstStyle/>
           <a:p>
-            <a:pPr marL="0" indent="0">
+            <a:pPr indent="0" marL="0">
               <a:buNone/>
             </a:pPr>
             <a:r>
@@ -10763,12 +10972,12 @@
                 <a:ea typeface="Calibri" pitchFamily="34" charset="-122"/>
                 <a:cs typeface="Calibri" pitchFamily="34" charset="-120"/>
               </a:rPr>
-              <a:t>Create .windsurf/rules/logdash.md</a:t>
+              <a:t>Create .devin/rules/logdash.md</a:t>
             </a:r>
             <a:endParaRPr lang="en-US" sz="1400" dirty="0"/>
           </a:p>
           <a:p>
-            <a:pPr marL="0" indent="0">
+            <a:pPr indent="0" marL="0">
               <a:buNone/>
             </a:pPr>
             <a:r>
@@ -10850,7 +11059,7 @@
           <a:bodyPr wrap="square" lIns="0" tIns="0" rIns="0" bIns="0" rtlCol="0" anchor="ctr"/>
           <a:lstStyle/>
           <a:p>
-            <a:pPr marL="0" indent="0" algn="ctr">
+            <a:pPr algn="ctr" indent="0" marL="0">
               <a:buNone/>
             </a:pPr>
             <a:r>
@@ -10889,7 +11098,7 @@
           <a:bodyPr wrap="square" lIns="0" tIns="0" rIns="0" bIns="0" rtlCol="0" anchor="ctr"/>
           <a:lstStyle/>
           <a:p>
-            <a:pPr marL="0" indent="0">
+            <a:pPr indent="0" marL="0">
               <a:buNone/>
             </a:pPr>
             <a:r>
@@ -10906,7 +11115,7 @@
             <a:endParaRPr lang="en-US" sz="1400" dirty="0"/>
           </a:p>
           <a:p>
-            <a:pPr marL="0" indent="0">
+            <a:pPr indent="0" marL="0">
               <a:buNone/>
             </a:pPr>
             <a:r>
@@ -10988,7 +11197,7 @@
           <a:bodyPr wrap="square" lIns="0" tIns="0" rIns="0" bIns="0" rtlCol="0" anchor="ctr"/>
           <a:lstStyle/>
           <a:p>
-            <a:pPr marL="0" indent="0" algn="ctr">
+            <a:pPr algn="ctr" indent="0" marL="0">
               <a:buNone/>
             </a:pPr>
             <a:r>
@@ -11027,7 +11236,7 @@
           <a:bodyPr wrap="square" lIns="0" tIns="0" rIns="0" bIns="0" rtlCol="0" anchor="ctr"/>
           <a:lstStyle/>
           <a:p>
-            <a:pPr marL="0" indent="0">
+            <a:pPr indent="0" marL="0">
               <a:buNone/>
             </a:pPr>
             <a:r>
@@ -11044,7 +11253,7 @@
             <a:endParaRPr lang="en-US" sz="1400" dirty="0"/>
           </a:p>
           <a:p>
-            <a:pPr marL="0" indent="0">
+            <a:pPr indent="0" marL="0">
               <a:buNone/>
             </a:pPr>
             <a:r>
@@ -11126,7 +11335,7 @@
           <a:bodyPr wrap="square" lIns="0" tIns="0" rIns="0" bIns="0" rtlCol="0" anchor="ctr"/>
           <a:lstStyle/>
           <a:p>
-            <a:pPr marL="0" indent="0" algn="ctr">
+            <a:pPr algn="ctr" indent="0" marL="0">
               <a:buNone/>
             </a:pPr>
             <a:r>
@@ -11165,7 +11374,7 @@
           <a:bodyPr wrap="square" lIns="0" tIns="0" rIns="0" bIns="0" rtlCol="0" anchor="ctr"/>
           <a:lstStyle/>
           <a:p>
-            <a:pPr marL="0" indent="0">
+            <a:pPr indent="0" marL="0">
               <a:buNone/>
             </a:pPr>
             <a:r>
@@ -11182,7 +11391,7 @@
             <a:endParaRPr lang="en-US" sz="1400" dirty="0"/>
           </a:p>
           <a:p>
-            <a:pPr marL="0" indent="0">
+            <a:pPr indent="0" marL="0">
               <a:buNone/>
             </a:pPr>
             <a:r>
@@ -11261,7 +11470,7 @@
           <a:bodyPr wrap="square" lIns="0" tIns="0" rIns="0" bIns="0" rtlCol="0" anchor="ctr"/>
           <a:lstStyle/>
           <a:p>
-            <a:pPr marL="0" indent="0">
+            <a:pPr indent="0" marL="0">
               <a:buNone/>
             </a:pPr>
             <a:r>
@@ -11300,7 +11509,7 @@
           <a:bodyPr wrap="square" lIns="0" tIns="0" rIns="0" bIns="0" rtlCol="0" anchor="ctr"/>
           <a:lstStyle/>
           <a:p>
-            <a:pPr marL="0" indent="0">
+            <a:pPr indent="0" marL="0">
               <a:buNone/>
             </a:pPr>
             <a:r>
@@ -11317,7 +11526,7 @@
             <a:endParaRPr lang="en-US" sz="1100" dirty="0"/>
           </a:p>
           <a:p>
-            <a:pPr marL="0" indent="0">
+            <a:pPr indent="0" marL="0">
               <a:buNone/>
             </a:pPr>
             <a:r>
@@ -11396,7 +11605,7 @@
           <a:bodyPr wrap="square" lIns="0" tIns="0" rIns="0" bIns="0" rtlCol="0" anchor="ctr"/>
           <a:lstStyle/>
           <a:p>
-            <a:pPr marL="0" indent="0">
+            <a:pPr indent="0" marL="0">
               <a:buNone/>
             </a:pPr>
             <a:r>
@@ -11435,7 +11644,7 @@
           <a:bodyPr wrap="square" lIns="0" tIns="0" rIns="0" bIns="0" rtlCol="0" anchor="ctr"/>
           <a:lstStyle/>
           <a:p>
-            <a:pPr marL="0" indent="0">
+            <a:pPr indent="0" marL="0">
               <a:buNone/>
             </a:pPr>
             <a:r>
@@ -11452,7 +11661,7 @@
             <a:endParaRPr lang="en-US" sz="1100" dirty="0"/>
           </a:p>
           <a:p>
-            <a:pPr marL="0" indent="0">
+            <a:pPr indent="0" marL="0">
               <a:buNone/>
             </a:pPr>
             <a:r>
@@ -11491,7 +11700,7 @@
           <a:bodyPr wrap="square" lIns="0" tIns="0" rIns="0" bIns="0" rtlCol="0" anchor="ctr"/>
           <a:lstStyle/>
           <a:p>
-            <a:pPr marL="0" indent="0">
+            <a:pPr indent="0" marL="0">
               <a:buNone/>
             </a:pPr>
             <a:r>
@@ -11503,7 +11712,7 @@
                 <a:ea typeface="Calibri" pitchFamily="34" charset="-122"/>
                 <a:cs typeface="Calibri" pitchFamily="34" charset="-120"/>
               </a:rPr>
-              <a:t>Demo: Create .windsurf/rules/logdash.md in Windsurf and show how Rules directly impact code generation quality</a:t>
+              <a:t>Demo: Create .devin/rules/logdash.md in Windsurf and show how Rules directly impact code generation quality</a:t>
             </a:r>
             <a:endParaRPr lang="en-US" sz="1200" dirty="0"/>
           </a:p>
@@ -11525,7 +11734,6 @@
         <a:solidFill>
           <a:srgbClr val="F8FAFC"/>
         </a:solidFill>
-        <a:effectLst/>
       </p:bgPr>
     </p:bg>
     <p:spTree>
@@ -11583,7 +11791,7 @@
           <a:bodyPr wrap="square" lIns="0" tIns="0" rIns="0" bIns="0" rtlCol="0" anchor="ctr"/>
           <a:lstStyle/>
           <a:p>
-            <a:pPr marL="0" indent="0">
+            <a:pPr indent="0" marL="0">
               <a:buNone/>
             </a:pPr>
             <a:r>
@@ -11622,7 +11830,7 @@
           <a:bodyPr wrap="square" lIns="0" tIns="0" rIns="0" bIns="0" rtlCol="0" anchor="ctr"/>
           <a:lstStyle/>
           <a:p>
-            <a:pPr marL="0" indent="0">
+            <a:pPr indent="0" marL="0">
               <a:buNone/>
             </a:pPr>
             <a:r>
@@ -11659,7 +11867,7 @@
           </a:solidFill>
           <a:ln/>
           <a:effectLst>
-            <a:outerShdw blurRad="76200" dist="25400" dir="8100000" algn="bl" rotWithShape="0">
+            <a:outerShdw sx="100000" sy="100000" kx="0" ky="0" algn="bl" rotWithShape="0" blurRad="76200" dist="25400" dir="8100000">
               <a:srgbClr val="000000">
                 <a:alpha val="10000"/>
               </a:srgbClr>
@@ -11688,7 +11896,7 @@
           <a:bodyPr wrap="square" lIns="0" tIns="0" rIns="0" bIns="0" rtlCol="0" anchor="ctr"/>
           <a:lstStyle/>
           <a:p>
-            <a:pPr marL="0" indent="0">
+            <a:pPr indent="0" marL="0">
               <a:buNone/>
             </a:pPr>
             <a:r>
@@ -11747,7 +11955,7 @@
           <a:bodyPr wrap="square" lIns="0" tIns="0" rIns="0" bIns="0" rtlCol="0" anchor="ctr"/>
           <a:lstStyle/>
           <a:p>
-            <a:pPr marL="0" indent="0">
+            <a:pPr indent="0" marL="0">
               <a:buNone/>
             </a:pPr>
             <a:r>
@@ -11786,7 +11994,7 @@
           <a:bodyPr wrap="square" lIns="0" tIns="0" rIns="0" bIns="0" rtlCol="0" anchor="ctr"/>
           <a:lstStyle/>
           <a:p>
-            <a:pPr marL="0" indent="0">
+            <a:pPr indent="0" marL="0">
               <a:buNone/>
             </a:pPr>
             <a:r>
@@ -11845,7 +12053,7 @@
           <a:bodyPr wrap="square" lIns="0" tIns="0" rIns="0" bIns="0" rtlCol="0" anchor="ctr"/>
           <a:lstStyle/>
           <a:p>
-            <a:pPr marL="0" indent="0">
+            <a:pPr indent="0" marL="0">
               <a:buNone/>
             </a:pPr>
             <a:r>
@@ -11884,7 +12092,7 @@
           <a:bodyPr wrap="square" lIns="0" tIns="0" rIns="0" bIns="0" rtlCol="0" anchor="ctr"/>
           <a:lstStyle/>
           <a:p>
-            <a:pPr marL="0" indent="0">
+            <a:pPr indent="0" marL="0">
               <a:buNone/>
             </a:pPr>
             <a:r>
@@ -11943,7 +12151,7 @@
           <a:bodyPr wrap="square" lIns="0" tIns="0" rIns="0" bIns="0" rtlCol="0" anchor="ctr"/>
           <a:lstStyle/>
           <a:p>
-            <a:pPr marL="0" indent="0">
+            <a:pPr indent="0" marL="0">
               <a:buNone/>
             </a:pPr>
             <a:r>
@@ -11982,7 +12190,7 @@
           <a:bodyPr wrap="square" lIns="0" tIns="0" rIns="0" bIns="0" rtlCol="0" anchor="ctr"/>
           <a:lstStyle/>
           <a:p>
-            <a:pPr marL="0" indent="0">
+            <a:pPr indent="0" marL="0">
               <a:buNone/>
             </a:pPr>
             <a:r>
@@ -12041,7 +12249,7 @@
           <a:bodyPr wrap="square" lIns="0" tIns="0" rIns="0" bIns="0" rtlCol="0" anchor="ctr"/>
           <a:lstStyle/>
           <a:p>
-            <a:pPr marL="0" indent="0">
+            <a:pPr indent="0" marL="0">
               <a:buNone/>
             </a:pPr>
             <a:r>
@@ -12080,7 +12288,7 @@
           <a:bodyPr wrap="square" lIns="0" tIns="0" rIns="0" bIns="0" rtlCol="0" anchor="ctr"/>
           <a:lstStyle/>
           <a:p>
-            <a:pPr marL="0" indent="0">
+            <a:pPr indent="0" marL="0">
               <a:buNone/>
             </a:pPr>
             <a:r>
@@ -12119,7 +12327,7 @@
           <a:bodyPr wrap="square" lIns="0" tIns="0" rIns="0" bIns="0" rtlCol="0" anchor="ctr"/>
           <a:lstStyle/>
           <a:p>
-            <a:pPr marL="0" indent="0">
+            <a:pPr indent="0" marL="0">
               <a:buNone/>
             </a:pPr>
             <a:r>
@@ -12198,7 +12406,7 @@
           <a:bodyPr wrap="square" rtlCol="0" anchor="ctr"/>
           <a:lstStyle/>
           <a:p>
-            <a:pPr marL="0" indent="0">
+            <a:pPr indent="0" marL="0">
               <a:buNone/>
             </a:pPr>
             <a:r>
@@ -12215,7 +12423,7 @@
             <a:endParaRPr lang="en-US" sz="1300" dirty="0"/>
           </a:p>
           <a:p>
-            <a:pPr marL="0" indent="0">
+            <a:pPr indent="0" marL="0">
               <a:buNone/>
             </a:pPr>
             <a:r>
@@ -12232,7 +12440,7 @@
             <a:endParaRPr lang="en-US" sz="1300" dirty="0"/>
           </a:p>
           <a:p>
-            <a:pPr marL="0" indent="0">
+            <a:pPr indent="0" marL="0">
               <a:buNone/>
             </a:pPr>
             <a:r>
@@ -12269,7 +12477,7 @@
           </a:solidFill>
           <a:ln/>
           <a:effectLst>
-            <a:outerShdw blurRad="76200" dist="25400" dir="8100000" algn="bl" rotWithShape="0">
+            <a:outerShdw sx="100000" sy="100000" kx="0" ky="0" algn="bl" rotWithShape="0" blurRad="76200" dist="25400" dir="8100000">
               <a:srgbClr val="000000">
                 <a:alpha val="10000"/>
               </a:srgbClr>
@@ -12318,7 +12526,7 @@
           <a:bodyPr wrap="square" rtlCol="0" anchor="ctr"/>
           <a:lstStyle/>
           <a:p>
-            <a:pPr marL="0" indent="0">
+            <a:pPr indent="0" marL="0">
               <a:buNone/>
             </a:pPr>
             <a:r>
@@ -12335,7 +12543,7 @@
             <a:endParaRPr lang="en-US" sz="1300" dirty="0"/>
           </a:p>
           <a:p>
-            <a:pPr marL="0" indent="0">
+            <a:pPr indent="0" marL="0">
               <a:buNone/>
             </a:pPr>
             <a:r>
@@ -12352,7 +12560,7 @@
             <a:endParaRPr lang="en-US" sz="1300" dirty="0"/>
           </a:p>
           <a:p>
-            <a:pPr marL="0" indent="0">
+            <a:pPr indent="0" marL="0">
               <a:buNone/>
             </a:pPr>
             <a:r>
@@ -12369,7 +12577,7 @@
             <a:endParaRPr lang="en-US" sz="1300" dirty="0"/>
           </a:p>
           <a:p>
-            <a:pPr marL="0" indent="0">
+            <a:pPr indent="0" marL="0">
               <a:buNone/>
             </a:pPr>
             <a:r>
@@ -12403,7 +12611,6 @@
         <a:solidFill>
           <a:srgbClr val="F8FAFC"/>
         </a:solidFill>
-        <a:effectLst/>
       </p:bgPr>
     </p:bg>
     <p:spTree>
@@ -12448,8 +12655,8 @@
         </p:nvSpPr>
         <p:spPr>
           <a:xfrm>
-            <a:off x="274320" y="320040"/>
-            <a:ext cx="8232518" cy="502920"/>
+            <a:off x="640080" y="320040"/>
+            <a:ext cx="7315200" cy="502920"/>
           </a:xfrm>
           <a:prstGeom prst="rect">
             <a:avLst/>
@@ -12461,7 +12668,7 @@
           <a:bodyPr wrap="square" lIns="0" tIns="0" rIns="0" bIns="0" rtlCol="0" anchor="ctr"/>
           <a:lstStyle/>
           <a:p>
-            <a:pPr marL="0" indent="0">
+            <a:pPr indent="0" marL="0">
               <a:buNone/>
             </a:pPr>
             <a:r>
@@ -12498,7 +12705,7 @@
           </a:solidFill>
           <a:ln/>
           <a:effectLst>
-            <a:outerShdw blurRad="76200" dist="25400" dir="8100000" algn="bl" rotWithShape="0">
+            <a:outerShdw sx="100000" sy="100000" kx="0" ky="0" algn="bl" rotWithShape="0" blurRad="76200" dist="25400" dir="8100000">
               <a:srgbClr val="000000">
                 <a:alpha val="10000"/>
               </a:srgbClr>
@@ -12547,7 +12754,7 @@
           <a:bodyPr wrap="square" lIns="0" tIns="0" rIns="0" bIns="0" rtlCol="0" anchor="ctr"/>
           <a:lstStyle/>
           <a:p>
-            <a:pPr marL="0" indent="0">
+            <a:pPr indent="0" marL="0">
               <a:buNone/>
             </a:pPr>
             <a:r>
@@ -12609,7 +12816,7 @@
           <a:bodyPr wrap="square" lIns="0" tIns="0" rIns="0" bIns="0" rtlCol="0" anchor="t"/>
           <a:lstStyle/>
           <a:p>
-            <a:pPr marL="0" indent="0">
+            <a:pPr indent="0" marL="0">
               <a:buNone/>
             </a:pPr>
             <a:r>
@@ -12626,7 +12833,7 @@
             <a:endParaRPr lang="en-US" sz="1300" dirty="0"/>
           </a:p>
           <a:p>
-            <a:pPr marL="0" indent="0">
+            <a:pPr indent="0" marL="0">
               <a:buNone/>
             </a:pPr>
             <a:r>
@@ -12643,7 +12850,7 @@
             <a:endParaRPr lang="en-US" sz="1300" dirty="0"/>
           </a:p>
           <a:p>
-            <a:pPr marL="0" indent="0">
+            <a:pPr indent="0" marL="0">
               <a:buNone/>
             </a:pPr>
             <a:r>
@@ -12660,7 +12867,7 @@
             <a:endParaRPr lang="en-US" sz="1300" dirty="0"/>
           </a:p>
           <a:p>
-            <a:pPr marL="0" indent="0">
+            <a:pPr indent="0" marL="0">
               <a:buNone/>
             </a:pPr>
             <a:r>
@@ -12697,7 +12904,7 @@
           </a:solidFill>
           <a:ln/>
           <a:effectLst>
-            <a:outerShdw blurRad="76200" dist="25400" dir="8100000" algn="bl" rotWithShape="0">
+            <a:outerShdw sx="100000" sy="100000" kx="0" ky="0" algn="bl" rotWithShape="0" blurRad="76200" dist="25400" dir="8100000">
               <a:srgbClr val="000000">
                 <a:alpha val="10000"/>
               </a:srgbClr>
@@ -12746,7 +12953,7 @@
           <a:bodyPr wrap="square" lIns="0" tIns="0" rIns="0" bIns="0" rtlCol="0" anchor="ctr"/>
           <a:lstStyle/>
           <a:p>
-            <a:pPr marL="0" indent="0">
+            <a:pPr indent="0" marL="0">
               <a:buNone/>
             </a:pPr>
             <a:r>
@@ -12808,7 +13015,7 @@
           <a:bodyPr wrap="square" lIns="0" tIns="0" rIns="0" bIns="0" rtlCol="0" anchor="t"/>
           <a:lstStyle/>
           <a:p>
-            <a:pPr marL="0" indent="0">
+            <a:pPr indent="0" marL="0">
               <a:buNone/>
             </a:pPr>
             <a:r>
@@ -12825,7 +13032,7 @@
             <a:endParaRPr lang="en-US" sz="1300" dirty="0"/>
           </a:p>
           <a:p>
-            <a:pPr marL="0" indent="0">
+            <a:pPr indent="0" marL="0">
               <a:buNone/>
             </a:pPr>
             <a:r>
@@ -12842,7 +13049,7 @@
             <a:endParaRPr lang="en-US" sz="1300" dirty="0"/>
           </a:p>
           <a:p>
-            <a:pPr marL="0" indent="0">
+            <a:pPr indent="0" marL="0">
               <a:buNone/>
             </a:pPr>
             <a:r>
@@ -12859,7 +13066,7 @@
             <a:endParaRPr lang="en-US" sz="1300" dirty="0"/>
           </a:p>
           <a:p>
-            <a:pPr marL="0" indent="0">
+            <a:pPr indent="0" marL="0">
               <a:buNone/>
             </a:pPr>
             <a:r>
@@ -12896,7 +13103,7 @@
           </a:solidFill>
           <a:ln/>
           <a:effectLst>
-            <a:outerShdw blurRad="76200" dist="25400" dir="8100000" algn="bl" rotWithShape="0">
+            <a:outerShdw sx="100000" sy="100000" kx="0" ky="0" algn="bl" rotWithShape="0" blurRad="76200" dist="25400" dir="8100000">
               <a:srgbClr val="000000">
                 <a:alpha val="10000"/>
               </a:srgbClr>
@@ -12945,7 +13152,7 @@
           <a:bodyPr wrap="square" lIns="0" tIns="0" rIns="0" bIns="0" rtlCol="0" anchor="ctr"/>
           <a:lstStyle/>
           <a:p>
-            <a:pPr marL="0" indent="0">
+            <a:pPr indent="0" marL="0">
               <a:buNone/>
             </a:pPr>
             <a:r>
@@ -13007,7 +13214,7 @@
           <a:bodyPr wrap="square" lIns="0" tIns="0" rIns="0" bIns="0" rtlCol="0" anchor="t"/>
           <a:lstStyle/>
           <a:p>
-            <a:pPr marL="0" indent="0">
+            <a:pPr indent="0" marL="0">
               <a:buNone/>
             </a:pPr>
             <a:r>
@@ -13024,7 +13231,7 @@
             <a:endParaRPr lang="en-US" sz="1300" dirty="0"/>
           </a:p>
           <a:p>
-            <a:pPr marL="0" indent="0">
+            <a:pPr indent="0" marL="0">
               <a:buNone/>
             </a:pPr>
             <a:r>
@@ -13041,7 +13248,7 @@
             <a:endParaRPr lang="en-US" sz="1300" dirty="0"/>
           </a:p>
           <a:p>
-            <a:pPr marL="0" indent="0">
+            <a:pPr indent="0" marL="0">
               <a:buNone/>
             </a:pPr>
             <a:r>
@@ -13058,7 +13265,7 @@
             <a:endParaRPr lang="en-US" sz="1300" dirty="0"/>
           </a:p>
           <a:p>
-            <a:pPr marL="0" indent="0">
+            <a:pPr indent="0" marL="0">
               <a:buNone/>
             </a:pPr>
             <a:r>
@@ -13117,7 +13324,7 @@
           <a:bodyPr wrap="square" lIns="0" tIns="0" rIns="0" bIns="0" rtlCol="0" anchor="ctr"/>
           <a:lstStyle/>
           <a:p>
-            <a:pPr marL="0" indent="0">
+            <a:pPr indent="0" marL="0">
               <a:buNone/>
             </a:pPr>
             <a:r>
@@ -13129,8 +13336,11 @@
                 <a:ea typeface="Consolas" pitchFamily="34" charset="-122"/>
                 <a:cs typeface="Consolas" pitchFamily="34" charset="-120"/>
               </a:rPr>
-              <a:t> .windsurf/skills/</a:t>
-            </a:r>
+              <a:t> .devin/skills/</a:t>
+            </a:r>
+            <a:pPr indent="0" marL="0">
+              <a:buNone/>
+            </a:pPr>
             <a:r>
               <a:rPr lang="en-US" sz="1000" dirty="0">
                 <a:solidFill>
@@ -13142,6 +13352,9 @@
               </a:rPr>
               <a:t>  dev/SKILL.md</a:t>
             </a:r>
+            <a:pPr indent="0" marL="0">
+              <a:buNone/>
+            </a:pPr>
             <a:r>
               <a:rPr lang="en-US" sz="1000" dirty="0">
                 <a:solidFill>
@@ -13153,6 +13366,9 @@
               </a:rPr>
               <a:t>  build/SKILL.md</a:t>
             </a:r>
+            <a:pPr indent="0" marL="0">
+              <a:buNone/>
+            </a:pPr>
             <a:r>
               <a:rPr lang="en-US" sz="1000" dirty="0">
                 <a:solidFill>
@@ -13184,7 +13400,6 @@
         <a:solidFill>
           <a:srgbClr val="F8FAFC"/>
         </a:solidFill>
-        <a:effectLst/>
       </p:bgPr>
     </p:bg>
     <p:spTree>
@@ -13229,8 +13444,8 @@
         </p:nvSpPr>
         <p:spPr>
           <a:xfrm>
-            <a:off x="369651" y="301752"/>
-            <a:ext cx="9445558" cy="594360"/>
+            <a:off x="640080" y="320040"/>
+            <a:ext cx="7315200" cy="594360"/>
           </a:xfrm>
           <a:prstGeom prst="rect">
             <a:avLst/>
@@ -13242,11 +13457,11 @@
           <a:bodyPr wrap="square" lIns="0" tIns="0" rIns="0" bIns="0" rtlCol="0" anchor="ctr"/>
           <a:lstStyle/>
           <a:p>
-            <a:pPr marL="0" indent="0">
-              <a:buNone/>
-            </a:pPr>
-            <a:r>
-              <a:rPr lang="en-US" sz="3200" dirty="0">
+            <a:pPr indent="0" marL="0">
+              <a:buNone/>
+            </a:pPr>
+            <a:r>
+              <a:rPr lang="en-US" sz="3600" dirty="0">
                 <a:solidFill>
                   <a:srgbClr val="1E293B"/>
                 </a:solidFill>
@@ -13256,7 +13471,7 @@
               </a:rPr>
               <a:t>Workflows — Process Orchestration</a:t>
             </a:r>
-            <a:endParaRPr lang="en-US" sz="3200" dirty="0"/>
+            <a:endParaRPr lang="en-US" sz="3600" dirty="0"/>
           </a:p>
         </p:txBody>
       </p:sp>
@@ -13281,7 +13496,7 @@
           <a:bodyPr wrap="square" lIns="0" tIns="0" rIns="0" bIns="0" rtlCol="0" anchor="ctr"/>
           <a:lstStyle/>
           <a:p>
-            <a:pPr marL="0" indent="0">
+            <a:pPr indent="0" marL="0">
               <a:buNone/>
             </a:pPr>
             <a:r>
@@ -13340,7 +13555,7 @@
           <a:bodyPr wrap="square" rtlCol="0" anchor="ctr"/>
           <a:lstStyle/>
           <a:p>
-            <a:pPr marL="0" indent="0">
+            <a:pPr indent="0" marL="0">
               <a:buNone/>
             </a:pPr>
             <a:r>
@@ -13357,7 +13572,7 @@
             <a:endParaRPr lang="en-US" sz="1400" dirty="0"/>
           </a:p>
           <a:p>
-            <a:pPr marL="0" indent="0">
+            <a:pPr indent="0" marL="0">
               <a:buNone/>
             </a:pPr>
             <a:r>
@@ -13374,7 +13589,7 @@
             <a:endParaRPr lang="en-US" sz="1400" dirty="0"/>
           </a:p>
           <a:p>
-            <a:pPr marL="0" indent="0">
+            <a:pPr indent="0" marL="0">
               <a:buNone/>
             </a:pPr>
             <a:r>
@@ -13411,7 +13626,7 @@
           </a:solidFill>
           <a:ln/>
           <a:effectLst>
-            <a:outerShdw blurRad="76200" dist="25400" dir="8100000" algn="bl" rotWithShape="0">
+            <a:outerShdw sx="100000" sy="100000" kx="0" ky="0" algn="bl" rotWithShape="0" blurRad="76200" dist="25400" dir="8100000">
               <a:srgbClr val="000000">
                 <a:alpha val="10000"/>
               </a:srgbClr>
@@ -13460,7 +13675,7 @@
           <a:bodyPr wrap="square" rtlCol="0" anchor="ctr"/>
           <a:lstStyle/>
           <a:p>
-            <a:pPr marL="0" indent="0">
+            <a:pPr indent="0" marL="0">
               <a:buNone/>
             </a:pPr>
             <a:r>
@@ -13477,7 +13692,7 @@
             <a:endParaRPr lang="en-US" sz="1400" dirty="0"/>
           </a:p>
           <a:p>
-            <a:pPr marL="0" indent="0">
+            <a:pPr indent="0" marL="0">
               <a:buNone/>
             </a:pPr>
             <a:r>
@@ -13494,7 +13709,7 @@
             <a:endParaRPr lang="en-US" sz="1400" dirty="0"/>
           </a:p>
           <a:p>
-            <a:pPr marL="0" indent="0">
+            <a:pPr indent="0" marL="0">
               <a:buNone/>
             </a:pPr>
             <a:r>
@@ -13533,7 +13748,7 @@
           <a:bodyPr wrap="square" lIns="0" tIns="0" rIns="0" bIns="0" rtlCol="0" anchor="ctr"/>
           <a:lstStyle/>
           <a:p>
-            <a:pPr marL="0" indent="0">
+            <a:pPr indent="0" marL="0">
               <a:buNone/>
             </a:pPr>
             <a:r>
@@ -13592,7 +13807,7 @@
           <a:bodyPr wrap="square" lIns="0" tIns="0" rIns="0" bIns="0" rtlCol="0" anchor="ctr"/>
           <a:lstStyle/>
           <a:p>
-            <a:pPr marL="0" indent="0" algn="ctr">
+            <a:pPr algn="ctr" indent="0" marL="0">
               <a:buNone/>
             </a:pPr>
             <a:r>
@@ -13631,7 +13846,7 @@
           <a:bodyPr wrap="square" lIns="0" tIns="0" rIns="0" bIns="0" rtlCol="0" anchor="ctr"/>
           <a:lstStyle/>
           <a:p>
-            <a:pPr marL="0" indent="0" algn="ctr">
+            <a:pPr algn="ctr" indent="0" marL="0">
               <a:buNone/>
             </a:pPr>
             <a:r>
@@ -13687,7 +13902,7 @@
           <a:bodyPr wrap="square" lIns="0" tIns="0" rIns="0" bIns="0" rtlCol="0" anchor="ctr"/>
           <a:lstStyle/>
           <a:p>
-            <a:pPr marL="0" indent="0" algn="ctr">
+            <a:pPr algn="ctr" indent="0" marL="0">
               <a:buNone/>
             </a:pPr>
             <a:r>
@@ -13726,7 +13941,7 @@
           <a:bodyPr wrap="square" lIns="0" tIns="0" rIns="0" bIns="0" rtlCol="0" anchor="ctr"/>
           <a:lstStyle/>
           <a:p>
-            <a:pPr marL="0" indent="0" algn="ctr">
+            <a:pPr algn="ctr" indent="0" marL="0">
               <a:buNone/>
             </a:pPr>
             <a:r>
@@ -13782,7 +13997,7 @@
           <a:bodyPr wrap="square" lIns="0" tIns="0" rIns="0" bIns="0" rtlCol="0" anchor="ctr"/>
           <a:lstStyle/>
           <a:p>
-            <a:pPr marL="0" indent="0" algn="ctr">
+            <a:pPr algn="ctr" indent="0" marL="0">
               <a:buNone/>
             </a:pPr>
             <a:r>
@@ -13821,7 +14036,7 @@
           <a:bodyPr wrap="square" lIns="0" tIns="0" rIns="0" bIns="0" rtlCol="0" anchor="ctr"/>
           <a:lstStyle/>
           <a:p>
-            <a:pPr marL="0" indent="0" algn="ctr">
+            <a:pPr algn="ctr" indent="0" marL="0">
               <a:buNone/>
             </a:pPr>
             <a:r>
@@ -13877,7 +14092,7 @@
           <a:bodyPr wrap="square" lIns="0" tIns="0" rIns="0" bIns="0" rtlCol="0" anchor="ctr"/>
           <a:lstStyle/>
           <a:p>
-            <a:pPr marL="0" indent="0" algn="ctr">
+            <a:pPr algn="ctr" indent="0" marL="0">
               <a:buNone/>
             </a:pPr>
             <a:r>
@@ -13916,7 +14131,7 @@
           <a:bodyPr wrap="square" lIns="0" tIns="0" rIns="0" bIns="0" rtlCol="0" anchor="ctr"/>
           <a:lstStyle/>
           <a:p>
-            <a:pPr marL="0" indent="0" algn="ctr">
+            <a:pPr algn="ctr" indent="0" marL="0">
               <a:buNone/>
             </a:pPr>
             <a:r>
@@ -13972,7 +14187,7 @@
           <a:bodyPr wrap="square" lIns="0" tIns="0" rIns="0" bIns="0" rtlCol="0" anchor="ctr"/>
           <a:lstStyle/>
           <a:p>
-            <a:pPr marL="0" indent="0" algn="ctr">
+            <a:pPr algn="ctr" indent="0" marL="0">
               <a:buNone/>
             </a:pPr>
             <a:r>
@@ -14011,7 +14226,7 @@
           <a:bodyPr wrap="square" lIns="0" tIns="0" rIns="0" bIns="0" rtlCol="0" anchor="ctr"/>
           <a:lstStyle/>
           <a:p>
-            <a:pPr marL="0" indent="0" algn="ctr">
+            <a:pPr algn="ctr" indent="0" marL="0">
               <a:buNone/>
             </a:pPr>
             <a:r>
@@ -14067,7 +14282,7 @@
           <a:bodyPr wrap="square" lIns="0" tIns="0" rIns="0" bIns="0" rtlCol="0" anchor="ctr"/>
           <a:lstStyle/>
           <a:p>
-            <a:pPr marL="0" indent="0" algn="ctr">
+            <a:pPr algn="ctr" indent="0" marL="0">
               <a:buNone/>
             </a:pPr>
             <a:r>
@@ -14106,7 +14321,7 @@
           <a:bodyPr wrap="square" lIns="0" tIns="0" rIns="0" bIns="0" rtlCol="0" anchor="ctr"/>
           <a:lstStyle/>
           <a:p>
-            <a:pPr marL="0" indent="0">
+            <a:pPr indent="0" marL="0">
               <a:buNone/>
             </a:pPr>
             <a:r>
@@ -14165,7 +14380,7 @@
           <a:bodyPr wrap="square" lIns="0" tIns="0" rIns="0" bIns="0" rtlCol="0" anchor="ctr"/>
           <a:lstStyle/>
           <a:p>
-            <a:pPr marL="0" indent="0" algn="ctr">
+            <a:pPr algn="ctr" indent="0" marL="0">
               <a:buNone/>
             </a:pPr>
             <a:r>
@@ -14224,7 +14439,7 @@
           <a:bodyPr wrap="square" lIns="0" tIns="0" rIns="0" bIns="0" rtlCol="0" anchor="ctr"/>
           <a:lstStyle/>
           <a:p>
-            <a:pPr marL="0" indent="0" algn="ctr">
+            <a:pPr algn="ctr" indent="0" marL="0">
               <a:buNone/>
             </a:pPr>
             <a:r>
@@ -14283,7 +14498,7 @@
           <a:bodyPr wrap="square" lIns="0" tIns="0" rIns="0" bIns="0" rtlCol="0" anchor="ctr"/>
           <a:lstStyle/>
           <a:p>
-            <a:pPr marL="0" indent="0" algn="ctr">
+            <a:pPr algn="ctr" indent="0" marL="0">
               <a:buNone/>
             </a:pPr>
             <a:r>
@@ -14342,7 +14557,7 @@
           <a:bodyPr wrap="square" lIns="0" tIns="0" rIns="0" bIns="0" rtlCol="0" anchor="ctr"/>
           <a:lstStyle/>
           <a:p>
-            <a:pPr marL="0" indent="0" algn="ctr">
+            <a:pPr algn="ctr" indent="0" marL="0">
               <a:buNone/>
             </a:pPr>
             <a:r>
@@ -14661,299 +14876,4 @@
     </a:ext>
   </a:extLst>
 </a:theme>
-</file>
-
-<file path=ppt/theme/theme2.xml><?xml version="1.0" encoding="utf-8"?>
-<a:theme xmlns:a="http://schemas.openxmlformats.org/drawingml/2006/main" name="Office 主题​​">
-  <a:themeElements>
-    <a:clrScheme name="Office">
-      <a:dk1>
-        <a:sysClr val="windowText" lastClr="000000"/>
-      </a:dk1>
-      <a:lt1>
-        <a:sysClr val="window" lastClr="FFFFFF"/>
-      </a:lt1>
-      <a:dk2>
-        <a:srgbClr val="44546A"/>
-      </a:dk2>
-      <a:lt2>
-        <a:srgbClr val="E7E6E6"/>
-      </a:lt2>
-      <a:accent1>
-        <a:srgbClr val="4472C4"/>
-      </a:accent1>
-      <a:accent2>
-        <a:srgbClr val="ED7D31"/>
-      </a:accent2>
-      <a:accent3>
-        <a:srgbClr val="A5A5A5"/>
-      </a:accent3>
-      <a:accent4>
-        <a:srgbClr val="FFC000"/>
-      </a:accent4>
-      <a:accent5>
-        <a:srgbClr val="5B9BD5"/>
-      </a:accent5>
-      <a:accent6>
-        <a:srgbClr val="70AD47"/>
-      </a:accent6>
-      <a:hlink>
-        <a:srgbClr val="0563C1"/>
-      </a:hlink>
-      <a:folHlink>
-        <a:srgbClr val="954F72"/>
-      </a:folHlink>
-    </a:clrScheme>
-    <a:fontScheme name="Office">
-      <a:majorFont>
-        <a:latin typeface="等线 Light" panose="020F0302020204030204"/>
-        <a:ea typeface=""/>
-        <a:cs typeface=""/>
-        <a:font script="Jpan" typeface="游ゴシック Light"/>
-        <a:font script="Hang" typeface="맑은 고딕"/>
-        <a:font script="Hans" typeface="等线 Light"/>
-        <a:font script="Hant" typeface="新細明體"/>
-        <a:font script="Arab" typeface="Times New Roman"/>
-        <a:font script="Hebr" typeface="Times New Roman"/>
-        <a:font script="Thai" typeface="Angsana New"/>
-        <a:font script="Ethi" typeface="Nyala"/>
-        <a:font script="Beng" typeface="Vrinda"/>
-        <a:font script="Gujr" typeface="Shruti"/>
-        <a:font script="Khmr" typeface="MoolBoran"/>
-        <a:font script="Knda" typeface="Tunga"/>
-        <a:font script="Guru" typeface="Raavi"/>
-        <a:font script="Cans" typeface="Euphemia"/>
-        <a:font script="Cher" typeface="Plantagenet Cherokee"/>
-        <a:font script="Yiii" typeface="Microsoft Yi Baiti"/>
-        <a:font script="Tibt" typeface="Microsoft Himalaya"/>
-        <a:font script="Thaa" typeface="MV Boli"/>
-        <a:font script="Deva" typeface="Mangal"/>
-        <a:font script="Telu" typeface="Gautami"/>
-        <a:font script="Taml" typeface="Latha"/>
-        <a:font script="Syrc" typeface="Estrangelo Edessa"/>
-        <a:font script="Orya" typeface="Kalinga"/>
-        <a:font script="Mlym" typeface="Kartika"/>
-        <a:font script="Laoo" typeface="DokChampa"/>
-        <a:font script="Sinh" typeface="Iskoola Pota"/>
-        <a:font script="Mong" typeface="Mongolian Baiti"/>
-        <a:font script="Viet" typeface="Times New Roman"/>
-        <a:font script="Uigh" typeface="Microsoft Uighur"/>
-        <a:font script="Geor" typeface="Sylfaen"/>
-        <a:font script="Armn" typeface="Arial"/>
-        <a:font script="Bugi" typeface="Leelawadee UI"/>
-        <a:font script="Bopo" typeface="Microsoft JhengHei"/>
-        <a:font script="Java" typeface="Javanese Text"/>
-        <a:font script="Lisu" typeface="Segoe UI"/>
-        <a:font script="Mymr" typeface="Myanmar Text"/>
-        <a:font script="Nkoo" typeface="Ebrima"/>
-        <a:font script="Olck" typeface="Nirmala UI"/>
-        <a:font script="Osma" typeface="Ebrima"/>
-        <a:font script="Phag" typeface="Phagspa"/>
-        <a:font script="Syrn" typeface="Estrangelo Edessa"/>
-        <a:font script="Syrj" typeface="Estrangelo Edessa"/>
-        <a:font script="Syre" typeface="Estrangelo Edessa"/>
-        <a:font script="Sora" typeface="Nirmala UI"/>
-        <a:font script="Tale" typeface="Microsoft Tai Le"/>
-        <a:font script="Talu" typeface="Microsoft New Tai Lue"/>
-        <a:font script="Tfng" typeface="Ebrima"/>
-      </a:majorFont>
-      <a:minorFont>
-        <a:latin typeface="等线" panose="020F0502020204030204"/>
-        <a:ea typeface=""/>
-        <a:cs typeface=""/>
-        <a:font script="Jpan" typeface="游ゴシック"/>
-        <a:font script="Hang" typeface="맑은 고딕"/>
-        <a:font script="Hans" typeface="等线"/>
-        <a:font script="Hant" typeface="新細明體"/>
-        <a:font script="Arab" typeface="Arial"/>
-        <a:font script="Hebr" typeface="Arial"/>
-        <a:font script="Thai" typeface="Cordia New"/>
-        <a:font script="Ethi" typeface="Nyala"/>
-        <a:font script="Beng" typeface="Vrinda"/>
-        <a:font script="Gujr" typeface="Shruti"/>
-        <a:font script="Khmr" typeface="DaunPenh"/>
-        <a:font script="Knda" typeface="Tunga"/>
-        <a:font script="Guru" typeface="Raavi"/>
-        <a:font script="Cans" typeface="Euphemia"/>
-        <a:font script="Cher" typeface="Plantagenet Cherokee"/>
-        <a:font script="Yiii" typeface="Microsoft Yi Baiti"/>
-        <a:font script="Tibt" typeface="Microsoft Himalaya"/>
-        <a:font script="Thaa" typeface="MV Boli"/>
-        <a:font script="Deva" typeface="Mangal"/>
-        <a:font script="Telu" typeface="Gautami"/>
-        <a:font script="Taml" typeface="Latha"/>
-        <a:font script="Syrc" typeface="Estrangelo Edessa"/>
-        <a:font script="Orya" typeface="Kalinga"/>
-        <a:font script="Mlym" typeface="Kartika"/>
-        <a:font script="Laoo" typeface="DokChampa"/>
-        <a:font script="Sinh" typeface="Iskoola Pota"/>
-        <a:font script="Mong" typeface="Mongolian Baiti"/>
-        <a:font script="Viet" typeface="Arial"/>
-        <a:font script="Uigh" typeface="Microsoft Uighur"/>
-        <a:font script="Geor" typeface="Sylfaen"/>
-        <a:font script="Armn" typeface="Arial"/>
-        <a:font script="Bugi" typeface="Leelawadee UI"/>
-        <a:font script="Bopo" typeface="Microsoft JhengHei"/>
-        <a:font script="Java" typeface="Javanese Text"/>
-        <a:font script="Lisu" typeface="Segoe UI"/>
-        <a:font script="Mymr" typeface="Myanmar Text"/>
-        <a:font script="Nkoo" typeface="Ebrima"/>
-        <a:font script="Olck" typeface="Nirmala UI"/>
-        <a:font script="Osma" typeface="Ebrima"/>
-        <a:font script="Phag" typeface="Phagspa"/>
-        <a:font script="Syrn" typeface="Estrangelo Edessa"/>
-        <a:font script="Syrj" typeface="Estrangelo Edessa"/>
-        <a:font script="Syre" typeface="Estrangelo Edessa"/>
-        <a:font script="Sora" typeface="Nirmala UI"/>
-        <a:font script="Tale" typeface="Microsoft Tai Le"/>
-        <a:font script="Talu" typeface="Microsoft New Tai Lue"/>
-        <a:font script="Tfng" typeface="Ebrima"/>
-      </a:minorFont>
-    </a:fontScheme>
-    <a:fmtScheme name="Office">
-      <a:fillStyleLst>
-        <a:solidFill>
-          <a:schemeClr val="phClr"/>
-        </a:solidFill>
-        <a:gradFill rotWithShape="1">
-          <a:gsLst>
-            <a:gs pos="0">
-              <a:schemeClr val="phClr">
-                <a:lumMod val="110000"/>
-                <a:satMod val="105000"/>
-                <a:tint val="67000"/>
-              </a:schemeClr>
-            </a:gs>
-            <a:gs pos="50000">
-              <a:schemeClr val="phClr">
-                <a:lumMod val="105000"/>
-                <a:satMod val="103000"/>
-                <a:tint val="73000"/>
-              </a:schemeClr>
-            </a:gs>
-            <a:gs pos="100000">
-              <a:schemeClr val="phClr">
-                <a:lumMod val="105000"/>
-                <a:satMod val="109000"/>
-                <a:tint val="81000"/>
-              </a:schemeClr>
-            </a:gs>
-          </a:gsLst>
-          <a:lin ang="5400000" scaled="0"/>
-        </a:gradFill>
-        <a:gradFill rotWithShape="1">
-          <a:gsLst>
-            <a:gs pos="0">
-              <a:schemeClr val="phClr">
-                <a:satMod val="103000"/>
-                <a:lumMod val="102000"/>
-                <a:tint val="94000"/>
-              </a:schemeClr>
-            </a:gs>
-            <a:gs pos="50000">
-              <a:schemeClr val="phClr">
-                <a:satMod val="110000"/>
-                <a:lumMod val="100000"/>
-                <a:shade val="100000"/>
-              </a:schemeClr>
-            </a:gs>
-            <a:gs pos="100000">
-              <a:schemeClr val="phClr">
-                <a:lumMod val="99000"/>
-                <a:satMod val="120000"/>
-                <a:shade val="78000"/>
-              </a:schemeClr>
-            </a:gs>
-          </a:gsLst>
-          <a:lin ang="5400000" scaled="0"/>
-        </a:gradFill>
-      </a:fillStyleLst>
-      <a:lnStyleLst>
-        <a:ln w="6350" cap="flat" cmpd="sng" algn="ctr">
-          <a:solidFill>
-            <a:schemeClr val="phClr"/>
-          </a:solidFill>
-          <a:prstDash val="solid"/>
-          <a:miter lim="800000"/>
-        </a:ln>
-        <a:ln w="12700" cap="flat" cmpd="sng" algn="ctr">
-          <a:solidFill>
-            <a:schemeClr val="phClr"/>
-          </a:solidFill>
-          <a:prstDash val="solid"/>
-          <a:miter lim="800000"/>
-        </a:ln>
-        <a:ln w="19050" cap="flat" cmpd="sng" algn="ctr">
-          <a:solidFill>
-            <a:schemeClr val="phClr"/>
-          </a:solidFill>
-          <a:prstDash val="solid"/>
-          <a:miter lim="800000"/>
-        </a:ln>
-      </a:lnStyleLst>
-      <a:effectStyleLst>
-        <a:effectStyle>
-          <a:effectLst/>
-        </a:effectStyle>
-        <a:effectStyle>
-          <a:effectLst/>
-        </a:effectStyle>
-        <a:effectStyle>
-          <a:effectLst>
-            <a:outerShdw blurRad="57150" dist="19050" dir="5400000" algn="ctr" rotWithShape="0">
-              <a:srgbClr val="000000">
-                <a:alpha val="63000"/>
-              </a:srgbClr>
-            </a:outerShdw>
-          </a:effectLst>
-        </a:effectStyle>
-      </a:effectStyleLst>
-      <a:bgFillStyleLst>
-        <a:solidFill>
-          <a:schemeClr val="phClr"/>
-        </a:solidFill>
-        <a:solidFill>
-          <a:schemeClr val="phClr">
-            <a:tint val="95000"/>
-            <a:satMod val="170000"/>
-          </a:schemeClr>
-        </a:solidFill>
-        <a:gradFill rotWithShape="1">
-          <a:gsLst>
-            <a:gs pos="0">
-              <a:schemeClr val="phClr">
-                <a:tint val="93000"/>
-                <a:satMod val="150000"/>
-                <a:shade val="98000"/>
-                <a:lumMod val="102000"/>
-              </a:schemeClr>
-            </a:gs>
-            <a:gs pos="50000">
-              <a:schemeClr val="phClr">
-                <a:tint val="98000"/>
-                <a:satMod val="130000"/>
-                <a:shade val="90000"/>
-                <a:lumMod val="103000"/>
-              </a:schemeClr>
-            </a:gs>
-            <a:gs pos="100000">
-              <a:schemeClr val="phClr">
-                <a:shade val="63000"/>
-                <a:satMod val="120000"/>
-              </a:schemeClr>
-            </a:gs>
-          </a:gsLst>
-          <a:lin ang="5400000" scaled="0"/>
-        </a:gradFill>
-      </a:bgFillStyleLst>
-    </a:fmtScheme>
-  </a:themeElements>
-  <a:objectDefaults/>
-  <a:extraClrSchemeLst/>
-  <a:extLst>
-    <a:ext uri="{05A4C25C-085E-4340-85A3-A5531E510DB2}">
-      <thm15:themeFamily xmlns:thm15="http://schemas.microsoft.com/office/thememl/2012/main" name="Office Theme" id="{62F939B6-93AF-4DB8-9C6B-D6C7DFDC589F}" vid="{4A3C46E8-61CC-4603-A589-7422A47A8E4A}"/>
-    </a:ext>
-  </a:extLst>
-</a:theme>
 </file>
</xml_diff>

<commit_message>
docs: update PPT and speaker notes for dev skill plan+review flow and specs/
</commit_message>
<xml_diff>
--- a/AI_Getting_Started_with_AI_Tools.pptx
+++ b/AI_Getting_Started_with_AI_Tools.pptx
@@ -12845,7 +12845,7 @@
                 <a:ea typeface="Calibri" pitchFamily="34" charset="-122"/>
                 <a:cs typeface="Calibri" pitchFamily="34" charset="-120"/>
               </a:rPr>
-              <a:t>Understand requirements</a:t>
+              <a:t>Read specs from specs/ folder</a:t>
             </a:r>
             <a:endParaRPr lang="en-US" sz="1300" dirty="0"/>
           </a:p>
@@ -12862,7 +12862,7 @@
                 <a:ea typeface="Calibri" pitchFamily="34" charset="-122"/>
                 <a:cs typeface="Calibri" pitchFamily="34" charset="-120"/>
               </a:rPr>
-              <a:t>Generate rule-compliant C code</a:t>
+              <a:t>Plan + AI review + user approval</a:t>
             </a:r>
             <a:endParaRPr lang="en-US" sz="1300" dirty="0"/>
           </a:p>
@@ -12879,7 +12879,7 @@
                 <a:ea typeface="Calibri" pitchFamily="34" charset="-122"/>
                 <a:cs typeface="Calibri" pitchFamily="34" charset="-120"/>
               </a:rPr>
-              <a:t>Create .c + .h files</a:t>
+              <a:t>Then generate C code</a:t>
             </a:r>
             <a:endParaRPr lang="en-US" sz="1300" dirty="0"/>
           </a:p>
@@ -13311,8 +13311,8 @@
         </p:nvSpPr>
         <p:spPr>
           <a:xfrm>
-            <a:off x="914400" y="4480560"/>
-            <a:ext cx="7315200" cy="457200"/>
+            <a:off x="914400" y="4389120"/>
+            <a:ext cx="7315200" cy="640080"/>
           </a:xfrm>
           <a:prstGeom prst="rect">
             <a:avLst/>
@@ -13379,6 +13379,34 @@
                 <a:cs typeface="Consolas" pitchFamily="34" charset="-120"/>
               </a:rPr>
               <a:t>  test/SKILL.md</a:t>
+            </a:r>
+            <a:pPr indent="0" marL="0">
+              <a:buNone/>
+            </a:pPr>
+            <a:r>
+              <a:rPr lang="en-US" sz="1000" dirty="0">
+                <a:solidFill>
+                  <a:srgbClr val="64748B"/>
+                </a:solidFill>
+                <a:latin typeface="Consolas" pitchFamily="34" charset="0"/>
+                <a:ea typeface="Consolas" pitchFamily="34" charset="-122"/>
+                <a:cs typeface="Consolas" pitchFamily="34" charset="-120"/>
+              </a:rPr>
+              <a:t> specs/</a:t>
+            </a:r>
+            <a:pPr indent="0" marL="0">
+              <a:buNone/>
+            </a:pPr>
+            <a:r>
+              <a:rPr lang="en-US" sz="1000" dirty="0">
+                <a:solidFill>
+                  <a:srgbClr val="94A3B8"/>
+                </a:solidFill>
+                <a:latin typeface="Consolas" pitchFamily="34" charset="0"/>
+                <a:ea typeface="Consolas" pitchFamily="34" charset="-122"/>
+                <a:cs typeface="Consolas" pitchFamily="34" charset="-120"/>
+              </a:rPr>
+              <a:t>  *.md  (spec docs read by dev)</a:t>
             </a:r>
             <a:endParaRPr lang="en-US" sz="1000" dirty="0"/>
           </a:p>

</xml_diff>

<commit_message>
docs: revise Call to Action slide with two key messages
</commit_message>
<xml_diff>
--- a/AI_Getting_Started_with_AI_Tools.pptx
+++ b/AI_Getting_Started_with_AI_Tools.pptx
@@ -20,9 +20,10 @@
     <p:sldId id="268" r:id="rId14"/>
     <p:sldId id="269" r:id="rId15"/>
     <p:sldId id="270" r:id="rId16"/>
+    <p:sldId id="271" r:id="rId17"/>
   </p:sldIdLst>
   <p:notesMasterIdLst>
-    <p:notesMasterId r:id="rId17"/>
+    <p:notesMasterId r:id="rId18"/>
   </p:notesMasterIdLst>
   <p:sldSz cx="9144000" cy="5143500"/>
   <p:notesSz cx="5143500" cy="9144000"/>
@@ -1068,6 +1069,94 @@
             <a:fld id="{F7021451-1387-4CA6-816F-3879F97B5CBC}" type="slidenum">
               <a:rPr lang="en-US"/>
               <a:t>15</a:t>
+            </a:fld>
+            <a:endParaRPr lang="en-US"/>
+          </a:p>
+        </p:txBody>
+      </p:sp>
+    </p:spTree>
+    <p:extLst>
+      <p:ext uri="{BB962C8B-B14F-4D97-AF65-F5344CB8AC3E}">
+        <p14:creationId xmlns:p14="http://schemas.microsoft.com/office/powerpoint/2010/main" val="1024086991"/>
+      </p:ext>
+    </p:extLst>
+  </p:cSld>
+  <p:clrMapOvr>
+    <a:masterClrMapping/>
+  </p:clrMapOvr>
+</p:notes>
+</file>
+
+<file path=ppt/notesSlides/notesSlide16.xml><?xml version="1.0" encoding="utf-8"?>
+<p:notes xmlns:a="http://schemas.openxmlformats.org/drawingml/2006/main" xmlns:r="http://schemas.openxmlformats.org/officeDocument/2006/relationships" xmlns:p="http://schemas.openxmlformats.org/presentationml/2006/main">
+  <p:cSld>
+    <p:spTree>
+      <p:nvGrpSpPr>
+        <p:cNvPr id="1" name=""/>
+        <p:cNvGrpSpPr/>
+        <p:nvPr/>
+      </p:nvGrpSpPr>
+      <p:grpSpPr>
+        <a:xfrm>
+          <a:off x="0" y="0"/>
+          <a:ext cx="0" cy="0"/>
+          <a:chOff x="0" y="0"/>
+          <a:chExt cx="0" cy="0"/>
+        </a:xfrm>
+      </p:grpSpPr>
+      <p:sp>
+        <p:nvSpPr>
+          <p:cNvPr id="2" name="Slide Image Placeholder 1"/>
+          <p:cNvSpPr>
+            <a:spLocks noGrp="1" noRot="1" noChangeAspect="1"/>
+          </p:cNvSpPr>
+          <p:nvPr>
+            <p:ph type="sldImg"/>
+          </p:nvPr>
+        </p:nvSpPr>
+        <p:spPr/>
+      </p:sp>
+      <p:sp>
+        <p:nvSpPr>
+          <p:cNvPr id="3" name="Notes Placeholder 2"/>
+          <p:cNvSpPr>
+            <a:spLocks noGrp="1"/>
+          </p:cNvSpPr>
+          <p:nvPr>
+            <p:ph type="body" idx="1"/>
+          </p:nvPr>
+        </p:nvSpPr>
+        <p:spPr/>
+        <p:txBody>
+          <a:bodyPr/>
+          <a:lstStyle/>
+          <a:p>
+            <a:r>
+              <a:rPr lang="en-US" dirty="0"/>
+              <a:t/>
+            </a:r>
+            <a:endParaRPr lang="en-US" dirty="0"/>
+          </a:p>
+        </p:txBody>
+      </p:sp>
+      <p:sp>
+        <p:nvSpPr>
+          <p:cNvPr id="4" name="Slide Number Placeholder 3"/>
+          <p:cNvSpPr>
+            <a:spLocks noGrp="1"/>
+          </p:cNvSpPr>
+          <p:nvPr>
+            <p:ph type="sldNum" sz="quarter" idx="10"/>
+          </p:nvPr>
+        </p:nvSpPr>
+        <p:spPr/>
+        <p:txBody>
+          <a:bodyPr/>
+          <a:lstStyle/>
+          <a:p>
+            <a:fld id="{F7021451-1387-4CA6-816F-3879F97B5CBC}" type="slidenum">
+              <a:rPr lang="en-US"/>
+              <a:t>16</a:t>
             </a:fld>
             <a:endParaRPr lang="en-US"/>
           </a:p>
@@ -7816,6 +7905,341 @@
         </p:nvSpPr>
         <p:spPr>
           <a:xfrm>
+            <a:off x="7772400" y="-914400"/>
+            <a:ext cx="2743200" cy="2743200"/>
+          </a:xfrm>
+          <a:prstGeom prst="ellipse">
+            <a:avLst/>
+          </a:prstGeom>
+          <a:solidFill>
+            <a:srgbClr val="F59E0B">
+              <a:alpha val="12000"/>
+            </a:srgbClr>
+          </a:solidFill>
+          <a:ln/>
+        </p:spPr>
+      </p:sp>
+      <p:sp>
+        <p:nvSpPr>
+          <p:cNvPr id="3" name="Shape 1"/>
+          <p:cNvSpPr/>
+          <p:nvPr/>
+        </p:nvSpPr>
+        <p:spPr>
+          <a:xfrm>
+            <a:off x="-1371600" y="3200400"/>
+            <a:ext cx="3200400" cy="3200400"/>
+          </a:xfrm>
+          <a:prstGeom prst="ellipse">
+            <a:avLst/>
+          </a:prstGeom>
+          <a:solidFill>
+            <a:srgbClr val="14B8A6">
+              <a:alpha val="12000"/>
+            </a:srgbClr>
+          </a:solidFill>
+          <a:ln/>
+        </p:spPr>
+      </p:sp>
+      <p:sp>
+        <p:nvSpPr>
+          <p:cNvPr id="4" name="Text 2"/>
+          <p:cNvSpPr/>
+          <p:nvPr/>
+        </p:nvSpPr>
+        <p:spPr>
+          <a:xfrm>
+            <a:off x="914400" y="548640"/>
+            <a:ext cx="7315200" cy="731520"/>
+          </a:xfrm>
+          <a:prstGeom prst="rect">
+            <a:avLst/>
+          </a:prstGeom>
+          <a:noFill/>
+          <a:ln/>
+        </p:spPr>
+        <p:txBody>
+          <a:bodyPr wrap="square" lIns="0" tIns="0" rIns="0" bIns="0" rtlCol="0" anchor="ctr"/>
+          <a:lstStyle/>
+          <a:p>
+            <a:pPr algn="ctr" indent="0" marL="0">
+              <a:buNone/>
+            </a:pPr>
+            <a:r>
+              <a:rPr lang="en-US" sz="2600" dirty="0">
+                <a:solidFill>
+                  <a:srgbClr val="F8FAFC"/>
+                </a:solidFill>
+                <a:latin typeface="Arial Black" pitchFamily="34" charset="0"/>
+                <a:ea typeface="Arial Black" pitchFamily="34" charset="-122"/>
+                <a:cs typeface="Arial Black" pitchFamily="34" charset="-120"/>
+              </a:rPr>
+              <a:t>No matter where you are with AI today,</a:t>
+            </a:r>
+            <a:endParaRPr lang="en-US" sz="2600" dirty="0"/>
+          </a:p>
+        </p:txBody>
+      </p:sp>
+      <p:sp>
+        <p:nvSpPr>
+          <p:cNvPr id="5" name="Shape 3"/>
+          <p:cNvSpPr/>
+          <p:nvPr/>
+        </p:nvSpPr>
+        <p:spPr>
+          <a:xfrm>
+            <a:off x="1371600" y="1371600"/>
+            <a:ext cx="6400800" cy="1097280"/>
+          </a:xfrm>
+          <a:prstGeom prst="rect">
+            <a:avLst/>
+          </a:prstGeom>
+          <a:solidFill>
+            <a:srgbClr val="1E293B"/>
+          </a:solidFill>
+          <a:ln/>
+        </p:spPr>
+      </p:sp>
+      <p:sp>
+        <p:nvSpPr>
+          <p:cNvPr id="6" name="Shape 4"/>
+          <p:cNvSpPr/>
+          <p:nvPr/>
+        </p:nvSpPr>
+        <p:spPr>
+          <a:xfrm>
+            <a:off x="1371600" y="1371600"/>
+            <a:ext cx="54864" cy="1097280"/>
+          </a:xfrm>
+          <a:prstGeom prst="rect">
+            <a:avLst/>
+          </a:prstGeom>
+          <a:solidFill>
+            <a:srgbClr val="14B8A6"/>
+          </a:solidFill>
+          <a:ln/>
+        </p:spPr>
+      </p:sp>
+      <p:sp>
+        <p:nvSpPr>
+          <p:cNvPr id="7" name="Text 5"/>
+          <p:cNvSpPr/>
+          <p:nvPr/>
+        </p:nvSpPr>
+        <p:spPr>
+          <a:xfrm>
+            <a:off x="1645920" y="1417320"/>
+            <a:ext cx="5852160" cy="1005840"/>
+          </a:xfrm>
+          <a:prstGeom prst="rect">
+            <a:avLst/>
+          </a:prstGeom>
+          <a:noFill/>
+          <a:ln/>
+        </p:spPr>
+        <p:txBody>
+          <a:bodyPr wrap="square" lIns="0" tIns="0" rIns="0" bIns="0" rtlCol="0" anchor="ctr"/>
+          <a:lstStyle/>
+          <a:p>
+            <a:pPr indent="0" marL="0">
+              <a:buNone/>
+            </a:pPr>
+            <a:r>
+              <a:rPr lang="en-US" sz="1800" b="1" dirty="0">
+                <a:solidFill>
+                  <a:srgbClr val="F8FAFC"/>
+                </a:solidFill>
+                <a:latin typeface="Calibri" pitchFamily="34" charset="0"/>
+                <a:ea typeface="Calibri" pitchFamily="34" charset="-122"/>
+                <a:cs typeface="Calibri" pitchFamily="34" charset="-120"/>
+              </a:rPr>
+              <a:t>From now on, deeply integrate AI into your daily work.</a:t>
+            </a:r>
+            <a:endParaRPr lang="en-US" sz="1800" dirty="0"/>
+          </a:p>
+          <a:p>
+            <a:pPr indent="0" marL="0">
+              <a:buNone/>
+            </a:pPr>
+            <a:r>
+              <a:rPr lang="en-US" sz="400" dirty="0">
+                <a:solidFill>
+                  <a:srgbClr val="000000"/>
+                </a:solidFill>
+              </a:rPr>
+              <a:t> </a:t>
+            </a:r>
+            <a:endParaRPr lang="en-US" sz="1800" dirty="0"/>
+          </a:p>
+          <a:p>
+            <a:pPr indent="0" marL="0">
+              <a:buNone/>
+            </a:pPr>
+            <a:r>
+              <a:rPr lang="en-US" sz="1400" dirty="0">
+                <a:solidFill>
+                  <a:srgbClr val="94A3B8"/>
+                </a:solidFill>
+                <a:latin typeface="Calibri" pitchFamily="34" charset="0"/>
+                <a:ea typeface="Calibri" pitchFamily="34" charset="-122"/>
+                <a:cs typeface="Calibri" pitchFamily="34" charset="-120"/>
+              </a:rPr>
+              <a:t>Not as a toy. Not as an afterthought. As a core part of how you engineer.</a:t>
+            </a:r>
+            <a:endParaRPr lang="en-US" sz="1800" dirty="0"/>
+          </a:p>
+        </p:txBody>
+      </p:sp>
+      <p:sp>
+        <p:nvSpPr>
+          <p:cNvPr id="8" name="Shape 6"/>
+          <p:cNvSpPr/>
+          <p:nvPr/>
+        </p:nvSpPr>
+        <p:spPr>
+          <a:xfrm>
+            <a:off x="1371600" y="2743200"/>
+            <a:ext cx="6400800" cy="1097280"/>
+          </a:xfrm>
+          <a:prstGeom prst="rect">
+            <a:avLst/>
+          </a:prstGeom>
+          <a:solidFill>
+            <a:srgbClr val="1E293B"/>
+          </a:solidFill>
+          <a:ln/>
+        </p:spPr>
+      </p:sp>
+      <p:sp>
+        <p:nvSpPr>
+          <p:cNvPr id="9" name="Shape 7"/>
+          <p:cNvSpPr/>
+          <p:nvPr/>
+        </p:nvSpPr>
+        <p:spPr>
+          <a:xfrm>
+            <a:off x="1371600" y="2743200"/>
+            <a:ext cx="54864" cy="1097280"/>
+          </a:xfrm>
+          <a:prstGeom prst="rect">
+            <a:avLst/>
+          </a:prstGeom>
+          <a:solidFill>
+            <a:srgbClr val="F59E0B"/>
+          </a:solidFill>
+          <a:ln/>
+        </p:spPr>
+      </p:sp>
+      <p:sp>
+        <p:nvSpPr>
+          <p:cNvPr id="10" name="Text 8"/>
+          <p:cNvSpPr/>
+          <p:nvPr/>
+        </p:nvSpPr>
+        <p:spPr>
+          <a:xfrm>
+            <a:off x="1645920" y="2788920"/>
+            <a:ext cx="5852160" cy="1005840"/>
+          </a:xfrm>
+          <a:prstGeom prst="rect">
+            <a:avLst/>
+          </a:prstGeom>
+          <a:noFill/>
+          <a:ln/>
+        </p:spPr>
+        <p:txBody>
+          <a:bodyPr wrap="square" lIns="0" tIns="0" rIns="0" bIns="0" rtlCol="0" anchor="ctr"/>
+          <a:lstStyle/>
+          <a:p>
+            <a:pPr indent="0" marL="0">
+              <a:buNone/>
+            </a:pPr>
+            <a:r>
+              <a:rPr lang="en-US" sz="1800" b="1" dirty="0">
+                <a:solidFill>
+                  <a:srgbClr val="F8FAFC"/>
+                </a:solidFill>
+                <a:latin typeface="Calibri" pitchFamily="34" charset="0"/>
+                <a:ea typeface="Calibri" pitchFamily="34" charset="-122"/>
+                <a:cs typeface="Calibri" pitchFamily="34" charset="-120"/>
+              </a:rPr>
+              <a:t>Everyone's workflow is different. Share your best ideas.</a:t>
+            </a:r>
+            <a:endParaRPr lang="en-US" sz="1800" dirty="0"/>
+          </a:p>
+          <a:p>
+            <a:pPr indent="0" marL="0">
+              <a:buNone/>
+            </a:pPr>
+            <a:r>
+              <a:rPr lang="en-US" sz="400" dirty="0">
+                <a:solidFill>
+                  <a:srgbClr val="000000"/>
+                </a:solidFill>
+              </a:rPr>
+              <a:t> </a:t>
+            </a:r>
+            <a:endParaRPr lang="en-US" sz="1800" dirty="0"/>
+          </a:p>
+          <a:p>
+            <a:pPr indent="0" marL="0">
+              <a:buNone/>
+            </a:pPr>
+            <a:r>
+              <a:rPr lang="en-US" sz="1400" dirty="0">
+                <a:solidFill>
+                  <a:srgbClr val="94A3B8"/>
+                </a:solidFill>
+                <a:latin typeface="Calibri" pitchFamily="34" charset="0"/>
+                <a:ea typeface="Calibri" pitchFamily="34" charset="-122"/>
+                <a:cs typeface="Calibri" pitchFamily="34" charset="-120"/>
+              </a:rPr>
+              <a:t>The prompt, rule, or skill you think is "obvious" might be exactly what someone else needs.</a:t>
+            </a:r>
+            <a:endParaRPr lang="en-US" sz="1800" dirty="0"/>
+          </a:p>
+        </p:txBody>
+      </p:sp>
+    </p:spTree>
+  </p:cSld>
+  <p:clrMapOvr>
+    <a:masterClrMapping/>
+  </p:clrMapOvr>
+</p:sld>
+</file>
+
+<file path=ppt/slides/slide16.xml><?xml version="1.0" encoding="utf-8"?>
+<p:sld xmlns:a="http://schemas.openxmlformats.org/drawingml/2006/main" xmlns:r="http://schemas.openxmlformats.org/officeDocument/2006/relationships" xmlns:p="http://schemas.openxmlformats.org/presentationml/2006/main">
+  <p:cSld name="Slide 16">
+    <p:bg>
+      <p:bgPr>
+        <a:solidFill>
+          <a:srgbClr val="0F172A"/>
+        </a:solidFill>
+      </p:bgPr>
+    </p:bg>
+    <p:spTree>
+      <p:nvGrpSpPr>
+        <p:cNvPr id="1" name=""/>
+        <p:cNvGrpSpPr/>
+        <p:nvPr/>
+      </p:nvGrpSpPr>
+      <p:grpSpPr>
+        <a:xfrm>
+          <a:off x="0" y="0"/>
+          <a:ext cx="0" cy="0"/>
+          <a:chOff x="0" y="0"/>
+          <a:chExt cx="0" cy="0"/>
+        </a:xfrm>
+      </p:grpSpPr>
+      <p:sp>
+        <p:nvSpPr>
+          <p:cNvPr id="2" name="Shape 0"/>
+          <p:cNvSpPr/>
+          <p:nvPr/>
+        </p:nvSpPr>
+        <p:spPr>
+          <a:xfrm>
             <a:off x="-1371600" y="-1371600"/>
             <a:ext cx="4572000" cy="4572000"/>
           </a:xfrm>

</xml_diff>

<commit_message>
feat: add loop-back retry to ci-pipeline on build/test failure
</commit_message>
<xml_diff>
--- a/AI_Getting_Started_with_AI_Tools.pptx
+++ b/AI_Getting_Started_with_AI_Tools.pptx
@@ -3119,7 +3119,7 @@
                 <a:ea typeface="Calibri" pitchFamily="34" charset="-122"/>
                 <a:cs typeface="Calibri" pitchFamily="34" charset="-120"/>
               </a:rPr>
-              <a:t>Fail: Report</a:t>
+              <a:t>Loop to dev</a:t>
             </a:r>
             <a:endParaRPr lang="en-US" sz="1100" dirty="0"/>
           </a:p>
@@ -3136,7 +3136,7 @@
                 <a:ea typeface="Calibri" pitchFamily="34" charset="-122"/>
                 <a:cs typeface="Calibri" pitchFamily="34" charset="-120"/>
               </a:rPr>
-              <a:t>+ Fix Hint</a:t>
+              <a:t>Retry (max 3)</a:t>
             </a:r>
             <a:endParaRPr lang="en-US" sz="1100" dirty="0"/>
           </a:p>
@@ -3330,8 +3330,8 @@
         </p:nvSpPr>
         <p:spPr>
           <a:xfrm>
-            <a:off x="4206240" y="3383280"/>
-            <a:ext cx="320040" cy="548640"/>
+            <a:off x="4937760" y="3520440"/>
+            <a:ext cx="457200" cy="548640"/>
           </a:xfrm>
           <a:prstGeom prst="rect">
             <a:avLst/>
@@ -3347,20 +3347,59 @@
               <a:buNone/>
             </a:pPr>
             <a:r>
-              <a:rPr lang="en-US" sz="1400" dirty="0">
+              <a:rPr lang="en-US" sz="2800" dirty="0">
                 <a:solidFill>
                   <a:srgbClr val="EF4444"/>
                 </a:solidFill>
               </a:rPr>
-              <a:t>✗</a:t>
-            </a:r>
-            <a:endParaRPr lang="en-US" sz="1400" dirty="0"/>
-          </a:p>
-        </p:txBody>
-      </p:sp>
-      <p:sp>
-        <p:nvSpPr>
-          <p:cNvPr id="27" name="Shape 25"/>
+              <a:t>⟲</a:t>
+            </a:r>
+            <a:endParaRPr lang="en-US" sz="2800" dirty="0"/>
+          </a:p>
+        </p:txBody>
+      </p:sp>
+      <p:sp>
+        <p:nvSpPr>
+          <p:cNvPr id="27" name="Text 25"/>
+          <p:cNvSpPr/>
+          <p:nvPr/>
+        </p:nvSpPr>
+        <p:spPr>
+          <a:xfrm>
+            <a:off x="914400" y="4160520"/>
+            <a:ext cx="2286000" cy="320040"/>
+          </a:xfrm>
+          <a:prstGeom prst="rect">
+            <a:avLst/>
+          </a:prstGeom>
+          <a:noFill/>
+          <a:ln/>
+        </p:spPr>
+        <p:txBody>
+          <a:bodyPr wrap="square" lIns="0" tIns="0" rIns="0" bIns="0" rtlCol="0" anchor="ctr"/>
+          <a:lstStyle/>
+          <a:p>
+            <a:pPr algn="ctr" indent="0" marL="0">
+              <a:buNone/>
+            </a:pPr>
+            <a:r>
+              <a:rPr lang="en-US" sz="900" i="1" dirty="0">
+                <a:solidFill>
+                  <a:srgbClr val="EF4444"/>
+                </a:solidFill>
+                <a:latin typeface="Calibri" pitchFamily="34" charset="0"/>
+                <a:ea typeface="Calibri" pitchFamily="34" charset="-122"/>
+                <a:cs typeface="Calibri" pitchFamily="34" charset="-120"/>
+              </a:rPr>
+              <a:t>back to dev</a:t>
+            </a:r>
+            <a:endParaRPr lang="en-US" sz="900" dirty="0"/>
+          </a:p>
+        </p:txBody>
+      </p:sp>
+      <p:sp>
+        <p:nvSpPr>
+          <p:cNvPr id="28" name="Shape 26"/>
           <p:cNvSpPr/>
           <p:nvPr/>
         </p:nvSpPr>
@@ -3380,7 +3419,7 @@
       </p:sp>
       <p:sp>
         <p:nvSpPr>
-          <p:cNvPr id="28" name="Text 26"/>
+          <p:cNvPr id="29" name="Text 27"/>
           <p:cNvSpPr/>
           <p:nvPr/>
         </p:nvSpPr>
@@ -3456,7 +3495,7 @@
                 <a:ea typeface="Consolas" pitchFamily="34" charset="-122"/>
                 <a:cs typeface="Consolas" pitchFamily="34" charset="-120"/>
               </a:rPr>
-              <a:t>  → dev → build → test</a:t>
+              <a:t>  dev → build → test  (fail → loop back to dev, max 3 retries)</a:t>
             </a:r>
             <a:endParaRPr lang="en-US" sz="1000" dirty="0"/>
           </a:p>
@@ -3464,7 +3503,7 @@
       </p:sp>
       <p:sp>
         <p:nvSpPr>
-          <p:cNvPr id="29" name="Text 27"/>
+          <p:cNvPr id="30" name="Text 28"/>
           <p:cNvSpPr/>
           <p:nvPr/>
         </p:nvSpPr>
@@ -3495,7 +3534,7 @@
                 <a:ea typeface="Calibri" pitchFamily="34" charset="-122"/>
                 <a:cs typeface="Calibri" pitchFamily="34" charset="-120"/>
               </a:rPr>
-              <a:t>Demo: Workflow calls three skills in sequence — dev → build → test — with state passing between each</a:t>
+              <a:t>Demo: On build or test failure, workflow loops back to dev for self-diagnosis, then re-runs build → test</a:t>
             </a:r>
             <a:endParaRPr lang="en-US" sz="1200" dirty="0"/>
           </a:p>

</xml_diff>